<commit_message>
Update PowerPoint with five real software screenshots using synthetic data
</commit_message>
<xml_diff>
--- a/materiales/Jose_David_Gomez_Diametral.pptx
+++ b/materiales/Jose_David_Gomez_Diametral.pptx
@@ -1,8 +1,9 @@
 
 <file path=ppt/presentation.xml><?xml version="1.0" encoding="utf-8"?>
-<p:presentation xmlns:p="http://schemas.openxmlformats.org/presentationml/2006/main">
+<p:presentation xmlns:r="http://schemas.openxmlformats.org/officeDocument/2006/relationships" xmlns:p="http://schemas.openxmlformats.org/presentationml/2006/main">
   <p:sldMasterIdLst>
     <p:sldMasterId xmlns:r="http://schemas.openxmlformats.org/officeDocument/2006/relationships" id="2147483648" r:id="R62417724679e43ae"/>
+    <p:sldMasterId id="2147483649" r:id="rIdAppendixMaster0"/>
   </p:sldMasterIdLst>
   <p:sldIdLst>
     <p:sldId xmlns:r="http://schemas.openxmlformats.org/officeDocument/2006/relationships" id="256" r:id="R0d5a77deffe94144"/>
@@ -18,10 +19,2505 @@
     <p:sldId xmlns:r="http://schemas.openxmlformats.org/officeDocument/2006/relationships" id="266" r:id="R3f2feaf9790e4134"/>
     <p:sldId xmlns:r="http://schemas.openxmlformats.org/officeDocument/2006/relationships" id="267" r:id="R17d8dad792de45e8"/>
     <p:sldId xmlns:r="http://schemas.openxmlformats.org/officeDocument/2006/relationships" id="268" r:id="Rdc53d74c870b4e87"/>
+    <p:sldId id="269" r:id="rIdAppendixSlide14"/>
+    <p:sldId id="270" r:id="rIdAppendixSlide15"/>
+    <p:sldId id="271" r:id="rIdAppendixSlide16"/>
+    <p:sldId id="272" r:id="rIdAppendixSlide17"/>
+    <p:sldId id="273" r:id="rIdAppendixSlide18"/>
   </p:sldIdLst>
   <p:sldSz cx="12192000" cy="6858000"/>
   <p:notesSz cx="6858000" cy="9144000"/>
 </p:presentation>
+</file>
+
+<file path=ppt/appendix/presProps.xml><?xml version="1.0" encoding="utf-8"?>
+<p:presentationPr xmlns:p="http://schemas.openxmlformats.org/presentationml/2006/main">
+  <p:extLst>
+    <p:ext xmlns:p14="http://schemas.microsoft.com/office/powerpoint/2010/main" uri="{E76CE94A-603C-4142-B9EB-6D1370010A27}">
+      <p14:discardImageEditData val="0"/>
+    </p:ext>
+    <p:ext xmlns:p14="http://schemas.microsoft.com/office/powerpoint/2010/main" uri="{D31A062A-798A-4329-ABDD-BBA856620510}">
+      <p14:defaultImageDpi val="32767"/>
+    </p:ext>
+    <p:ext xmlns:p15="http://schemas.microsoft.com/office/powerpoint/2012/main" uri="{FD5EFAAD-0ECE-453E-9831-46B23BE46B34}">
+      <p15:chartTrackingRefBased val="1"/>
+    </p:ext>
+  </p:extLst>
+</p:presentationPr>
+</file>
+
+<file path=ppt/appendix/slideLayouts/slideLayout1.xml><?xml version="1.0" encoding="utf-8"?>
+<p:sldLayout xmlns:p="http://schemas.openxmlformats.org/presentationml/2006/main" type="title">
+  <p:cSld name="Title Slide">
+    <p:spTree>
+      <p:nvGrpSpPr>
+        <p:cNvPr id="1" name=""/>
+        <p:cNvGrpSpPr/>
+        <p:nvPr/>
+      </p:nvGrpSpPr>
+      <p:grpSpPr>
+        <a:xfrm xmlns:a="http://schemas.openxmlformats.org/drawingml/2006/main"/>
+      </p:grpSpPr>
+      <p:sp>
+        <p:nvSpPr>
+          <p:cNvPr id="3" name="Title">
+            <a:extLst xmlns:a="http://schemas.openxmlformats.org/drawingml/2006/main">
+              <a:ext uri="{FF2B5EF4-FFF2-40B4-BE49-F238E27FC236}">
+                <a16:creationId xmlns:a16="http://schemas.microsoft.com/office/drawing/2014/main" id="{A1A97819-3B21-443D-840B-4F6E55592FA0}"/>
+              </a:ext>
+            </a:extLst>
+          </p:cNvPr>
+          <p:cNvSpPr>
+            <a:spLocks xmlns:a="http://schemas.openxmlformats.org/drawingml/2006/main" noGrp="1"/>
+          </p:cNvSpPr>
+          <p:nvPr>
+            <p:ph type="title" idx="0"/>
+          </p:nvPr>
+        </p:nvSpPr>
+        <p:spPr>
+          <a:xfrm xmlns:a="http://schemas.openxmlformats.org/drawingml/2006/main">
+            <a:off x="1219200" y="2590800"/>
+            <a:ext cx="9753600" cy="990600"/>
+          </a:xfrm>
+          <a:prstGeom xmlns:a="http://schemas.openxmlformats.org/drawingml/2006/main" prst="rect">
+            <a:avLst/>
+          </a:prstGeom>
+          <a:noFill xmlns:a="http://schemas.openxmlformats.org/drawingml/2006/main"/>
+          <a:ln xmlns:a="http://schemas.openxmlformats.org/drawingml/2006/main">
+            <a:noFill/>
+            <a:prstDash val="solid"/>
+          </a:ln>
+        </p:spPr>
+        <p:txBody>
+          <a:bodyPr xmlns:a="http://schemas.openxmlformats.org/drawingml/2006/main" wrap="square" lIns="0" tIns="0" rIns="0" bIns="0" anchor="ctr">
+            <a:normAutofit/>
+          </a:bodyPr>
+          <a:lstStyle xmlns:a="http://schemas.openxmlformats.org/drawingml/2006/main">
+            <a:defPPr algn="ctr">
+              <a:defRPr sz="4800" b="1">
+                <a:solidFill>
+                  <a:schemeClr val="tx1"/>
+                </a:solidFill>
+                <a:latin typeface="+mj-lt"/>
+                <a:ea typeface="+mj-lt"/>
+                <a:cs typeface="+mj-lt"/>
+              </a:defRPr>
+            </a:defPPr>
+            <a:lvl1pPr marL="0" indent="0">
+              <a:lnSpc>
+                <a:spcPct val="110000"/>
+              </a:lnSpc>
+              <a:spcBef>
+                <a:spcPts val="0"/>
+              </a:spcBef>
+              <a:spcAft>
+                <a:spcPts val="0"/>
+              </a:spcAft>
+              <a:buNone/>
+            </a:lvl1pPr>
+            <a:lvl2pPr marL="0" indent="0">
+              <a:lnSpc>
+                <a:spcPct val="110000"/>
+              </a:lnSpc>
+              <a:spcBef>
+                <a:spcPts val="0"/>
+              </a:spcBef>
+              <a:spcAft>
+                <a:spcPts val="0"/>
+              </a:spcAft>
+              <a:buNone/>
+            </a:lvl2pPr>
+            <a:lvl3pPr marL="0" indent="0">
+              <a:lnSpc>
+                <a:spcPct val="110000"/>
+              </a:lnSpc>
+              <a:spcBef>
+                <a:spcPts val="0"/>
+              </a:spcBef>
+              <a:spcAft>
+                <a:spcPts val="0"/>
+              </a:spcAft>
+              <a:buNone/>
+            </a:lvl3pPr>
+            <a:lvl4pPr marL="0" indent="0">
+              <a:lnSpc>
+                <a:spcPct val="110000"/>
+              </a:lnSpc>
+              <a:spcBef>
+                <a:spcPts val="0"/>
+              </a:spcBef>
+              <a:spcAft>
+                <a:spcPts val="0"/>
+              </a:spcAft>
+              <a:buNone/>
+            </a:lvl4pPr>
+            <a:lvl5pPr marL="0" indent="0">
+              <a:lnSpc>
+                <a:spcPct val="110000"/>
+              </a:lnSpc>
+              <a:spcBef>
+                <a:spcPts val="0"/>
+              </a:spcBef>
+              <a:spcAft>
+                <a:spcPts val="0"/>
+              </a:spcAft>
+              <a:buNone/>
+            </a:lvl5pPr>
+            <a:lvl6pPr marL="0" indent="0">
+              <a:lnSpc>
+                <a:spcPct val="110000"/>
+              </a:lnSpc>
+              <a:spcBef>
+                <a:spcPts val="0"/>
+              </a:spcBef>
+              <a:spcAft>
+                <a:spcPts val="0"/>
+              </a:spcAft>
+              <a:buNone/>
+            </a:lvl6pPr>
+            <a:lvl7pPr marL="0" indent="0">
+              <a:lnSpc>
+                <a:spcPct val="110000"/>
+              </a:lnSpc>
+              <a:spcBef>
+                <a:spcPts val="0"/>
+              </a:spcBef>
+              <a:spcAft>
+                <a:spcPts val="0"/>
+              </a:spcAft>
+              <a:buNone/>
+            </a:lvl7pPr>
+            <a:lvl8pPr marL="0" indent="0">
+              <a:lnSpc>
+                <a:spcPct val="110000"/>
+              </a:lnSpc>
+              <a:spcBef>
+                <a:spcPts val="0"/>
+              </a:spcBef>
+              <a:spcAft>
+                <a:spcPts val="0"/>
+              </a:spcAft>
+              <a:buNone/>
+            </a:lvl8pPr>
+            <a:lvl9pPr marL="0" indent="0">
+              <a:lnSpc>
+                <a:spcPct val="110000"/>
+              </a:lnSpc>
+              <a:spcBef>
+                <a:spcPts val="0"/>
+              </a:spcBef>
+              <a:spcAft>
+                <a:spcPts val="0"/>
+              </a:spcAft>
+              <a:buNone/>
+            </a:lvl9pPr>
+          </a:lstStyle>
+          <a:p xmlns:a="http://schemas.openxmlformats.org/drawingml/2006/main"/>
+        </p:txBody>
+      </p:sp>
+      <p:sp>
+        <p:nvSpPr>
+          <p:cNvPr id="2" name="Subtitle">
+            <a:extLst xmlns:a="http://schemas.openxmlformats.org/drawingml/2006/main">
+              <a:ext uri="{FF2B5EF4-FFF2-40B4-BE49-F238E27FC236}">
+                <a16:creationId xmlns:a16="http://schemas.microsoft.com/office/drawing/2014/main" id="{6CAC5965-77E6-4C8C-86CC-90DCB29D12FB}"/>
+              </a:ext>
+            </a:extLst>
+          </p:cNvPr>
+          <p:cNvSpPr>
+            <a:spLocks xmlns:a="http://schemas.openxmlformats.org/drawingml/2006/main" noGrp="1"/>
+          </p:cNvSpPr>
+          <p:nvPr>
+            <p:ph type="subTitle" idx="1"/>
+          </p:nvPr>
+        </p:nvSpPr>
+        <p:spPr>
+          <a:xfrm xmlns:a="http://schemas.openxmlformats.org/drawingml/2006/main">
+            <a:off x="1828800" y="3771900"/>
+            <a:ext cx="8534400" cy="762000"/>
+          </a:xfrm>
+          <a:prstGeom xmlns:a="http://schemas.openxmlformats.org/drawingml/2006/main" prst="rect">
+            <a:avLst/>
+          </a:prstGeom>
+          <a:noFill xmlns:a="http://schemas.openxmlformats.org/drawingml/2006/main"/>
+          <a:ln xmlns:a="http://schemas.openxmlformats.org/drawingml/2006/main">
+            <a:noFill/>
+            <a:prstDash val="solid"/>
+          </a:ln>
+        </p:spPr>
+        <p:txBody>
+          <a:bodyPr xmlns:a="http://schemas.openxmlformats.org/drawingml/2006/main" wrap="square" lIns="0" tIns="0" rIns="0" bIns="0" anchor="ctr">
+            <a:normAutofit/>
+          </a:bodyPr>
+          <a:lstStyle xmlns:a="http://schemas.openxmlformats.org/drawingml/2006/main">
+            <a:defPPr algn="ctr">
+              <a:defRPr sz="2100" b="0">
+                <a:solidFill>
+                  <a:schemeClr val="tx1"/>
+                </a:solidFill>
+                <a:latin typeface="+mn-lt"/>
+                <a:ea typeface="+mn-lt"/>
+                <a:cs typeface="+mn-lt"/>
+              </a:defRPr>
+            </a:defPPr>
+            <a:lvl1pPr marL="0" indent="0">
+              <a:lnSpc>
+                <a:spcPct val="110000"/>
+              </a:lnSpc>
+              <a:spcBef>
+                <a:spcPts val="0"/>
+              </a:spcBef>
+              <a:spcAft>
+                <a:spcPts val="0"/>
+              </a:spcAft>
+              <a:buNone/>
+            </a:lvl1pPr>
+            <a:lvl2pPr marL="0" indent="0">
+              <a:lnSpc>
+                <a:spcPct val="110000"/>
+              </a:lnSpc>
+              <a:spcBef>
+                <a:spcPts val="0"/>
+              </a:spcBef>
+              <a:spcAft>
+                <a:spcPts val="0"/>
+              </a:spcAft>
+              <a:buNone/>
+            </a:lvl2pPr>
+            <a:lvl3pPr marL="0" indent="0">
+              <a:lnSpc>
+                <a:spcPct val="110000"/>
+              </a:lnSpc>
+              <a:spcBef>
+                <a:spcPts val="0"/>
+              </a:spcBef>
+              <a:spcAft>
+                <a:spcPts val="0"/>
+              </a:spcAft>
+              <a:buNone/>
+            </a:lvl3pPr>
+            <a:lvl4pPr marL="0" indent="0">
+              <a:lnSpc>
+                <a:spcPct val="110000"/>
+              </a:lnSpc>
+              <a:spcBef>
+                <a:spcPts val="0"/>
+              </a:spcBef>
+              <a:spcAft>
+                <a:spcPts val="0"/>
+              </a:spcAft>
+              <a:buNone/>
+            </a:lvl4pPr>
+            <a:lvl5pPr marL="0" indent="0">
+              <a:lnSpc>
+                <a:spcPct val="110000"/>
+              </a:lnSpc>
+              <a:spcBef>
+                <a:spcPts val="0"/>
+              </a:spcBef>
+              <a:spcAft>
+                <a:spcPts val="0"/>
+              </a:spcAft>
+              <a:buNone/>
+            </a:lvl5pPr>
+            <a:lvl6pPr marL="0" indent="0">
+              <a:lnSpc>
+                <a:spcPct val="110000"/>
+              </a:lnSpc>
+              <a:spcBef>
+                <a:spcPts val="0"/>
+              </a:spcBef>
+              <a:spcAft>
+                <a:spcPts val="0"/>
+              </a:spcAft>
+              <a:buNone/>
+            </a:lvl6pPr>
+            <a:lvl7pPr marL="0" indent="0">
+              <a:lnSpc>
+                <a:spcPct val="110000"/>
+              </a:lnSpc>
+              <a:spcBef>
+                <a:spcPts val="0"/>
+              </a:spcBef>
+              <a:spcAft>
+                <a:spcPts val="0"/>
+              </a:spcAft>
+              <a:buNone/>
+            </a:lvl7pPr>
+            <a:lvl8pPr marL="0" indent="0">
+              <a:lnSpc>
+                <a:spcPct val="110000"/>
+              </a:lnSpc>
+              <a:spcBef>
+                <a:spcPts val="0"/>
+              </a:spcBef>
+              <a:spcAft>
+                <a:spcPts val="0"/>
+              </a:spcAft>
+              <a:buNone/>
+            </a:lvl8pPr>
+            <a:lvl9pPr marL="0" indent="0">
+              <a:lnSpc>
+                <a:spcPct val="110000"/>
+              </a:lnSpc>
+              <a:spcBef>
+                <a:spcPts val="0"/>
+              </a:spcBef>
+              <a:spcAft>
+                <a:spcPts val="0"/>
+              </a:spcAft>
+              <a:buNone/>
+            </a:lvl9pPr>
+          </a:lstStyle>
+          <a:p xmlns:a="http://schemas.openxmlformats.org/drawingml/2006/main"/>
+        </p:txBody>
+      </p:sp>
+    </p:spTree>
+  </p:cSld>
+</p:sldLayout>
+</file>
+
+<file path=ppt/appendix/slideLayouts/slideLayout2.xml><?xml version="1.0" encoding="utf-8"?>
+<p:sldLayout xmlns:p="http://schemas.openxmlformats.org/presentationml/2006/main">
+  <p:cSld name="Section Header">
+    <p:spTree>
+      <p:nvGrpSpPr>
+        <p:cNvPr id="1" name=""/>
+        <p:cNvGrpSpPr/>
+        <p:nvPr/>
+      </p:nvGrpSpPr>
+      <p:grpSpPr>
+        <a:xfrm xmlns:a="http://schemas.openxmlformats.org/drawingml/2006/main"/>
+      </p:grpSpPr>
+      <p:sp>
+        <p:nvSpPr>
+          <p:cNvPr id="2" name="Section title">
+            <a:extLst xmlns:a="http://schemas.openxmlformats.org/drawingml/2006/main">
+              <a:ext uri="{FF2B5EF4-FFF2-40B4-BE49-F238E27FC236}">
+                <a16:creationId xmlns:a16="http://schemas.microsoft.com/office/drawing/2014/main" id="{D9788617-4F1E-4C50-94D6-DD459DDABEE1}"/>
+              </a:ext>
+            </a:extLst>
+          </p:cNvPr>
+          <p:cNvSpPr>
+            <a:spLocks xmlns:a="http://schemas.openxmlformats.org/drawingml/2006/main" noGrp="1"/>
+          </p:cNvSpPr>
+          <p:nvPr>
+            <p:ph type="title" idx="0"/>
+          </p:nvPr>
+        </p:nvSpPr>
+        <p:spPr>
+          <a:xfrm xmlns:a="http://schemas.openxmlformats.org/drawingml/2006/main">
+            <a:off x="1219200" y="2857500"/>
+            <a:ext cx="9753600" cy="1143000"/>
+          </a:xfrm>
+          <a:prstGeom xmlns:a="http://schemas.openxmlformats.org/drawingml/2006/main" prst="rect">
+            <a:avLst/>
+          </a:prstGeom>
+          <a:noFill xmlns:a="http://schemas.openxmlformats.org/drawingml/2006/main"/>
+          <a:ln xmlns:a="http://schemas.openxmlformats.org/drawingml/2006/main">
+            <a:noFill/>
+            <a:prstDash val="solid"/>
+          </a:ln>
+        </p:spPr>
+        <p:txBody>
+          <a:bodyPr xmlns:a="http://schemas.openxmlformats.org/drawingml/2006/main" wrap="square" lIns="0" tIns="0" rIns="0" bIns="0" anchor="ctr">
+            <a:normAutofit/>
+          </a:bodyPr>
+          <a:lstStyle xmlns:a="http://schemas.openxmlformats.org/drawingml/2006/main">
+            <a:defPPr algn="ctr">
+              <a:defRPr sz="4200" b="1">
+                <a:solidFill>
+                  <a:schemeClr val="tx1"/>
+                </a:solidFill>
+                <a:latin typeface="+mj-lt"/>
+                <a:ea typeface="+mj-lt"/>
+                <a:cs typeface="+mj-lt"/>
+              </a:defRPr>
+            </a:defPPr>
+            <a:lvl1pPr marL="0" indent="0">
+              <a:lnSpc>
+                <a:spcPct val="110000"/>
+              </a:lnSpc>
+              <a:spcBef>
+                <a:spcPts val="0"/>
+              </a:spcBef>
+              <a:spcAft>
+                <a:spcPts val="0"/>
+              </a:spcAft>
+              <a:buNone/>
+            </a:lvl1pPr>
+            <a:lvl2pPr marL="0" indent="0">
+              <a:lnSpc>
+                <a:spcPct val="110000"/>
+              </a:lnSpc>
+              <a:spcBef>
+                <a:spcPts val="0"/>
+              </a:spcBef>
+              <a:spcAft>
+                <a:spcPts val="0"/>
+              </a:spcAft>
+              <a:buNone/>
+            </a:lvl2pPr>
+            <a:lvl3pPr marL="0" indent="0">
+              <a:lnSpc>
+                <a:spcPct val="110000"/>
+              </a:lnSpc>
+              <a:spcBef>
+                <a:spcPts val="0"/>
+              </a:spcBef>
+              <a:spcAft>
+                <a:spcPts val="0"/>
+              </a:spcAft>
+              <a:buNone/>
+            </a:lvl3pPr>
+            <a:lvl4pPr marL="0" indent="0">
+              <a:lnSpc>
+                <a:spcPct val="110000"/>
+              </a:lnSpc>
+              <a:spcBef>
+                <a:spcPts val="0"/>
+              </a:spcBef>
+              <a:spcAft>
+                <a:spcPts val="0"/>
+              </a:spcAft>
+              <a:buNone/>
+            </a:lvl4pPr>
+            <a:lvl5pPr marL="0" indent="0">
+              <a:lnSpc>
+                <a:spcPct val="110000"/>
+              </a:lnSpc>
+              <a:spcBef>
+                <a:spcPts val="0"/>
+              </a:spcBef>
+              <a:spcAft>
+                <a:spcPts val="0"/>
+              </a:spcAft>
+              <a:buNone/>
+            </a:lvl5pPr>
+            <a:lvl6pPr marL="0" indent="0">
+              <a:lnSpc>
+                <a:spcPct val="110000"/>
+              </a:lnSpc>
+              <a:spcBef>
+                <a:spcPts val="0"/>
+              </a:spcBef>
+              <a:spcAft>
+                <a:spcPts val="0"/>
+              </a:spcAft>
+              <a:buNone/>
+            </a:lvl6pPr>
+            <a:lvl7pPr marL="0" indent="0">
+              <a:lnSpc>
+                <a:spcPct val="110000"/>
+              </a:lnSpc>
+              <a:spcBef>
+                <a:spcPts val="0"/>
+              </a:spcBef>
+              <a:spcAft>
+                <a:spcPts val="0"/>
+              </a:spcAft>
+              <a:buNone/>
+            </a:lvl7pPr>
+            <a:lvl8pPr marL="0" indent="0">
+              <a:lnSpc>
+                <a:spcPct val="110000"/>
+              </a:lnSpc>
+              <a:spcBef>
+                <a:spcPts val="0"/>
+              </a:spcBef>
+              <a:spcAft>
+                <a:spcPts val="0"/>
+              </a:spcAft>
+              <a:buNone/>
+            </a:lvl8pPr>
+            <a:lvl9pPr marL="0" indent="0">
+              <a:lnSpc>
+                <a:spcPct val="110000"/>
+              </a:lnSpc>
+              <a:spcBef>
+                <a:spcPts val="0"/>
+              </a:spcBef>
+              <a:spcAft>
+                <a:spcPts val="0"/>
+              </a:spcAft>
+              <a:buNone/>
+            </a:lvl9pPr>
+          </a:lstStyle>
+          <a:p xmlns:a="http://schemas.openxmlformats.org/drawingml/2006/main"/>
+        </p:txBody>
+      </p:sp>
+    </p:spTree>
+  </p:cSld>
+</p:sldLayout>
+</file>
+
+<file path=ppt/appendix/slideLayouts/slideLayout3.xml><?xml version="1.0" encoding="utf-8"?>
+<p:sldLayout xmlns:p="http://schemas.openxmlformats.org/presentationml/2006/main">
+  <p:cSld name="Title and Body">
+    <p:spTree>
+      <p:nvGrpSpPr>
+        <p:cNvPr id="1" name=""/>
+        <p:cNvGrpSpPr/>
+        <p:nvPr/>
+      </p:nvGrpSpPr>
+      <p:grpSpPr>
+        <a:xfrm xmlns:a="http://schemas.openxmlformats.org/drawingml/2006/main"/>
+      </p:grpSpPr>
+      <p:sp>
+        <p:nvSpPr>
+          <p:cNvPr id="3" name="Title">
+            <a:extLst xmlns:a="http://schemas.openxmlformats.org/drawingml/2006/main">
+              <a:ext uri="{FF2B5EF4-FFF2-40B4-BE49-F238E27FC236}">
+                <a16:creationId xmlns:a16="http://schemas.microsoft.com/office/drawing/2014/main" id="{0A4D7CFF-49B6-49DD-BCE7-FCF74D5AE4C9}"/>
+              </a:ext>
+            </a:extLst>
+          </p:cNvPr>
+          <p:cNvSpPr>
+            <a:spLocks xmlns:a="http://schemas.openxmlformats.org/drawingml/2006/main" noGrp="1"/>
+          </p:cNvSpPr>
+          <p:nvPr>
+            <p:ph type="title" idx="0"/>
+          </p:nvPr>
+        </p:nvSpPr>
+        <p:spPr>
+          <a:xfrm xmlns:a="http://schemas.openxmlformats.org/drawingml/2006/main">
+            <a:off x="685800" y="533400"/>
+            <a:ext cx="10820400" cy="838200"/>
+          </a:xfrm>
+          <a:prstGeom xmlns:a="http://schemas.openxmlformats.org/drawingml/2006/main" prst="rect">
+            <a:avLst/>
+          </a:prstGeom>
+          <a:noFill xmlns:a="http://schemas.openxmlformats.org/drawingml/2006/main"/>
+          <a:ln xmlns:a="http://schemas.openxmlformats.org/drawingml/2006/main">
+            <a:noFill/>
+            <a:prstDash val="solid"/>
+          </a:ln>
+        </p:spPr>
+        <p:txBody>
+          <a:bodyPr xmlns:a="http://schemas.openxmlformats.org/drawingml/2006/main" wrap="square" lIns="0" tIns="0" rIns="0" bIns="0" anchor="t">
+            <a:normAutofit/>
+          </a:bodyPr>
+          <a:lstStyle xmlns:a="http://schemas.openxmlformats.org/drawingml/2006/main">
+            <a:defPPr algn="l">
+              <a:defRPr sz="3300" b="1">
+                <a:solidFill>
+                  <a:schemeClr val="tx1"/>
+                </a:solidFill>
+                <a:latin typeface="+mj-lt"/>
+                <a:ea typeface="+mj-lt"/>
+                <a:cs typeface="+mj-lt"/>
+              </a:defRPr>
+            </a:defPPr>
+            <a:lvl1pPr marL="0" indent="0">
+              <a:lnSpc>
+                <a:spcPct val="110000"/>
+              </a:lnSpc>
+              <a:spcBef>
+                <a:spcPts val="0"/>
+              </a:spcBef>
+              <a:spcAft>
+                <a:spcPts val="0"/>
+              </a:spcAft>
+              <a:buNone/>
+            </a:lvl1pPr>
+            <a:lvl2pPr marL="0" indent="0">
+              <a:lnSpc>
+                <a:spcPct val="110000"/>
+              </a:lnSpc>
+              <a:spcBef>
+                <a:spcPts val="0"/>
+              </a:spcBef>
+              <a:spcAft>
+                <a:spcPts val="0"/>
+              </a:spcAft>
+              <a:buNone/>
+            </a:lvl2pPr>
+            <a:lvl3pPr marL="0" indent="0">
+              <a:lnSpc>
+                <a:spcPct val="110000"/>
+              </a:lnSpc>
+              <a:spcBef>
+                <a:spcPts val="0"/>
+              </a:spcBef>
+              <a:spcAft>
+                <a:spcPts val="0"/>
+              </a:spcAft>
+              <a:buNone/>
+            </a:lvl3pPr>
+            <a:lvl4pPr marL="0" indent="0">
+              <a:lnSpc>
+                <a:spcPct val="110000"/>
+              </a:lnSpc>
+              <a:spcBef>
+                <a:spcPts val="0"/>
+              </a:spcBef>
+              <a:spcAft>
+                <a:spcPts val="0"/>
+              </a:spcAft>
+              <a:buNone/>
+            </a:lvl4pPr>
+            <a:lvl5pPr marL="0" indent="0">
+              <a:lnSpc>
+                <a:spcPct val="110000"/>
+              </a:lnSpc>
+              <a:spcBef>
+                <a:spcPts val="0"/>
+              </a:spcBef>
+              <a:spcAft>
+                <a:spcPts val="0"/>
+              </a:spcAft>
+              <a:buNone/>
+            </a:lvl5pPr>
+            <a:lvl6pPr marL="0" indent="0">
+              <a:lnSpc>
+                <a:spcPct val="110000"/>
+              </a:lnSpc>
+              <a:spcBef>
+                <a:spcPts val="0"/>
+              </a:spcBef>
+              <a:spcAft>
+                <a:spcPts val="0"/>
+              </a:spcAft>
+              <a:buNone/>
+            </a:lvl6pPr>
+            <a:lvl7pPr marL="0" indent="0">
+              <a:lnSpc>
+                <a:spcPct val="110000"/>
+              </a:lnSpc>
+              <a:spcBef>
+                <a:spcPts val="0"/>
+              </a:spcBef>
+              <a:spcAft>
+                <a:spcPts val="0"/>
+              </a:spcAft>
+              <a:buNone/>
+            </a:lvl7pPr>
+            <a:lvl8pPr marL="0" indent="0">
+              <a:lnSpc>
+                <a:spcPct val="110000"/>
+              </a:lnSpc>
+              <a:spcBef>
+                <a:spcPts val="0"/>
+              </a:spcBef>
+              <a:spcAft>
+                <a:spcPts val="0"/>
+              </a:spcAft>
+              <a:buNone/>
+            </a:lvl8pPr>
+            <a:lvl9pPr marL="0" indent="0">
+              <a:lnSpc>
+                <a:spcPct val="110000"/>
+              </a:lnSpc>
+              <a:spcBef>
+                <a:spcPts val="0"/>
+              </a:spcBef>
+              <a:spcAft>
+                <a:spcPts val="0"/>
+              </a:spcAft>
+              <a:buNone/>
+            </a:lvl9pPr>
+          </a:lstStyle>
+          <a:p xmlns:a="http://schemas.openxmlformats.org/drawingml/2006/main"/>
+        </p:txBody>
+      </p:sp>
+      <p:sp>
+        <p:nvSpPr>
+          <p:cNvPr id="2" name="Body">
+            <a:extLst xmlns:a="http://schemas.openxmlformats.org/drawingml/2006/main">
+              <a:ext uri="{FF2B5EF4-FFF2-40B4-BE49-F238E27FC236}">
+                <a16:creationId xmlns:a16="http://schemas.microsoft.com/office/drawing/2014/main" id="{24931739-6B6C-4444-9BD8-83A0CCFF0CB7}"/>
+              </a:ext>
+            </a:extLst>
+          </p:cNvPr>
+          <p:cNvSpPr>
+            <a:spLocks xmlns:a="http://schemas.openxmlformats.org/drawingml/2006/main" noGrp="1"/>
+          </p:cNvSpPr>
+          <p:nvPr>
+            <p:ph type="body" idx="1"/>
+          </p:nvPr>
+        </p:nvSpPr>
+        <p:spPr>
+          <a:xfrm xmlns:a="http://schemas.openxmlformats.org/drawingml/2006/main">
+            <a:off x="685800" y="1905000"/>
+            <a:ext cx="10820400" cy="4267200"/>
+          </a:xfrm>
+          <a:prstGeom xmlns:a="http://schemas.openxmlformats.org/drawingml/2006/main" prst="rect">
+            <a:avLst/>
+          </a:prstGeom>
+          <a:noFill xmlns:a="http://schemas.openxmlformats.org/drawingml/2006/main"/>
+          <a:ln xmlns:a="http://schemas.openxmlformats.org/drawingml/2006/main">
+            <a:noFill/>
+            <a:prstDash val="solid"/>
+          </a:ln>
+        </p:spPr>
+        <p:txBody>
+          <a:bodyPr xmlns:a="http://schemas.openxmlformats.org/drawingml/2006/main" wrap="square" lIns="0" tIns="0" rIns="0" bIns="0" anchor="t">
+            <a:normAutofit/>
+          </a:bodyPr>
+          <a:lstStyle xmlns:a="http://schemas.openxmlformats.org/drawingml/2006/main">
+            <a:defPPr algn="l">
+              <a:defRPr sz="2250" b="0">
+                <a:solidFill>
+                  <a:schemeClr val="tx1"/>
+                </a:solidFill>
+                <a:latin typeface="+mn-lt"/>
+                <a:ea typeface="+mn-lt"/>
+                <a:cs typeface="+mn-lt"/>
+              </a:defRPr>
+            </a:defPPr>
+            <a:lvl1pPr marL="228600" indent="-228600">
+              <a:lnSpc>
+                <a:spcPct val="110000"/>
+              </a:lnSpc>
+              <a:spcBef>
+                <a:spcPts val="0"/>
+              </a:spcBef>
+              <a:spcAft>
+                <a:spcPts val="1200"/>
+              </a:spcAft>
+              <a:buChar char="•"/>
+            </a:lvl1pPr>
+            <a:lvl2pPr marL="533400" indent="-228600">
+              <a:lnSpc>
+                <a:spcPct val="110000"/>
+              </a:lnSpc>
+              <a:spcBef>
+                <a:spcPts val="0"/>
+              </a:spcBef>
+              <a:spcAft>
+                <a:spcPts val="1200"/>
+              </a:spcAft>
+              <a:buChar char="•"/>
+            </a:lvl2pPr>
+            <a:lvl3pPr marL="838200" indent="-228600">
+              <a:lnSpc>
+                <a:spcPct val="110000"/>
+              </a:lnSpc>
+              <a:spcBef>
+                <a:spcPts val="0"/>
+              </a:spcBef>
+              <a:spcAft>
+                <a:spcPts val="1200"/>
+              </a:spcAft>
+              <a:buChar char="•"/>
+            </a:lvl3pPr>
+            <a:lvl4pPr marL="1143000" indent="-228600">
+              <a:lnSpc>
+                <a:spcPct val="110000"/>
+              </a:lnSpc>
+              <a:spcBef>
+                <a:spcPts val="0"/>
+              </a:spcBef>
+              <a:spcAft>
+                <a:spcPts val="1200"/>
+              </a:spcAft>
+              <a:buChar char="•"/>
+            </a:lvl4pPr>
+            <a:lvl5pPr marL="1447800" indent="-228600">
+              <a:lnSpc>
+                <a:spcPct val="110000"/>
+              </a:lnSpc>
+              <a:spcBef>
+                <a:spcPts val="0"/>
+              </a:spcBef>
+              <a:spcAft>
+                <a:spcPts val="1200"/>
+              </a:spcAft>
+              <a:buChar char="•"/>
+            </a:lvl5pPr>
+            <a:lvl6pPr marL="1752600" indent="-228600">
+              <a:lnSpc>
+                <a:spcPct val="110000"/>
+              </a:lnSpc>
+              <a:spcBef>
+                <a:spcPts val="0"/>
+              </a:spcBef>
+              <a:spcAft>
+                <a:spcPts val="1200"/>
+              </a:spcAft>
+              <a:buChar char="•"/>
+            </a:lvl6pPr>
+            <a:lvl7pPr marL="2057400" indent="-228600">
+              <a:lnSpc>
+                <a:spcPct val="110000"/>
+              </a:lnSpc>
+              <a:spcBef>
+                <a:spcPts val="0"/>
+              </a:spcBef>
+              <a:spcAft>
+                <a:spcPts val="1200"/>
+              </a:spcAft>
+              <a:buChar char="•"/>
+            </a:lvl7pPr>
+            <a:lvl8pPr marL="2362200" indent="-228600">
+              <a:lnSpc>
+                <a:spcPct val="110000"/>
+              </a:lnSpc>
+              <a:spcBef>
+                <a:spcPts val="0"/>
+              </a:spcBef>
+              <a:spcAft>
+                <a:spcPts val="1200"/>
+              </a:spcAft>
+              <a:buChar char="•"/>
+            </a:lvl8pPr>
+            <a:lvl9pPr marL="2667000" indent="-228600">
+              <a:lnSpc>
+                <a:spcPct val="110000"/>
+              </a:lnSpc>
+              <a:spcBef>
+                <a:spcPts val="0"/>
+              </a:spcBef>
+              <a:spcAft>
+                <a:spcPts val="1200"/>
+              </a:spcAft>
+              <a:buChar char="•"/>
+            </a:lvl9pPr>
+          </a:lstStyle>
+          <a:p xmlns:a="http://schemas.openxmlformats.org/drawingml/2006/main"/>
+        </p:txBody>
+      </p:sp>
+    </p:spTree>
+  </p:cSld>
+</p:sldLayout>
+</file>
+
+<file path=ppt/appendix/slideLayouts/slideLayout4.xml><?xml version="1.0" encoding="utf-8"?>
+<p:sldLayout xmlns:p="http://schemas.openxmlformats.org/presentationml/2006/main">
+  <p:cSld name="Title and Two Column">
+    <p:spTree>
+      <p:nvGrpSpPr>
+        <p:cNvPr id="1" name=""/>
+        <p:cNvGrpSpPr/>
+        <p:nvPr/>
+      </p:nvGrpSpPr>
+      <p:grpSpPr>
+        <a:xfrm xmlns:a="http://schemas.openxmlformats.org/drawingml/2006/main"/>
+      </p:grpSpPr>
+      <p:sp>
+        <p:nvSpPr>
+          <p:cNvPr id="4" name="Title">
+            <a:extLst xmlns:a="http://schemas.openxmlformats.org/drawingml/2006/main">
+              <a:ext uri="{FF2B5EF4-FFF2-40B4-BE49-F238E27FC236}">
+                <a16:creationId xmlns:a16="http://schemas.microsoft.com/office/drawing/2014/main" id="{3E0B7E45-1ECF-45E4-AB6C-62272CF0011C}"/>
+              </a:ext>
+            </a:extLst>
+          </p:cNvPr>
+          <p:cNvSpPr>
+            <a:spLocks xmlns:a="http://schemas.openxmlformats.org/drawingml/2006/main" noGrp="1"/>
+          </p:cNvSpPr>
+          <p:nvPr>
+            <p:ph type="title" idx="0"/>
+          </p:nvPr>
+        </p:nvSpPr>
+        <p:spPr>
+          <a:xfrm xmlns:a="http://schemas.openxmlformats.org/drawingml/2006/main">
+            <a:off x="685800" y="533400"/>
+            <a:ext cx="10820400" cy="838200"/>
+          </a:xfrm>
+          <a:prstGeom xmlns:a="http://schemas.openxmlformats.org/drawingml/2006/main" prst="rect">
+            <a:avLst/>
+          </a:prstGeom>
+          <a:noFill xmlns:a="http://schemas.openxmlformats.org/drawingml/2006/main"/>
+          <a:ln xmlns:a="http://schemas.openxmlformats.org/drawingml/2006/main">
+            <a:noFill/>
+            <a:prstDash val="solid"/>
+          </a:ln>
+        </p:spPr>
+        <p:txBody>
+          <a:bodyPr xmlns:a="http://schemas.openxmlformats.org/drawingml/2006/main" wrap="square" lIns="0" tIns="0" rIns="0" bIns="0" anchor="t">
+            <a:normAutofit/>
+          </a:bodyPr>
+          <a:lstStyle xmlns:a="http://schemas.openxmlformats.org/drawingml/2006/main">
+            <a:defPPr algn="l">
+              <a:defRPr sz="3300" b="1">
+                <a:solidFill>
+                  <a:schemeClr val="tx1"/>
+                </a:solidFill>
+                <a:latin typeface="+mj-lt"/>
+                <a:ea typeface="+mj-lt"/>
+                <a:cs typeface="+mj-lt"/>
+              </a:defRPr>
+            </a:defPPr>
+            <a:lvl1pPr marL="0" indent="0">
+              <a:lnSpc>
+                <a:spcPct val="110000"/>
+              </a:lnSpc>
+              <a:spcBef>
+                <a:spcPts val="0"/>
+              </a:spcBef>
+              <a:spcAft>
+                <a:spcPts val="0"/>
+              </a:spcAft>
+              <a:buNone/>
+            </a:lvl1pPr>
+            <a:lvl2pPr marL="0" indent="0">
+              <a:lnSpc>
+                <a:spcPct val="110000"/>
+              </a:lnSpc>
+              <a:spcBef>
+                <a:spcPts val="0"/>
+              </a:spcBef>
+              <a:spcAft>
+                <a:spcPts val="0"/>
+              </a:spcAft>
+              <a:buNone/>
+            </a:lvl2pPr>
+            <a:lvl3pPr marL="0" indent="0">
+              <a:lnSpc>
+                <a:spcPct val="110000"/>
+              </a:lnSpc>
+              <a:spcBef>
+                <a:spcPts val="0"/>
+              </a:spcBef>
+              <a:spcAft>
+                <a:spcPts val="0"/>
+              </a:spcAft>
+              <a:buNone/>
+            </a:lvl3pPr>
+            <a:lvl4pPr marL="0" indent="0">
+              <a:lnSpc>
+                <a:spcPct val="110000"/>
+              </a:lnSpc>
+              <a:spcBef>
+                <a:spcPts val="0"/>
+              </a:spcBef>
+              <a:spcAft>
+                <a:spcPts val="0"/>
+              </a:spcAft>
+              <a:buNone/>
+            </a:lvl4pPr>
+            <a:lvl5pPr marL="0" indent="0">
+              <a:lnSpc>
+                <a:spcPct val="110000"/>
+              </a:lnSpc>
+              <a:spcBef>
+                <a:spcPts val="0"/>
+              </a:spcBef>
+              <a:spcAft>
+                <a:spcPts val="0"/>
+              </a:spcAft>
+              <a:buNone/>
+            </a:lvl5pPr>
+            <a:lvl6pPr marL="0" indent="0">
+              <a:lnSpc>
+                <a:spcPct val="110000"/>
+              </a:lnSpc>
+              <a:spcBef>
+                <a:spcPts val="0"/>
+              </a:spcBef>
+              <a:spcAft>
+                <a:spcPts val="0"/>
+              </a:spcAft>
+              <a:buNone/>
+            </a:lvl6pPr>
+            <a:lvl7pPr marL="0" indent="0">
+              <a:lnSpc>
+                <a:spcPct val="110000"/>
+              </a:lnSpc>
+              <a:spcBef>
+                <a:spcPts val="0"/>
+              </a:spcBef>
+              <a:spcAft>
+                <a:spcPts val="0"/>
+              </a:spcAft>
+              <a:buNone/>
+            </a:lvl7pPr>
+            <a:lvl8pPr marL="0" indent="0">
+              <a:lnSpc>
+                <a:spcPct val="110000"/>
+              </a:lnSpc>
+              <a:spcBef>
+                <a:spcPts val="0"/>
+              </a:spcBef>
+              <a:spcAft>
+                <a:spcPts val="0"/>
+              </a:spcAft>
+              <a:buNone/>
+            </a:lvl8pPr>
+            <a:lvl9pPr marL="0" indent="0">
+              <a:lnSpc>
+                <a:spcPct val="110000"/>
+              </a:lnSpc>
+              <a:spcBef>
+                <a:spcPts val="0"/>
+              </a:spcBef>
+              <a:spcAft>
+                <a:spcPts val="0"/>
+              </a:spcAft>
+              <a:buNone/>
+            </a:lvl9pPr>
+          </a:lstStyle>
+          <a:p xmlns:a="http://schemas.openxmlformats.org/drawingml/2006/main"/>
+        </p:txBody>
+      </p:sp>
+      <p:sp>
+        <p:nvSpPr>
+          <p:cNvPr id="2" name="Left column">
+            <a:extLst xmlns:a="http://schemas.openxmlformats.org/drawingml/2006/main">
+              <a:ext uri="{FF2B5EF4-FFF2-40B4-BE49-F238E27FC236}">
+                <a16:creationId xmlns:a16="http://schemas.microsoft.com/office/drawing/2014/main" id="{63107E63-B881-45AF-9789-DA5A9C2BFAC9}"/>
+              </a:ext>
+            </a:extLst>
+          </p:cNvPr>
+          <p:cNvSpPr>
+            <a:spLocks xmlns:a="http://schemas.openxmlformats.org/drawingml/2006/main" noGrp="1"/>
+          </p:cNvSpPr>
+          <p:nvPr>
+            <p:ph type="body" idx="1"/>
+          </p:nvPr>
+        </p:nvSpPr>
+        <p:spPr>
+          <a:xfrm xmlns:a="http://schemas.openxmlformats.org/drawingml/2006/main">
+            <a:off x="685800" y="1905000"/>
+            <a:ext cx="5029200" cy="4267200"/>
+          </a:xfrm>
+          <a:prstGeom xmlns:a="http://schemas.openxmlformats.org/drawingml/2006/main" prst="rect">
+            <a:avLst/>
+          </a:prstGeom>
+          <a:noFill xmlns:a="http://schemas.openxmlformats.org/drawingml/2006/main"/>
+          <a:ln xmlns:a="http://schemas.openxmlformats.org/drawingml/2006/main">
+            <a:noFill/>
+            <a:prstDash val="solid"/>
+          </a:ln>
+        </p:spPr>
+        <p:txBody>
+          <a:bodyPr xmlns:a="http://schemas.openxmlformats.org/drawingml/2006/main" wrap="square" lIns="0" tIns="0" rIns="0" bIns="0" anchor="t">
+            <a:normAutofit/>
+          </a:bodyPr>
+          <a:lstStyle xmlns:a="http://schemas.openxmlformats.org/drawingml/2006/main">
+            <a:defPPr algn="l">
+              <a:defRPr sz="2100" b="0">
+                <a:solidFill>
+                  <a:schemeClr val="tx1"/>
+                </a:solidFill>
+                <a:latin typeface="+mn-lt"/>
+                <a:ea typeface="+mn-lt"/>
+                <a:cs typeface="+mn-lt"/>
+              </a:defRPr>
+            </a:defPPr>
+            <a:lvl1pPr marL="228600" indent="-228600">
+              <a:lnSpc>
+                <a:spcPct val="110000"/>
+              </a:lnSpc>
+              <a:spcBef>
+                <a:spcPts val="0"/>
+              </a:spcBef>
+              <a:spcAft>
+                <a:spcPts val="1200"/>
+              </a:spcAft>
+              <a:buChar char="•"/>
+            </a:lvl1pPr>
+            <a:lvl2pPr marL="533400" indent="-228600">
+              <a:lnSpc>
+                <a:spcPct val="110000"/>
+              </a:lnSpc>
+              <a:spcBef>
+                <a:spcPts val="0"/>
+              </a:spcBef>
+              <a:spcAft>
+                <a:spcPts val="1200"/>
+              </a:spcAft>
+              <a:buChar char="•"/>
+            </a:lvl2pPr>
+            <a:lvl3pPr marL="838200" indent="-228600">
+              <a:lnSpc>
+                <a:spcPct val="110000"/>
+              </a:lnSpc>
+              <a:spcBef>
+                <a:spcPts val="0"/>
+              </a:spcBef>
+              <a:spcAft>
+                <a:spcPts val="1200"/>
+              </a:spcAft>
+              <a:buChar char="•"/>
+            </a:lvl3pPr>
+            <a:lvl4pPr marL="1143000" indent="-228600">
+              <a:lnSpc>
+                <a:spcPct val="110000"/>
+              </a:lnSpc>
+              <a:spcBef>
+                <a:spcPts val="0"/>
+              </a:spcBef>
+              <a:spcAft>
+                <a:spcPts val="1200"/>
+              </a:spcAft>
+              <a:buChar char="•"/>
+            </a:lvl4pPr>
+            <a:lvl5pPr marL="1447800" indent="-228600">
+              <a:lnSpc>
+                <a:spcPct val="110000"/>
+              </a:lnSpc>
+              <a:spcBef>
+                <a:spcPts val="0"/>
+              </a:spcBef>
+              <a:spcAft>
+                <a:spcPts val="1200"/>
+              </a:spcAft>
+              <a:buChar char="•"/>
+            </a:lvl5pPr>
+            <a:lvl6pPr marL="1752600" indent="-228600">
+              <a:lnSpc>
+                <a:spcPct val="110000"/>
+              </a:lnSpc>
+              <a:spcBef>
+                <a:spcPts val="0"/>
+              </a:spcBef>
+              <a:spcAft>
+                <a:spcPts val="1200"/>
+              </a:spcAft>
+              <a:buChar char="•"/>
+            </a:lvl6pPr>
+            <a:lvl7pPr marL="2057400" indent="-228600">
+              <a:lnSpc>
+                <a:spcPct val="110000"/>
+              </a:lnSpc>
+              <a:spcBef>
+                <a:spcPts val="0"/>
+              </a:spcBef>
+              <a:spcAft>
+                <a:spcPts val="1200"/>
+              </a:spcAft>
+              <a:buChar char="•"/>
+            </a:lvl7pPr>
+            <a:lvl8pPr marL="2362200" indent="-228600">
+              <a:lnSpc>
+                <a:spcPct val="110000"/>
+              </a:lnSpc>
+              <a:spcBef>
+                <a:spcPts val="0"/>
+              </a:spcBef>
+              <a:spcAft>
+                <a:spcPts val="1200"/>
+              </a:spcAft>
+              <a:buChar char="•"/>
+            </a:lvl8pPr>
+            <a:lvl9pPr marL="2667000" indent="-228600">
+              <a:lnSpc>
+                <a:spcPct val="110000"/>
+              </a:lnSpc>
+              <a:spcBef>
+                <a:spcPts val="0"/>
+              </a:spcBef>
+              <a:spcAft>
+                <a:spcPts val="1200"/>
+              </a:spcAft>
+              <a:buChar char="•"/>
+            </a:lvl9pPr>
+          </a:lstStyle>
+          <a:p xmlns:a="http://schemas.openxmlformats.org/drawingml/2006/main"/>
+        </p:txBody>
+      </p:sp>
+      <p:sp>
+        <p:nvSpPr>
+          <p:cNvPr id="3" name="Right column">
+            <a:extLst xmlns:a="http://schemas.openxmlformats.org/drawingml/2006/main">
+              <a:ext uri="{FF2B5EF4-FFF2-40B4-BE49-F238E27FC236}">
+                <a16:creationId xmlns:a16="http://schemas.microsoft.com/office/drawing/2014/main" id="{EEC60147-EBF4-4036-9A77-437D9BB59BB8}"/>
+              </a:ext>
+            </a:extLst>
+          </p:cNvPr>
+          <p:cNvSpPr>
+            <a:spLocks xmlns:a="http://schemas.openxmlformats.org/drawingml/2006/main" noGrp="1"/>
+          </p:cNvSpPr>
+          <p:nvPr>
+            <p:ph type="body" idx="2"/>
+          </p:nvPr>
+        </p:nvSpPr>
+        <p:spPr>
+          <a:xfrm xmlns:a="http://schemas.openxmlformats.org/drawingml/2006/main">
+            <a:off x="6477000" y="1905000"/>
+            <a:ext cx="5029200" cy="4267200"/>
+          </a:xfrm>
+          <a:prstGeom xmlns:a="http://schemas.openxmlformats.org/drawingml/2006/main" prst="rect">
+            <a:avLst/>
+          </a:prstGeom>
+          <a:noFill xmlns:a="http://schemas.openxmlformats.org/drawingml/2006/main"/>
+          <a:ln xmlns:a="http://schemas.openxmlformats.org/drawingml/2006/main">
+            <a:noFill/>
+            <a:prstDash val="solid"/>
+          </a:ln>
+        </p:spPr>
+        <p:txBody>
+          <a:bodyPr xmlns:a="http://schemas.openxmlformats.org/drawingml/2006/main" wrap="square" lIns="0" tIns="0" rIns="0" bIns="0" anchor="t">
+            <a:normAutofit/>
+          </a:bodyPr>
+          <a:lstStyle xmlns:a="http://schemas.openxmlformats.org/drawingml/2006/main">
+            <a:defPPr algn="l">
+              <a:defRPr sz="2100" b="0">
+                <a:solidFill>
+                  <a:schemeClr val="tx1"/>
+                </a:solidFill>
+                <a:latin typeface="+mn-lt"/>
+                <a:ea typeface="+mn-lt"/>
+                <a:cs typeface="+mn-lt"/>
+              </a:defRPr>
+            </a:defPPr>
+            <a:lvl1pPr marL="228600" indent="-228600">
+              <a:lnSpc>
+                <a:spcPct val="110000"/>
+              </a:lnSpc>
+              <a:spcBef>
+                <a:spcPts val="0"/>
+              </a:spcBef>
+              <a:spcAft>
+                <a:spcPts val="1200"/>
+              </a:spcAft>
+              <a:buChar char="•"/>
+            </a:lvl1pPr>
+            <a:lvl2pPr marL="533400" indent="-228600">
+              <a:lnSpc>
+                <a:spcPct val="110000"/>
+              </a:lnSpc>
+              <a:spcBef>
+                <a:spcPts val="0"/>
+              </a:spcBef>
+              <a:spcAft>
+                <a:spcPts val="1200"/>
+              </a:spcAft>
+              <a:buChar char="•"/>
+            </a:lvl2pPr>
+            <a:lvl3pPr marL="838200" indent="-228600">
+              <a:lnSpc>
+                <a:spcPct val="110000"/>
+              </a:lnSpc>
+              <a:spcBef>
+                <a:spcPts val="0"/>
+              </a:spcBef>
+              <a:spcAft>
+                <a:spcPts val="1200"/>
+              </a:spcAft>
+              <a:buChar char="•"/>
+            </a:lvl3pPr>
+            <a:lvl4pPr marL="1143000" indent="-228600">
+              <a:lnSpc>
+                <a:spcPct val="110000"/>
+              </a:lnSpc>
+              <a:spcBef>
+                <a:spcPts val="0"/>
+              </a:spcBef>
+              <a:spcAft>
+                <a:spcPts val="1200"/>
+              </a:spcAft>
+              <a:buChar char="•"/>
+            </a:lvl4pPr>
+            <a:lvl5pPr marL="1447800" indent="-228600">
+              <a:lnSpc>
+                <a:spcPct val="110000"/>
+              </a:lnSpc>
+              <a:spcBef>
+                <a:spcPts val="0"/>
+              </a:spcBef>
+              <a:spcAft>
+                <a:spcPts val="1200"/>
+              </a:spcAft>
+              <a:buChar char="•"/>
+            </a:lvl5pPr>
+            <a:lvl6pPr marL="1752600" indent="-228600">
+              <a:lnSpc>
+                <a:spcPct val="110000"/>
+              </a:lnSpc>
+              <a:spcBef>
+                <a:spcPts val="0"/>
+              </a:spcBef>
+              <a:spcAft>
+                <a:spcPts val="1200"/>
+              </a:spcAft>
+              <a:buChar char="•"/>
+            </a:lvl6pPr>
+            <a:lvl7pPr marL="2057400" indent="-228600">
+              <a:lnSpc>
+                <a:spcPct val="110000"/>
+              </a:lnSpc>
+              <a:spcBef>
+                <a:spcPts val="0"/>
+              </a:spcBef>
+              <a:spcAft>
+                <a:spcPts val="1200"/>
+              </a:spcAft>
+              <a:buChar char="•"/>
+            </a:lvl7pPr>
+            <a:lvl8pPr marL="2362200" indent="-228600">
+              <a:lnSpc>
+                <a:spcPct val="110000"/>
+              </a:lnSpc>
+              <a:spcBef>
+                <a:spcPts val="0"/>
+              </a:spcBef>
+              <a:spcAft>
+                <a:spcPts val="1200"/>
+              </a:spcAft>
+              <a:buChar char="•"/>
+            </a:lvl8pPr>
+            <a:lvl9pPr marL="2667000" indent="-228600">
+              <a:lnSpc>
+                <a:spcPct val="110000"/>
+              </a:lnSpc>
+              <a:spcBef>
+                <a:spcPts val="0"/>
+              </a:spcBef>
+              <a:spcAft>
+                <a:spcPts val="1200"/>
+              </a:spcAft>
+              <a:buChar char="•"/>
+            </a:lvl9pPr>
+          </a:lstStyle>
+          <a:p xmlns:a="http://schemas.openxmlformats.org/drawingml/2006/main"/>
+        </p:txBody>
+      </p:sp>
+    </p:spTree>
+  </p:cSld>
+</p:sldLayout>
+</file>
+
+<file path=ppt/appendix/slideLayouts/slideLayout5.xml><?xml version="1.0" encoding="utf-8"?>
+<p:sldLayout xmlns:p="http://schemas.openxmlformats.org/presentationml/2006/main">
+  <p:cSld name="Title and One Column">
+    <p:spTree>
+      <p:nvGrpSpPr>
+        <p:cNvPr id="1" name=""/>
+        <p:cNvGrpSpPr/>
+        <p:nvPr/>
+      </p:nvGrpSpPr>
+      <p:grpSpPr>
+        <a:xfrm xmlns:a="http://schemas.openxmlformats.org/drawingml/2006/main"/>
+      </p:grpSpPr>
+      <p:sp>
+        <p:nvSpPr>
+          <p:cNvPr id="3" name="Title">
+            <a:extLst xmlns:a="http://schemas.openxmlformats.org/drawingml/2006/main">
+              <a:ext uri="{FF2B5EF4-FFF2-40B4-BE49-F238E27FC236}">
+                <a16:creationId xmlns:a16="http://schemas.microsoft.com/office/drawing/2014/main" id="{7EF23B5B-47D2-44EA-B9F9-B51947100536}"/>
+              </a:ext>
+            </a:extLst>
+          </p:cNvPr>
+          <p:cNvSpPr>
+            <a:spLocks xmlns:a="http://schemas.openxmlformats.org/drawingml/2006/main" noGrp="1"/>
+          </p:cNvSpPr>
+          <p:nvPr>
+            <p:ph type="title" idx="0"/>
+          </p:nvPr>
+        </p:nvSpPr>
+        <p:spPr>
+          <a:xfrm xmlns:a="http://schemas.openxmlformats.org/drawingml/2006/main">
+            <a:off x="685800" y="533400"/>
+            <a:ext cx="10820400" cy="838200"/>
+          </a:xfrm>
+          <a:prstGeom xmlns:a="http://schemas.openxmlformats.org/drawingml/2006/main" prst="rect">
+            <a:avLst/>
+          </a:prstGeom>
+          <a:noFill xmlns:a="http://schemas.openxmlformats.org/drawingml/2006/main"/>
+          <a:ln xmlns:a="http://schemas.openxmlformats.org/drawingml/2006/main">
+            <a:noFill/>
+            <a:prstDash val="solid"/>
+          </a:ln>
+        </p:spPr>
+        <p:txBody>
+          <a:bodyPr xmlns:a="http://schemas.openxmlformats.org/drawingml/2006/main" wrap="square" lIns="0" tIns="0" rIns="0" bIns="0" anchor="t">
+            <a:normAutofit/>
+          </a:bodyPr>
+          <a:lstStyle xmlns:a="http://schemas.openxmlformats.org/drawingml/2006/main">
+            <a:defPPr algn="l">
+              <a:defRPr sz="3300" b="1">
+                <a:solidFill>
+                  <a:schemeClr val="tx1"/>
+                </a:solidFill>
+                <a:latin typeface="+mj-lt"/>
+                <a:ea typeface="+mj-lt"/>
+                <a:cs typeface="+mj-lt"/>
+              </a:defRPr>
+            </a:defPPr>
+            <a:lvl1pPr marL="0" indent="0">
+              <a:lnSpc>
+                <a:spcPct val="110000"/>
+              </a:lnSpc>
+              <a:spcBef>
+                <a:spcPts val="0"/>
+              </a:spcBef>
+              <a:spcAft>
+                <a:spcPts val="0"/>
+              </a:spcAft>
+              <a:buNone/>
+            </a:lvl1pPr>
+            <a:lvl2pPr marL="0" indent="0">
+              <a:lnSpc>
+                <a:spcPct val="110000"/>
+              </a:lnSpc>
+              <a:spcBef>
+                <a:spcPts val="0"/>
+              </a:spcBef>
+              <a:spcAft>
+                <a:spcPts val="0"/>
+              </a:spcAft>
+              <a:buNone/>
+            </a:lvl2pPr>
+            <a:lvl3pPr marL="0" indent="0">
+              <a:lnSpc>
+                <a:spcPct val="110000"/>
+              </a:lnSpc>
+              <a:spcBef>
+                <a:spcPts val="0"/>
+              </a:spcBef>
+              <a:spcAft>
+                <a:spcPts val="0"/>
+              </a:spcAft>
+              <a:buNone/>
+            </a:lvl3pPr>
+            <a:lvl4pPr marL="0" indent="0">
+              <a:lnSpc>
+                <a:spcPct val="110000"/>
+              </a:lnSpc>
+              <a:spcBef>
+                <a:spcPts val="0"/>
+              </a:spcBef>
+              <a:spcAft>
+                <a:spcPts val="0"/>
+              </a:spcAft>
+              <a:buNone/>
+            </a:lvl4pPr>
+            <a:lvl5pPr marL="0" indent="0">
+              <a:lnSpc>
+                <a:spcPct val="110000"/>
+              </a:lnSpc>
+              <a:spcBef>
+                <a:spcPts val="0"/>
+              </a:spcBef>
+              <a:spcAft>
+                <a:spcPts val="0"/>
+              </a:spcAft>
+              <a:buNone/>
+            </a:lvl5pPr>
+            <a:lvl6pPr marL="0" indent="0">
+              <a:lnSpc>
+                <a:spcPct val="110000"/>
+              </a:lnSpc>
+              <a:spcBef>
+                <a:spcPts val="0"/>
+              </a:spcBef>
+              <a:spcAft>
+                <a:spcPts val="0"/>
+              </a:spcAft>
+              <a:buNone/>
+            </a:lvl6pPr>
+            <a:lvl7pPr marL="0" indent="0">
+              <a:lnSpc>
+                <a:spcPct val="110000"/>
+              </a:lnSpc>
+              <a:spcBef>
+                <a:spcPts val="0"/>
+              </a:spcBef>
+              <a:spcAft>
+                <a:spcPts val="0"/>
+              </a:spcAft>
+              <a:buNone/>
+            </a:lvl7pPr>
+            <a:lvl8pPr marL="0" indent="0">
+              <a:lnSpc>
+                <a:spcPct val="110000"/>
+              </a:lnSpc>
+              <a:spcBef>
+                <a:spcPts val="0"/>
+              </a:spcBef>
+              <a:spcAft>
+                <a:spcPts val="0"/>
+              </a:spcAft>
+              <a:buNone/>
+            </a:lvl8pPr>
+            <a:lvl9pPr marL="0" indent="0">
+              <a:lnSpc>
+                <a:spcPct val="110000"/>
+              </a:lnSpc>
+              <a:spcBef>
+                <a:spcPts val="0"/>
+              </a:spcBef>
+              <a:spcAft>
+                <a:spcPts val="0"/>
+              </a:spcAft>
+              <a:buNone/>
+            </a:lvl9pPr>
+          </a:lstStyle>
+          <a:p xmlns:a="http://schemas.openxmlformats.org/drawingml/2006/main"/>
+        </p:txBody>
+      </p:sp>
+      <p:sp>
+        <p:nvSpPr>
+          <p:cNvPr id="2" name="Left column">
+            <a:extLst xmlns:a="http://schemas.openxmlformats.org/drawingml/2006/main">
+              <a:ext uri="{FF2B5EF4-FFF2-40B4-BE49-F238E27FC236}">
+                <a16:creationId xmlns:a16="http://schemas.microsoft.com/office/drawing/2014/main" id="{83DD814F-50B1-4EEB-8CF1-65D897136C0B}"/>
+              </a:ext>
+            </a:extLst>
+          </p:cNvPr>
+          <p:cNvSpPr>
+            <a:spLocks xmlns:a="http://schemas.openxmlformats.org/drawingml/2006/main" noGrp="1"/>
+          </p:cNvSpPr>
+          <p:nvPr>
+            <p:ph type="body" idx="1"/>
+          </p:nvPr>
+        </p:nvSpPr>
+        <p:spPr>
+          <a:xfrm xmlns:a="http://schemas.openxmlformats.org/drawingml/2006/main">
+            <a:off x="685800" y="1905000"/>
+            <a:ext cx="5029200" cy="4267200"/>
+          </a:xfrm>
+          <a:prstGeom xmlns:a="http://schemas.openxmlformats.org/drawingml/2006/main" prst="rect">
+            <a:avLst/>
+          </a:prstGeom>
+          <a:noFill xmlns:a="http://schemas.openxmlformats.org/drawingml/2006/main"/>
+          <a:ln xmlns:a="http://schemas.openxmlformats.org/drawingml/2006/main">
+            <a:noFill/>
+            <a:prstDash val="solid"/>
+          </a:ln>
+        </p:spPr>
+        <p:txBody>
+          <a:bodyPr xmlns:a="http://schemas.openxmlformats.org/drawingml/2006/main" wrap="square" lIns="0" tIns="0" rIns="0" bIns="0" anchor="t">
+            <a:normAutofit/>
+          </a:bodyPr>
+          <a:lstStyle xmlns:a="http://schemas.openxmlformats.org/drawingml/2006/main">
+            <a:defPPr algn="l">
+              <a:defRPr sz="2250" b="0">
+                <a:solidFill>
+                  <a:schemeClr val="tx1"/>
+                </a:solidFill>
+                <a:latin typeface="+mn-lt"/>
+                <a:ea typeface="+mn-lt"/>
+                <a:cs typeface="+mn-lt"/>
+              </a:defRPr>
+            </a:defPPr>
+            <a:lvl1pPr marL="228600" indent="-228600">
+              <a:lnSpc>
+                <a:spcPct val="110000"/>
+              </a:lnSpc>
+              <a:spcBef>
+                <a:spcPts val="0"/>
+              </a:spcBef>
+              <a:spcAft>
+                <a:spcPts val="1200"/>
+              </a:spcAft>
+              <a:buChar char="•"/>
+            </a:lvl1pPr>
+            <a:lvl2pPr marL="533400" indent="-228600">
+              <a:lnSpc>
+                <a:spcPct val="110000"/>
+              </a:lnSpc>
+              <a:spcBef>
+                <a:spcPts val="0"/>
+              </a:spcBef>
+              <a:spcAft>
+                <a:spcPts val="1200"/>
+              </a:spcAft>
+              <a:buChar char="•"/>
+            </a:lvl2pPr>
+            <a:lvl3pPr marL="838200" indent="-228600">
+              <a:lnSpc>
+                <a:spcPct val="110000"/>
+              </a:lnSpc>
+              <a:spcBef>
+                <a:spcPts val="0"/>
+              </a:spcBef>
+              <a:spcAft>
+                <a:spcPts val="1200"/>
+              </a:spcAft>
+              <a:buChar char="•"/>
+            </a:lvl3pPr>
+            <a:lvl4pPr marL="1143000" indent="-228600">
+              <a:lnSpc>
+                <a:spcPct val="110000"/>
+              </a:lnSpc>
+              <a:spcBef>
+                <a:spcPts val="0"/>
+              </a:spcBef>
+              <a:spcAft>
+                <a:spcPts val="1200"/>
+              </a:spcAft>
+              <a:buChar char="•"/>
+            </a:lvl4pPr>
+            <a:lvl5pPr marL="1447800" indent="-228600">
+              <a:lnSpc>
+                <a:spcPct val="110000"/>
+              </a:lnSpc>
+              <a:spcBef>
+                <a:spcPts val="0"/>
+              </a:spcBef>
+              <a:spcAft>
+                <a:spcPts val="1200"/>
+              </a:spcAft>
+              <a:buChar char="•"/>
+            </a:lvl5pPr>
+            <a:lvl6pPr marL="1752600" indent="-228600">
+              <a:lnSpc>
+                <a:spcPct val="110000"/>
+              </a:lnSpc>
+              <a:spcBef>
+                <a:spcPts val="0"/>
+              </a:spcBef>
+              <a:spcAft>
+                <a:spcPts val="1200"/>
+              </a:spcAft>
+              <a:buChar char="•"/>
+            </a:lvl6pPr>
+            <a:lvl7pPr marL="2057400" indent="-228600">
+              <a:lnSpc>
+                <a:spcPct val="110000"/>
+              </a:lnSpc>
+              <a:spcBef>
+                <a:spcPts val="0"/>
+              </a:spcBef>
+              <a:spcAft>
+                <a:spcPts val="1200"/>
+              </a:spcAft>
+              <a:buChar char="•"/>
+            </a:lvl7pPr>
+            <a:lvl8pPr marL="2362200" indent="-228600">
+              <a:lnSpc>
+                <a:spcPct val="110000"/>
+              </a:lnSpc>
+              <a:spcBef>
+                <a:spcPts val="0"/>
+              </a:spcBef>
+              <a:spcAft>
+                <a:spcPts val="1200"/>
+              </a:spcAft>
+              <a:buChar char="•"/>
+            </a:lvl8pPr>
+            <a:lvl9pPr marL="2667000" indent="-228600">
+              <a:lnSpc>
+                <a:spcPct val="110000"/>
+              </a:lnSpc>
+              <a:spcBef>
+                <a:spcPts val="0"/>
+              </a:spcBef>
+              <a:spcAft>
+                <a:spcPts val="1200"/>
+              </a:spcAft>
+              <a:buChar char="•"/>
+            </a:lvl9pPr>
+          </a:lstStyle>
+          <a:p xmlns:a="http://schemas.openxmlformats.org/drawingml/2006/main"/>
+        </p:txBody>
+      </p:sp>
+    </p:spTree>
+  </p:cSld>
+</p:sldLayout>
+</file>
+
+<file path=ppt/appendix/slideLayouts/slideLayout6.xml><?xml version="1.0" encoding="utf-8"?>
+<p:sldLayout xmlns:p="http://schemas.openxmlformats.org/presentationml/2006/main" type="blank">
+  <p:cSld name="Blank">
+    <p:spTree>
+      <p:nvGrpSpPr>
+        <p:cNvPr id="1" name=""/>
+        <p:cNvGrpSpPr/>
+        <p:nvPr/>
+      </p:nvGrpSpPr>
+      <p:grpSpPr>
+        <a:xfrm xmlns:a="http://schemas.openxmlformats.org/drawingml/2006/main"/>
+      </p:grpSpPr>
+    </p:spTree>
+  </p:cSld>
+</p:sldLayout>
+</file>
+
+<file path=ppt/appendix/slideMasters/slideMaster1.xml><?xml version="1.0" encoding="utf-8"?>
+<p:sldMaster xmlns:p="http://schemas.openxmlformats.org/presentationml/2006/main">
+  <p:cSld name="Master">
+    <p:bg>
+      <p:bgRef idx="1001">
+        <a:schemeClr xmlns:a="http://schemas.openxmlformats.org/drawingml/2006/main" val="bg1"/>
+      </p:bgRef>
+    </p:bg>
+    <p:spTree>
+      <p:nvGrpSpPr>
+        <p:cNvPr id="1" name=""/>
+        <p:cNvGrpSpPr/>
+        <p:nvPr/>
+      </p:nvGrpSpPr>
+      <p:grpSpPr>
+        <a:xfrm xmlns:a="http://schemas.openxmlformats.org/drawingml/2006/main"/>
+      </p:grpSpPr>
+    </p:spTree>
+  </p:cSld>
+  <p:clrMap bg1="lt1" tx1="dk1" bg2="lt2" tx2="dk2" accent1="accent1" accent2="accent2" accent3="accent3" accent4="accent4" accent5="accent5" accent6="accent6" hlink="hlink" folHlink="folHlink"/>
+  <p:sldLayoutIdLst>
+    <p:sldLayoutId xmlns:r="http://schemas.openxmlformats.org/officeDocument/2006/relationships" id="2147483649" r:id="R328640d498f64b65"/>
+    <p:sldLayoutId xmlns:r="http://schemas.openxmlformats.org/officeDocument/2006/relationships" id="2147483650" r:id="R9e52dc110a4e486c"/>
+    <p:sldLayoutId xmlns:r="http://schemas.openxmlformats.org/officeDocument/2006/relationships" id="2147483651" r:id="R45d09f31c5594c48"/>
+    <p:sldLayoutId xmlns:r="http://schemas.openxmlformats.org/officeDocument/2006/relationships" id="2147483652" r:id="R738bc5f6e4d14c36"/>
+    <p:sldLayoutId xmlns:r="http://schemas.openxmlformats.org/officeDocument/2006/relationships" id="2147483653" r:id="Rcd8b2d5db0e144f0"/>
+    <p:sldLayoutId xmlns:r="http://schemas.openxmlformats.org/officeDocument/2006/relationships" id="2147483654" r:id="R65af107abf9b43a6"/>
+  </p:sldLayoutIdLst>
+  <p:txStyles>
+    <p:titleStyle>
+      <a:lvl1pPr xmlns:a="http://schemas.openxmlformats.org/drawingml/2006/main" algn="l">
+        <a:lnSpc>
+          <a:spcPct val="90000"/>
+        </a:lnSpc>
+        <a:spcBef>
+          <a:spcPts val="0"/>
+        </a:spcBef>
+        <a:buNone/>
+        <a:defRPr sz="4400">
+          <a:solidFill>
+            <a:schemeClr val="tx1"/>
+          </a:solidFill>
+          <a:latin typeface="+mj-lt"/>
+          <a:ea typeface="+mj-lt"/>
+          <a:cs typeface="+mj-lt"/>
+        </a:defRPr>
+      </a:lvl1pPr>
+    </p:titleStyle>
+    <p:bodyStyle>
+      <a:lvl1pPr xmlns:a="http://schemas.openxmlformats.org/drawingml/2006/main" marL="228600" indent="-228600" algn="l">
+        <a:lnSpc>
+          <a:spcPct val="90000"/>
+        </a:lnSpc>
+        <a:spcBef>
+          <a:spcPts val="1000"/>
+        </a:spcBef>
+        <a:buChar char="•"/>
+        <a:defRPr sz="2800">
+          <a:solidFill>
+            <a:schemeClr val="tx1"/>
+          </a:solidFill>
+          <a:latin typeface="+mn-lt"/>
+          <a:ea typeface="+mn-lt"/>
+          <a:cs typeface="+mn-lt"/>
+        </a:defRPr>
+      </a:lvl1pPr>
+      <a:lvl2pPr xmlns:a="http://schemas.openxmlformats.org/drawingml/2006/main" marL="685800" indent="-228600" algn="l">
+        <a:lnSpc>
+          <a:spcPct val="90000"/>
+        </a:lnSpc>
+        <a:spcBef>
+          <a:spcPts val="500"/>
+        </a:spcBef>
+        <a:buChar char="•"/>
+        <a:defRPr sz="2400">
+          <a:solidFill>
+            <a:schemeClr val="tx1"/>
+          </a:solidFill>
+          <a:latin typeface="+mn-lt"/>
+          <a:ea typeface="+mn-lt"/>
+          <a:cs typeface="+mn-lt"/>
+        </a:defRPr>
+      </a:lvl2pPr>
+      <a:lvl3pPr xmlns:a="http://schemas.openxmlformats.org/drawingml/2006/main" marL="1143000" indent="-228600" algn="l">
+        <a:lnSpc>
+          <a:spcPct val="90000"/>
+        </a:lnSpc>
+        <a:spcBef>
+          <a:spcPts val="500"/>
+        </a:spcBef>
+        <a:buChar char="•"/>
+        <a:defRPr sz="2000">
+          <a:solidFill>
+            <a:schemeClr val="tx1"/>
+          </a:solidFill>
+          <a:latin typeface="+mn-lt"/>
+          <a:ea typeface="+mn-lt"/>
+          <a:cs typeface="+mn-lt"/>
+        </a:defRPr>
+      </a:lvl3pPr>
+      <a:lvl4pPr xmlns:a="http://schemas.openxmlformats.org/drawingml/2006/main" marL="1600200" indent="-228600" algn="l">
+        <a:lnSpc>
+          <a:spcPct val="90000"/>
+        </a:lnSpc>
+        <a:spcBef>
+          <a:spcPts val="500"/>
+        </a:spcBef>
+        <a:buChar char="•"/>
+        <a:defRPr sz="1800">
+          <a:solidFill>
+            <a:schemeClr val="tx1"/>
+          </a:solidFill>
+          <a:latin typeface="+mn-lt"/>
+          <a:ea typeface="+mn-lt"/>
+          <a:cs typeface="+mn-lt"/>
+        </a:defRPr>
+      </a:lvl4pPr>
+      <a:lvl5pPr xmlns:a="http://schemas.openxmlformats.org/drawingml/2006/main" marL="2057400" indent="-228600" algn="l">
+        <a:lnSpc>
+          <a:spcPct val="90000"/>
+        </a:lnSpc>
+        <a:spcBef>
+          <a:spcPts val="500"/>
+        </a:spcBef>
+        <a:buChar char="•"/>
+        <a:defRPr sz="1800">
+          <a:solidFill>
+            <a:schemeClr val="tx1"/>
+          </a:solidFill>
+          <a:latin typeface="+mn-lt"/>
+          <a:ea typeface="+mn-lt"/>
+          <a:cs typeface="+mn-lt"/>
+        </a:defRPr>
+      </a:lvl5pPr>
+      <a:lvl6pPr xmlns:a="http://schemas.openxmlformats.org/drawingml/2006/main" marL="2514600" indent="-228600" algn="l">
+        <a:lnSpc>
+          <a:spcPct val="90000"/>
+        </a:lnSpc>
+        <a:spcBef>
+          <a:spcPts val="500"/>
+        </a:spcBef>
+        <a:buChar char="•"/>
+        <a:defRPr sz="1800">
+          <a:solidFill>
+            <a:schemeClr val="tx1"/>
+          </a:solidFill>
+          <a:latin typeface="+mn-lt"/>
+          <a:ea typeface="+mn-lt"/>
+          <a:cs typeface="+mn-lt"/>
+        </a:defRPr>
+      </a:lvl6pPr>
+      <a:lvl7pPr xmlns:a="http://schemas.openxmlformats.org/drawingml/2006/main" marL="2971800" indent="-228600" algn="l">
+        <a:lnSpc>
+          <a:spcPct val="90000"/>
+        </a:lnSpc>
+        <a:spcBef>
+          <a:spcPts val="500"/>
+        </a:spcBef>
+        <a:buChar char="•"/>
+        <a:defRPr sz="1800">
+          <a:solidFill>
+            <a:schemeClr val="tx1"/>
+          </a:solidFill>
+          <a:latin typeface="+mn-lt"/>
+          <a:ea typeface="+mn-lt"/>
+          <a:cs typeface="+mn-lt"/>
+        </a:defRPr>
+      </a:lvl7pPr>
+      <a:lvl8pPr xmlns:a="http://schemas.openxmlformats.org/drawingml/2006/main" marL="3429000" indent="-228600" algn="l">
+        <a:lnSpc>
+          <a:spcPct val="90000"/>
+        </a:lnSpc>
+        <a:spcBef>
+          <a:spcPts val="500"/>
+        </a:spcBef>
+        <a:buChar char="•"/>
+        <a:defRPr sz="1800">
+          <a:solidFill>
+            <a:schemeClr val="tx1"/>
+          </a:solidFill>
+          <a:latin typeface="+mn-lt"/>
+          <a:ea typeface="+mn-lt"/>
+          <a:cs typeface="+mn-lt"/>
+        </a:defRPr>
+      </a:lvl8pPr>
+      <a:lvl9pPr xmlns:a="http://schemas.openxmlformats.org/drawingml/2006/main" marL="3886200" indent="-228600" algn="l">
+        <a:lnSpc>
+          <a:spcPct val="90000"/>
+        </a:lnSpc>
+        <a:spcBef>
+          <a:spcPts val="500"/>
+        </a:spcBef>
+        <a:buChar char="•"/>
+        <a:defRPr sz="1800">
+          <a:solidFill>
+            <a:schemeClr val="tx1"/>
+          </a:solidFill>
+          <a:latin typeface="+mn-lt"/>
+          <a:ea typeface="+mn-lt"/>
+          <a:cs typeface="+mn-lt"/>
+        </a:defRPr>
+      </a:lvl9pPr>
+    </p:bodyStyle>
+    <p:otherStyle>
+      <a:lvl1pPr xmlns:a="http://schemas.openxmlformats.org/drawingml/2006/main" marL="0" algn="l">
+        <a:buNone/>
+        <a:defRPr sz="1800">
+          <a:solidFill>
+            <a:schemeClr val="tx1"/>
+          </a:solidFill>
+          <a:latin typeface="+mn-lt"/>
+          <a:ea typeface="+mn-lt"/>
+          <a:cs typeface="+mn-lt"/>
+        </a:defRPr>
+      </a:lvl1pPr>
+      <a:lvl2pPr xmlns:a="http://schemas.openxmlformats.org/drawingml/2006/main" marL="457200" algn="l">
+        <a:buNone/>
+        <a:defRPr sz="1800">
+          <a:solidFill>
+            <a:schemeClr val="tx1"/>
+          </a:solidFill>
+          <a:latin typeface="+mn-lt"/>
+          <a:ea typeface="+mn-lt"/>
+          <a:cs typeface="+mn-lt"/>
+        </a:defRPr>
+      </a:lvl2pPr>
+      <a:lvl3pPr xmlns:a="http://schemas.openxmlformats.org/drawingml/2006/main" marL="914400" algn="l">
+        <a:buNone/>
+        <a:defRPr sz="1800">
+          <a:solidFill>
+            <a:schemeClr val="tx1"/>
+          </a:solidFill>
+          <a:latin typeface="+mn-lt"/>
+          <a:ea typeface="+mn-lt"/>
+          <a:cs typeface="+mn-lt"/>
+        </a:defRPr>
+      </a:lvl3pPr>
+      <a:lvl4pPr xmlns:a="http://schemas.openxmlformats.org/drawingml/2006/main" marL="1371600" algn="l">
+        <a:buNone/>
+        <a:defRPr sz="1800">
+          <a:solidFill>
+            <a:schemeClr val="tx1"/>
+          </a:solidFill>
+          <a:latin typeface="+mn-lt"/>
+          <a:ea typeface="+mn-lt"/>
+          <a:cs typeface="+mn-lt"/>
+        </a:defRPr>
+      </a:lvl4pPr>
+      <a:lvl5pPr xmlns:a="http://schemas.openxmlformats.org/drawingml/2006/main" marL="1828800" algn="l">
+        <a:buNone/>
+        <a:defRPr sz="1800">
+          <a:solidFill>
+            <a:schemeClr val="tx1"/>
+          </a:solidFill>
+          <a:latin typeface="+mn-lt"/>
+          <a:ea typeface="+mn-lt"/>
+          <a:cs typeface="+mn-lt"/>
+        </a:defRPr>
+      </a:lvl5pPr>
+      <a:lvl6pPr xmlns:a="http://schemas.openxmlformats.org/drawingml/2006/main" marL="2286000" algn="l">
+        <a:buNone/>
+        <a:defRPr sz="1800">
+          <a:solidFill>
+            <a:schemeClr val="tx1"/>
+          </a:solidFill>
+          <a:latin typeface="+mn-lt"/>
+          <a:ea typeface="+mn-lt"/>
+          <a:cs typeface="+mn-lt"/>
+        </a:defRPr>
+      </a:lvl6pPr>
+      <a:lvl7pPr xmlns:a="http://schemas.openxmlformats.org/drawingml/2006/main" marL="2743200" algn="l">
+        <a:buNone/>
+        <a:defRPr sz="1800">
+          <a:solidFill>
+            <a:schemeClr val="tx1"/>
+          </a:solidFill>
+          <a:latin typeface="+mn-lt"/>
+          <a:ea typeface="+mn-lt"/>
+          <a:cs typeface="+mn-lt"/>
+        </a:defRPr>
+      </a:lvl7pPr>
+      <a:lvl8pPr xmlns:a="http://schemas.openxmlformats.org/drawingml/2006/main" marL="3200400" algn="l">
+        <a:buNone/>
+        <a:defRPr sz="1800">
+          <a:solidFill>
+            <a:schemeClr val="tx1"/>
+          </a:solidFill>
+          <a:latin typeface="+mn-lt"/>
+          <a:ea typeface="+mn-lt"/>
+          <a:cs typeface="+mn-lt"/>
+        </a:defRPr>
+      </a:lvl8pPr>
+      <a:lvl9pPr xmlns:a="http://schemas.openxmlformats.org/drawingml/2006/main" marL="3657600" algn="l">
+        <a:buNone/>
+        <a:defRPr sz="1800">
+          <a:solidFill>
+            <a:schemeClr val="tx1"/>
+          </a:solidFill>
+          <a:latin typeface="+mn-lt"/>
+          <a:ea typeface="+mn-lt"/>
+          <a:cs typeface="+mn-lt"/>
+        </a:defRPr>
+      </a:lvl9pPr>
+    </p:otherStyle>
+  </p:txStyles>
+</p:sldMaster>
+</file>
+
+<file path=ppt/appendix/slideMasters/theme/theme2.xml><?xml version="1.0" encoding="utf-8"?>
+<a:theme xmlns:a="http://schemas.openxmlformats.org/drawingml/2006/main" name="ChatGPT">
+  <a:themeElements>
+    <a:clrScheme name="ChatGPT">
+      <a:dk1>
+        <a:srgbClr val="000000"/>
+      </a:dk1>
+      <a:lt1>
+        <a:srgbClr val="FFFFFF"/>
+      </a:lt1>
+      <a:dk2>
+        <a:srgbClr val="0E2841"/>
+      </a:dk2>
+      <a:lt2>
+        <a:srgbClr val="E8E8E8"/>
+      </a:lt2>
+      <a:accent1>
+        <a:srgbClr val="156082"/>
+      </a:accent1>
+      <a:accent2>
+        <a:srgbClr val="E97132"/>
+      </a:accent2>
+      <a:accent3>
+        <a:srgbClr val="196B24"/>
+      </a:accent3>
+      <a:accent4>
+        <a:srgbClr val="0F9ED5"/>
+      </a:accent4>
+      <a:accent5>
+        <a:srgbClr val="A02B93"/>
+      </a:accent5>
+      <a:accent6>
+        <a:srgbClr val="4EA72E"/>
+      </a:accent6>
+      <a:hlink>
+        <a:srgbClr val="467886"/>
+      </a:hlink>
+      <a:folHlink>
+        <a:srgbClr val="96607D"/>
+      </a:folHlink>
+    </a:clrScheme>
+    <a:fontScheme name="">
+      <a:majorFont>
+        <a:latin typeface="Aptos"/>
+        <a:ea typeface=""/>
+        <a:cs typeface=""/>
+      </a:majorFont>
+      <a:minorFont>
+        <a:latin typeface="Aptos"/>
+        <a:ea typeface=""/>
+        <a:cs typeface=""/>
+      </a:minorFont>
+    </a:fontScheme>
+    <a:fmtScheme name="ChatGPT">
+      <a:fillStyleLst>
+        <a:solidFill>
+          <a:schemeClr val="phClr"/>
+        </a:solidFill>
+        <a:gradFill>
+          <a:gsLst>
+            <a:gs pos="0">
+              <a:schemeClr val="phClr">
+                <a:tint val="67000"/>
+                <a:lumMod val="110000"/>
+                <a:satMod val="105000"/>
+              </a:schemeClr>
+            </a:gs>
+            <a:gs pos="50000">
+              <a:schemeClr val="phClr">
+                <a:tint val="73000"/>
+                <a:lumMod val="105000"/>
+                <a:satMod val="103000"/>
+              </a:schemeClr>
+            </a:gs>
+            <a:gs pos="100000">
+              <a:schemeClr val="phClr">
+                <a:tint val="81000"/>
+                <a:lumMod val="105000"/>
+                <a:satMod val="109000"/>
+              </a:schemeClr>
+            </a:gs>
+          </a:gsLst>
+          <a:lin ang="5400000" scaled="0"/>
+        </a:gradFill>
+        <a:gradFill>
+          <a:gsLst>
+            <a:gs pos="0">
+              <a:schemeClr val="phClr">
+                <a:tint val="94000"/>
+                <a:lumMod val="102000"/>
+                <a:satMod val="103000"/>
+              </a:schemeClr>
+            </a:gs>
+            <a:gs pos="50000">
+              <a:schemeClr val="phClr">
+                <a:shade val="100000"/>
+                <a:lumMod val="100000"/>
+                <a:satMod val="110000"/>
+              </a:schemeClr>
+            </a:gs>
+            <a:gs pos="100000">
+              <a:schemeClr val="phClr">
+                <a:shade val="78000"/>
+                <a:lumMod val="99000"/>
+                <a:satMod val="120000"/>
+              </a:schemeClr>
+            </a:gs>
+          </a:gsLst>
+          <a:lin ang="5400000" scaled="0"/>
+        </a:gradFill>
+      </a:fillStyleLst>
+      <a:lnStyleLst>
+        <a:ln w="12700">
+          <a:solidFill>
+            <a:schemeClr val="phClr"/>
+          </a:solidFill>
+          <a:prstDash val="solid"/>
+        </a:ln>
+        <a:ln w="19050">
+          <a:solidFill>
+            <a:schemeClr val="phClr"/>
+          </a:solidFill>
+          <a:prstDash val="solid"/>
+        </a:ln>
+        <a:ln w="25400">
+          <a:solidFill>
+            <a:schemeClr val="phClr"/>
+          </a:solidFill>
+          <a:prstDash val="solid"/>
+        </a:ln>
+      </a:lnStyleLst>
+      <a:effectStyleLst>
+        <a:effectStyle>
+          <a:effectLst/>
+        </a:effectStyle>
+        <a:effectStyle>
+          <a:effectLst/>
+        </a:effectStyle>
+        <a:effectStyle>
+          <a:effectLst>
+            <a:outerShdw blurRad="57150" dist="19050" dir="5400000">
+              <a:srgbClr val="000000">
+                <a:alpha val="16000"/>
+              </a:srgbClr>
+            </a:outerShdw>
+          </a:effectLst>
+        </a:effectStyle>
+        <a:effectStyle>
+          <a:effectLst>
+            <a:outerShdw blurRad="19050" dist="9525" dir="5400000">
+              <a:srgbClr val="000000">
+                <a:alpha val="6000"/>
+              </a:srgbClr>
+            </a:outerShdw>
+          </a:effectLst>
+        </a:effectStyle>
+        <a:effectStyle>
+          <a:effectLst>
+            <a:outerShdw blurRad="28575" dist="9525" dir="5400000">
+              <a:srgbClr val="000000">
+                <a:alpha val="8000"/>
+              </a:srgbClr>
+            </a:outerShdw>
+          </a:effectLst>
+        </a:effectStyle>
+        <a:effectStyle>
+          <a:effectLst>
+            <a:outerShdw blurRad="57150" dist="19050" dir="5400000">
+              <a:srgbClr val="000000">
+                <a:alpha val="10000"/>
+              </a:srgbClr>
+            </a:outerShdw>
+          </a:effectLst>
+        </a:effectStyle>
+        <a:effectStyle>
+          <a:effectLst>
+            <a:outerShdw blurRad="114300" dist="38100" dir="5400000">
+              <a:srgbClr val="000000">
+                <a:alpha val="12000"/>
+              </a:srgbClr>
+            </a:outerShdw>
+          </a:effectLst>
+        </a:effectStyle>
+        <a:effectStyle>
+          <a:effectLst>
+            <a:outerShdw blurRad="171450" dist="57150" dir="5400000">
+              <a:srgbClr val="000000">
+                <a:alpha val="16000"/>
+              </a:srgbClr>
+            </a:outerShdw>
+          </a:effectLst>
+        </a:effectStyle>
+        <a:effectStyle>
+          <a:effectLst>
+            <a:outerShdw blurRad="266700" dist="95250" dir="5400000">
+              <a:srgbClr val="000000">
+                <a:alpha val="24000"/>
+              </a:srgbClr>
+            </a:outerShdw>
+          </a:effectLst>
+        </a:effectStyle>
+      </a:effectStyleLst>
+      <a:bgFillStyleLst>
+        <a:solidFill>
+          <a:schemeClr val="phClr"/>
+        </a:solidFill>
+        <a:solidFill>
+          <a:schemeClr val="phClr">
+            <a:tint val="95000"/>
+            <a:satMod val="170000"/>
+          </a:schemeClr>
+        </a:solidFill>
+        <a:gradFill>
+          <a:gsLst>
+            <a:gs pos="0">
+              <a:schemeClr val="phClr">
+                <a:tint val="93000"/>
+                <a:shade val="98000"/>
+                <a:lumMod val="102000"/>
+                <a:satMod val="150000"/>
+              </a:schemeClr>
+            </a:gs>
+            <a:gs pos="50000">
+              <a:schemeClr val="phClr">
+                <a:tint val="98000"/>
+                <a:shade val="90000"/>
+                <a:lumMod val="103000"/>
+                <a:satMod val="130000"/>
+              </a:schemeClr>
+            </a:gs>
+            <a:gs pos="100000">
+              <a:schemeClr val="phClr">
+                <a:shade val="63000"/>
+                <a:satMod val="120000"/>
+              </a:schemeClr>
+            </a:gs>
+          </a:gsLst>
+          <a:lin ang="5400000" scaled="0"/>
+        </a:gradFill>
+      </a:bgFillStyleLst>
+    </a:fmtScheme>
+  </a:themeElements>
+</a:theme>
+</file>
+
+<file path=ppt/appendix/tableStyles.xml><?xml version="1.0" encoding="utf-8"?>
+<a:tblStyleLst xmlns:a="http://schemas.openxmlformats.org/drawingml/2006/main" def="{5C22544A-7EE6-4342-B048-85BDC9FD1C3A}"/>
+</file>
+
+<file path=ppt/appendix/theme/theme1.xml><?xml version="1.0" encoding="utf-8"?>
+<a:theme xmlns:a="http://schemas.openxmlformats.org/drawingml/2006/main" name="ChatGPT">
+  <a:themeElements>
+    <a:clrScheme name="ChatGPT">
+      <a:dk1>
+        <a:srgbClr val="000000"/>
+      </a:dk1>
+      <a:lt1>
+        <a:srgbClr val="FFFFFF"/>
+      </a:lt1>
+      <a:dk2>
+        <a:srgbClr val="0E2841"/>
+      </a:dk2>
+      <a:lt2>
+        <a:srgbClr val="E8E8E8"/>
+      </a:lt2>
+      <a:accent1>
+        <a:srgbClr val="156082"/>
+      </a:accent1>
+      <a:accent2>
+        <a:srgbClr val="E97132"/>
+      </a:accent2>
+      <a:accent3>
+        <a:srgbClr val="196B24"/>
+      </a:accent3>
+      <a:accent4>
+        <a:srgbClr val="0F9ED5"/>
+      </a:accent4>
+      <a:accent5>
+        <a:srgbClr val="A02B93"/>
+      </a:accent5>
+      <a:accent6>
+        <a:srgbClr val="4EA72E"/>
+      </a:accent6>
+      <a:hlink>
+        <a:srgbClr val="467886"/>
+      </a:hlink>
+      <a:folHlink>
+        <a:srgbClr val="96607D"/>
+      </a:folHlink>
+    </a:clrScheme>
+    <a:fontScheme name="">
+      <a:majorFont>
+        <a:latin typeface="Aptos"/>
+        <a:ea typeface=""/>
+        <a:cs typeface=""/>
+      </a:majorFont>
+      <a:minorFont>
+        <a:latin typeface="Aptos"/>
+        <a:ea typeface=""/>
+        <a:cs typeface=""/>
+      </a:minorFont>
+    </a:fontScheme>
+    <a:fmtScheme name="ChatGPT">
+      <a:fillStyleLst>
+        <a:solidFill>
+          <a:schemeClr val="phClr"/>
+        </a:solidFill>
+        <a:gradFill>
+          <a:gsLst>
+            <a:gs pos="0">
+              <a:schemeClr val="phClr">
+                <a:tint val="67000"/>
+                <a:lumMod val="110000"/>
+                <a:satMod val="105000"/>
+              </a:schemeClr>
+            </a:gs>
+            <a:gs pos="50000">
+              <a:schemeClr val="phClr">
+                <a:tint val="73000"/>
+                <a:lumMod val="105000"/>
+                <a:satMod val="103000"/>
+              </a:schemeClr>
+            </a:gs>
+            <a:gs pos="100000">
+              <a:schemeClr val="phClr">
+                <a:tint val="81000"/>
+                <a:lumMod val="105000"/>
+                <a:satMod val="109000"/>
+              </a:schemeClr>
+            </a:gs>
+          </a:gsLst>
+          <a:lin ang="5400000" scaled="0"/>
+        </a:gradFill>
+        <a:gradFill>
+          <a:gsLst>
+            <a:gs pos="0">
+              <a:schemeClr val="phClr">
+                <a:tint val="94000"/>
+                <a:lumMod val="102000"/>
+                <a:satMod val="103000"/>
+              </a:schemeClr>
+            </a:gs>
+            <a:gs pos="50000">
+              <a:schemeClr val="phClr">
+                <a:shade val="100000"/>
+                <a:lumMod val="100000"/>
+                <a:satMod val="110000"/>
+              </a:schemeClr>
+            </a:gs>
+            <a:gs pos="100000">
+              <a:schemeClr val="phClr">
+                <a:shade val="78000"/>
+                <a:lumMod val="99000"/>
+                <a:satMod val="120000"/>
+              </a:schemeClr>
+            </a:gs>
+          </a:gsLst>
+          <a:lin ang="5400000" scaled="0"/>
+        </a:gradFill>
+      </a:fillStyleLst>
+      <a:lnStyleLst>
+        <a:ln w="12700">
+          <a:solidFill>
+            <a:schemeClr val="phClr"/>
+          </a:solidFill>
+          <a:prstDash val="solid"/>
+        </a:ln>
+        <a:ln w="19050">
+          <a:solidFill>
+            <a:schemeClr val="phClr"/>
+          </a:solidFill>
+          <a:prstDash val="solid"/>
+        </a:ln>
+        <a:ln w="25400">
+          <a:solidFill>
+            <a:schemeClr val="phClr"/>
+          </a:solidFill>
+          <a:prstDash val="solid"/>
+        </a:ln>
+      </a:lnStyleLst>
+      <a:effectStyleLst>
+        <a:effectStyle>
+          <a:effectLst/>
+        </a:effectStyle>
+        <a:effectStyle>
+          <a:effectLst/>
+        </a:effectStyle>
+        <a:effectStyle>
+          <a:effectLst>
+            <a:outerShdw blurRad="57150" dist="19050" dir="5400000">
+              <a:srgbClr val="000000">
+                <a:alpha val="16000"/>
+              </a:srgbClr>
+            </a:outerShdw>
+          </a:effectLst>
+        </a:effectStyle>
+        <a:effectStyle>
+          <a:effectLst>
+            <a:outerShdw blurRad="19050" dist="9525" dir="5400000">
+              <a:srgbClr val="000000">
+                <a:alpha val="6000"/>
+              </a:srgbClr>
+            </a:outerShdw>
+          </a:effectLst>
+        </a:effectStyle>
+        <a:effectStyle>
+          <a:effectLst>
+            <a:outerShdw blurRad="28575" dist="9525" dir="5400000">
+              <a:srgbClr val="000000">
+                <a:alpha val="8000"/>
+              </a:srgbClr>
+            </a:outerShdw>
+          </a:effectLst>
+        </a:effectStyle>
+        <a:effectStyle>
+          <a:effectLst>
+            <a:outerShdw blurRad="57150" dist="19050" dir="5400000">
+              <a:srgbClr val="000000">
+                <a:alpha val="10000"/>
+              </a:srgbClr>
+            </a:outerShdw>
+          </a:effectLst>
+        </a:effectStyle>
+        <a:effectStyle>
+          <a:effectLst>
+            <a:outerShdw blurRad="114300" dist="38100" dir="5400000">
+              <a:srgbClr val="000000">
+                <a:alpha val="12000"/>
+              </a:srgbClr>
+            </a:outerShdw>
+          </a:effectLst>
+        </a:effectStyle>
+        <a:effectStyle>
+          <a:effectLst>
+            <a:outerShdw blurRad="171450" dist="57150" dir="5400000">
+              <a:srgbClr val="000000">
+                <a:alpha val="16000"/>
+              </a:srgbClr>
+            </a:outerShdw>
+          </a:effectLst>
+        </a:effectStyle>
+        <a:effectStyle>
+          <a:effectLst>
+            <a:outerShdw blurRad="266700" dist="95250" dir="5400000">
+              <a:srgbClr val="000000">
+                <a:alpha val="24000"/>
+              </a:srgbClr>
+            </a:outerShdw>
+          </a:effectLst>
+        </a:effectStyle>
+      </a:effectStyleLst>
+      <a:bgFillStyleLst>
+        <a:solidFill>
+          <a:schemeClr val="phClr"/>
+        </a:solidFill>
+        <a:solidFill>
+          <a:schemeClr val="phClr">
+            <a:tint val="95000"/>
+            <a:satMod val="170000"/>
+          </a:schemeClr>
+        </a:solidFill>
+        <a:gradFill>
+          <a:gsLst>
+            <a:gs pos="0">
+              <a:schemeClr val="phClr">
+                <a:tint val="93000"/>
+                <a:shade val="98000"/>
+                <a:lumMod val="102000"/>
+                <a:satMod val="150000"/>
+              </a:schemeClr>
+            </a:gs>
+            <a:gs pos="50000">
+              <a:schemeClr val="phClr">
+                <a:tint val="98000"/>
+                <a:shade val="90000"/>
+                <a:lumMod val="103000"/>
+                <a:satMod val="130000"/>
+              </a:schemeClr>
+            </a:gs>
+            <a:gs pos="100000">
+              <a:schemeClr val="phClr">
+                <a:shade val="63000"/>
+                <a:satMod val="120000"/>
+              </a:schemeClr>
+            </a:gs>
+          </a:gsLst>
+          <a:lin ang="5400000" scaled="0"/>
+        </a:gradFill>
+      </a:bgFillStyleLst>
+    </a:fmtScheme>
+  </a:themeElements>
+</a:theme>
 </file>
 
 <file path=ppt/slideLayouts/slideLayout1.xml><?xml version="1.0" encoding="utf-8"?>
@@ -5991,6 +8487,1651 @@
 </p:sld>
 </file>
 
+<file path=ppt/slides/slide14.xml><?xml version="1.0" encoding="utf-8"?>
+<p:sld xmlns:p="http://schemas.openxmlformats.org/presentationml/2006/main">
+  <p:cSld>
+    <p:bg>
+      <p:bgPr>
+        <a:solidFill xmlns:a="http://schemas.openxmlformats.org/drawingml/2006/main">
+          <a:srgbClr val="F6F3EB"/>
+        </a:solidFill>
+      </p:bgPr>
+    </p:bg>
+    <p:spTree>
+      <p:nvGrpSpPr>
+        <p:cNvPr id="1" name=""/>
+        <p:cNvGrpSpPr/>
+        <p:nvPr/>
+      </p:nvGrpSpPr>
+      <p:grpSpPr>
+        <a:xfrm xmlns:a="http://schemas.openxmlformats.org/drawingml/2006/main"/>
+      </p:grpSpPr>
+      <p:sp>
+        <p:nvSpPr>
+          <p:cNvPr id="6" name="appendix-text-1">
+            <a:extLst xmlns:a="http://schemas.openxmlformats.org/drawingml/2006/main">
+              <a:ext uri="{FF2B5EF4-FFF2-40B4-BE49-F238E27FC236}">
+                <a16:creationId xmlns:a16="http://schemas.microsoft.com/office/drawing/2014/main" id="{7CDA8814-70AB-4DB0-A89A-623BCEB2D54B}"/>
+              </a:ext>
+            </a:extLst>
+          </p:cNvPr>
+          <p:cNvSpPr>
+            <a:spLocks xmlns:a="http://schemas.openxmlformats.org/drawingml/2006/main" noGrp="1"/>
+          </p:cNvSpPr>
+          <p:nvPr/>
+        </p:nvSpPr>
+        <p:spPr>
+          <a:xfrm xmlns:a="http://schemas.openxmlformats.org/drawingml/2006/main">
+            <a:off x="685800" y="514350"/>
+            <a:ext cx="10820400" cy="838200"/>
+          </a:xfrm>
+          <a:prstGeom xmlns:a="http://schemas.openxmlformats.org/drawingml/2006/main" prst="rect">
+            <a:avLst/>
+          </a:prstGeom>
+          <a:noFill xmlns:a="http://schemas.openxmlformats.org/drawingml/2006/main"/>
+          <a:ln xmlns:a="http://schemas.openxmlformats.org/drawingml/2006/main" w="0">
+            <a:noFill/>
+          </a:ln>
+        </p:spPr>
+        <p:txBody>
+          <a:bodyPr xmlns:a="http://schemas.openxmlformats.org/drawingml/2006/main" wrap="square" lIns="0" tIns="0" rIns="0" bIns="0" anchor="t">
+            <a:noAutofit/>
+          </a:bodyPr>
+          <a:lstStyle xmlns:a="http://schemas.openxmlformats.org/drawingml/2006/main">
+            <a:defPPr algn="l">
+              <a:defRPr sz="3600" b="1">
+                <a:solidFill>
+                  <a:srgbClr val="0D292E"/>
+                </a:solidFill>
+                <a:latin typeface="Arial"/>
+                <a:ea typeface="Arial"/>
+                <a:cs typeface="Arial"/>
+              </a:defRPr>
+            </a:defPPr>
+          </a:lstStyle>
+          <a:p xmlns:a="http://schemas.openxmlformats.org/drawingml/2006/main">
+            <a:pPr algn="l">
+              <a:defRPr sz="3600" b="1">
+                <a:solidFill>
+                  <a:srgbClr val="0D292E"/>
+                </a:solidFill>
+                <a:latin typeface="Arial"/>
+                <a:ea typeface="Arial"/>
+                <a:cs typeface="Arial"/>
+              </a:defRPr>
+            </a:pPr>
+            <a:r>
+              <a:rPr sz="3600" b="1">
+                <a:solidFill>
+                  <a:srgbClr val="0D292E"/>
+                </a:solidFill>
+                <a:latin typeface="Arial"/>
+                <a:ea typeface="Arial"/>
+                <a:cs typeface="Arial"/>
+              </a:rPr>
+              <a:t>Fleet Maintenance</a:t>
+            </a:r>
+          </a:p>
+        </p:txBody>
+      </p:sp>
+      <p:sp>
+        <p:nvSpPr>
+          <p:cNvPr id="2" name="appendix-text-2">
+            <a:extLst xmlns:a="http://schemas.openxmlformats.org/drawingml/2006/main">
+              <a:ext uri="{FF2B5EF4-FFF2-40B4-BE49-F238E27FC236}">
+                <a16:creationId xmlns:a16="http://schemas.microsoft.com/office/drawing/2014/main" id="{67B178A7-5F27-42E8-89E2-38E86BF49167}"/>
+              </a:ext>
+            </a:extLst>
+          </p:cNvPr>
+          <p:cNvSpPr>
+            <a:spLocks xmlns:a="http://schemas.openxmlformats.org/drawingml/2006/main" noGrp="1"/>
+          </p:cNvSpPr>
+          <p:nvPr/>
+        </p:nvSpPr>
+        <p:spPr>
+          <a:xfrm xmlns:a="http://schemas.openxmlformats.org/drawingml/2006/main">
+            <a:off x="685800" y="1381125"/>
+            <a:ext cx="10820400" cy="457200"/>
+          </a:xfrm>
+          <a:prstGeom xmlns:a="http://schemas.openxmlformats.org/drawingml/2006/main" prst="rect">
+            <a:avLst/>
+          </a:prstGeom>
+          <a:noFill xmlns:a="http://schemas.openxmlformats.org/drawingml/2006/main"/>
+          <a:ln xmlns:a="http://schemas.openxmlformats.org/drawingml/2006/main" w="0">
+            <a:noFill/>
+          </a:ln>
+        </p:spPr>
+        <p:txBody>
+          <a:bodyPr xmlns:a="http://schemas.openxmlformats.org/drawingml/2006/main" wrap="square" lIns="0" tIns="0" rIns="0" bIns="0" anchor="t">
+            <a:noAutofit/>
+          </a:bodyPr>
+          <a:lstStyle xmlns:a="http://schemas.openxmlformats.org/drawingml/2006/main">
+            <a:defPPr algn="l">
+              <a:defRPr sz="1875" b="0">
+                <a:solidFill>
+                  <a:srgbClr val="506367"/>
+                </a:solidFill>
+                <a:latin typeface="Arial"/>
+                <a:ea typeface="Arial"/>
+                <a:cs typeface="Arial"/>
+              </a:defRPr>
+            </a:defPPr>
+          </a:lstStyle>
+          <a:p xmlns:a="http://schemas.openxmlformats.org/drawingml/2006/main">
+            <a:pPr algn="l">
+              <a:defRPr sz="1875" b="0">
+                <a:solidFill>
+                  <a:srgbClr val="506367"/>
+                </a:solidFill>
+                <a:latin typeface="Arial"/>
+                <a:ea typeface="Arial"/>
+                <a:cs typeface="Arial"/>
+              </a:defRPr>
+            </a:pPr>
+            <a:r>
+              <a:rPr sz="1875" b="0">
+                <a:solidFill>
+                  <a:srgbClr val="506367"/>
+                </a:solidFill>
+                <a:latin typeface="Arial"/>
+                <a:ea typeface="Arial"/>
+                <a:cs typeface="Arial"/>
+              </a:rPr>
+              <a:t>Seguimiento de inspecciones, TAG y horómetros</a:t>
+            </a:r>
+          </a:p>
+        </p:txBody>
+      </p:sp>
+      <p:pic>
+        <p:nvPicPr>
+          <p:cNvPr id="3" name="">
+            <a:extLst xmlns:a="http://schemas.openxmlformats.org/drawingml/2006/main">
+              <a:ext uri="{FF2B5EF4-FFF2-40B4-BE49-F238E27FC236}">
+                <a16:creationId xmlns:a16="http://schemas.microsoft.com/office/drawing/2014/main" id="{8D13C495-0ED3-4AB4-B97F-58737A5B03A7}"/>
+              </a:ext>
+            </a:extLst>
+          </p:cNvPr>
+          <p:cNvPicPr>
+            <a:picLocks xmlns:a="http://schemas.openxmlformats.org/drawingml/2006/main" noChangeAspect="1"/>
+          </p:cNvPicPr>
+          <p:nvPr/>
+        </p:nvPicPr>
+        <p:blipFill>
+          <a:blip xmlns:r="http://schemas.openxmlformats.org/officeDocument/2006/relationships" xmlns:a="http://schemas.openxmlformats.org/drawingml/2006/main" r:embed="Rb93a019b24ea4a11"/>
+          <a:stretch xmlns:a="http://schemas.openxmlformats.org/drawingml/2006/main"/>
+        </p:blipFill>
+        <p:spPr>
+          <a:xfrm xmlns:a="http://schemas.openxmlformats.org/drawingml/2006/main">
+            <a:off x="2773680" y="1885950"/>
+            <a:ext cx="6644640" cy="4152900"/>
+          </a:xfrm>
+          <a:prstGeom xmlns:a="http://schemas.openxmlformats.org/drawingml/2006/main" prst="rect">
+            <a:avLst/>
+          </a:prstGeom>
+        </p:spPr>
+      </p:pic>
+      <p:sp>
+        <p:nvSpPr>
+          <p:cNvPr id="4" name="appendix-text-3">
+            <a:extLst xmlns:a="http://schemas.openxmlformats.org/drawingml/2006/main">
+              <a:ext uri="{FF2B5EF4-FFF2-40B4-BE49-F238E27FC236}">
+                <a16:creationId xmlns:a16="http://schemas.microsoft.com/office/drawing/2014/main" id="{40CEF484-A651-4B54-A1C5-19681DAE9AEE}"/>
+              </a:ext>
+            </a:extLst>
+          </p:cNvPr>
+          <p:cNvSpPr>
+            <a:spLocks xmlns:a="http://schemas.openxmlformats.org/drawingml/2006/main" noGrp="1"/>
+          </p:cNvSpPr>
+          <p:nvPr/>
+        </p:nvSpPr>
+        <p:spPr>
+          <a:xfrm xmlns:a="http://schemas.openxmlformats.org/drawingml/2006/main">
+            <a:off x="685800" y="6191250"/>
+            <a:ext cx="9906000" cy="266700"/>
+          </a:xfrm>
+          <a:prstGeom xmlns:a="http://schemas.openxmlformats.org/drawingml/2006/main" prst="rect">
+            <a:avLst/>
+          </a:prstGeom>
+          <a:noFill xmlns:a="http://schemas.openxmlformats.org/drawingml/2006/main"/>
+          <a:ln xmlns:a="http://schemas.openxmlformats.org/drawingml/2006/main" w="0">
+            <a:noFill/>
+          </a:ln>
+        </p:spPr>
+        <p:txBody>
+          <a:bodyPr xmlns:a="http://schemas.openxmlformats.org/drawingml/2006/main" wrap="square" lIns="0" tIns="0" rIns="0" bIns="0" anchor="t">
+            <a:noAutofit/>
+          </a:bodyPr>
+          <a:lstStyle xmlns:a="http://schemas.openxmlformats.org/drawingml/2006/main">
+            <a:defPPr algn="l">
+              <a:defRPr sz="1575" b="0">
+                <a:solidFill>
+                  <a:srgbClr val="506367"/>
+                </a:solidFill>
+                <a:latin typeface="Arial"/>
+                <a:ea typeface="Arial"/>
+                <a:cs typeface="Arial"/>
+              </a:defRPr>
+            </a:defPPr>
+          </a:lstStyle>
+          <a:p xmlns:a="http://schemas.openxmlformats.org/drawingml/2006/main">
+            <a:pPr algn="l">
+              <a:defRPr sz="1575" b="0">
+                <a:solidFill>
+                  <a:srgbClr val="506367"/>
+                </a:solidFill>
+                <a:latin typeface="Arial"/>
+                <a:ea typeface="Arial"/>
+                <a:cs typeface="Arial"/>
+              </a:defRPr>
+            </a:pPr>
+            <a:r>
+              <a:rPr sz="1575" b="0">
+                <a:solidFill>
+                  <a:srgbClr val="506367"/>
+                </a:solidFill>
+                <a:latin typeface="Arial"/>
+                <a:ea typeface="Arial"/>
+                <a:cs typeface="Arial"/>
+              </a:rPr>
+              <a:t>Interfaz original funcionando con datos 100% sintéticos</a:t>
+            </a:r>
+          </a:p>
+        </p:txBody>
+      </p:sp>
+      <p:sp>
+        <p:nvSpPr>
+          <p:cNvPr id="5" name="appendix-text-4">
+            <a:extLst xmlns:a="http://schemas.openxmlformats.org/drawingml/2006/main">
+              <a:ext uri="{FF2B5EF4-FFF2-40B4-BE49-F238E27FC236}">
+                <a16:creationId xmlns:a16="http://schemas.microsoft.com/office/drawing/2014/main" id="{2776E4B1-D1ED-4C70-B419-0E8F11ED3EC9}"/>
+              </a:ext>
+            </a:extLst>
+          </p:cNvPr>
+          <p:cNvSpPr>
+            <a:spLocks xmlns:a="http://schemas.openxmlformats.org/drawingml/2006/main" noGrp="1"/>
+          </p:cNvSpPr>
+          <p:nvPr/>
+        </p:nvSpPr>
+        <p:spPr>
+          <a:xfrm xmlns:a="http://schemas.openxmlformats.org/drawingml/2006/main">
+            <a:off x="10953750" y="6286500"/>
+            <a:ext cx="552450" cy="266700"/>
+          </a:xfrm>
+          <a:prstGeom xmlns:a="http://schemas.openxmlformats.org/drawingml/2006/main" prst="rect">
+            <a:avLst/>
+          </a:prstGeom>
+          <a:noFill xmlns:a="http://schemas.openxmlformats.org/drawingml/2006/main"/>
+          <a:ln xmlns:a="http://schemas.openxmlformats.org/drawingml/2006/main" w="0">
+            <a:noFill/>
+          </a:ln>
+        </p:spPr>
+        <p:txBody>
+          <a:bodyPr xmlns:a="http://schemas.openxmlformats.org/drawingml/2006/main" wrap="square" lIns="0" tIns="0" rIns="0" bIns="0" anchor="t">
+            <a:noAutofit/>
+          </a:bodyPr>
+          <a:lstStyle xmlns:a="http://schemas.openxmlformats.org/drawingml/2006/main">
+            <a:defPPr algn="r">
+              <a:defRPr sz="1500" b="0">
+                <a:solidFill>
+                  <a:srgbClr val="506367"/>
+                </a:solidFill>
+                <a:latin typeface="Arial"/>
+                <a:ea typeface="Arial"/>
+                <a:cs typeface="Arial"/>
+              </a:defRPr>
+            </a:defPPr>
+          </a:lstStyle>
+          <a:p xmlns:a="http://schemas.openxmlformats.org/drawingml/2006/main">
+            <a:pPr algn="r">
+              <a:defRPr sz="1500" b="0">
+                <a:solidFill>
+                  <a:srgbClr val="506367"/>
+                </a:solidFill>
+                <a:latin typeface="Arial"/>
+                <a:ea typeface="Arial"/>
+                <a:cs typeface="Arial"/>
+              </a:defRPr>
+            </a:pPr>
+            <a:r>
+              <a:rPr sz="1500" b="0">
+                <a:solidFill>
+                  <a:srgbClr val="506367"/>
+                </a:solidFill>
+                <a:latin typeface="Arial"/>
+                <a:ea typeface="Arial"/>
+                <a:cs typeface="Arial"/>
+              </a:rPr>
+              <a:t>14</a:t>
+            </a:r>
+          </a:p>
+        </p:txBody>
+      </p:sp>
+    </p:spTree>
+    <p:extLst>
+      <p:ext uri="{BB962C8B-B14F-4D97-AF65-F5344CB8AC3E}">
+        <p14:creationId xmlns:p14="http://schemas.microsoft.com/office/powerpoint/2010/main" val="444732825"/>
+      </p:ext>
+    </p:extLst>
+  </p:cSld>
+</p:sld>
+</file>
+
+<file path=ppt/slides/slide15.xml><?xml version="1.0" encoding="utf-8"?>
+<p:sld xmlns:p="http://schemas.openxmlformats.org/presentationml/2006/main">
+  <p:cSld>
+    <p:bg>
+      <p:bgPr>
+        <a:solidFill xmlns:a="http://schemas.openxmlformats.org/drawingml/2006/main">
+          <a:srgbClr val="F6F3EB"/>
+        </a:solidFill>
+      </p:bgPr>
+    </p:bg>
+    <p:spTree>
+      <p:nvGrpSpPr>
+        <p:cNvPr id="1" name=""/>
+        <p:cNvGrpSpPr/>
+        <p:nvPr/>
+      </p:nvGrpSpPr>
+      <p:grpSpPr>
+        <a:xfrm xmlns:a="http://schemas.openxmlformats.org/drawingml/2006/main"/>
+      </p:grpSpPr>
+      <p:sp>
+        <p:nvSpPr>
+          <p:cNvPr id="6" name="appendix-text-5">
+            <a:extLst xmlns:a="http://schemas.openxmlformats.org/drawingml/2006/main">
+              <a:ext uri="{FF2B5EF4-FFF2-40B4-BE49-F238E27FC236}">
+                <a16:creationId xmlns:a16="http://schemas.microsoft.com/office/drawing/2014/main" id="{7736F091-0C35-441C-99DB-A673801B0EA5}"/>
+              </a:ext>
+            </a:extLst>
+          </p:cNvPr>
+          <p:cNvSpPr>
+            <a:spLocks xmlns:a="http://schemas.openxmlformats.org/drawingml/2006/main" noGrp="1"/>
+          </p:cNvSpPr>
+          <p:nvPr/>
+        </p:nvSpPr>
+        <p:spPr>
+          <a:xfrm xmlns:a="http://schemas.openxmlformats.org/drawingml/2006/main">
+            <a:off x="685800" y="514350"/>
+            <a:ext cx="10820400" cy="838200"/>
+          </a:xfrm>
+          <a:prstGeom xmlns:a="http://schemas.openxmlformats.org/drawingml/2006/main" prst="rect">
+            <a:avLst/>
+          </a:prstGeom>
+          <a:noFill xmlns:a="http://schemas.openxmlformats.org/drawingml/2006/main"/>
+          <a:ln xmlns:a="http://schemas.openxmlformats.org/drawingml/2006/main" w="0">
+            <a:noFill/>
+          </a:ln>
+        </p:spPr>
+        <p:txBody>
+          <a:bodyPr xmlns:a="http://schemas.openxmlformats.org/drawingml/2006/main" wrap="square" lIns="0" tIns="0" rIns="0" bIns="0" anchor="t">
+            <a:noAutofit/>
+          </a:bodyPr>
+          <a:lstStyle xmlns:a="http://schemas.openxmlformats.org/drawingml/2006/main">
+            <a:defPPr algn="l">
+              <a:defRPr sz="3600" b="1">
+                <a:solidFill>
+                  <a:srgbClr val="0D292E"/>
+                </a:solidFill>
+                <a:latin typeface="Arial"/>
+                <a:ea typeface="Arial"/>
+                <a:cs typeface="Arial"/>
+              </a:defRPr>
+            </a:defPPr>
+          </a:lstStyle>
+          <a:p xmlns:a="http://schemas.openxmlformats.org/drawingml/2006/main">
+            <a:pPr algn="l">
+              <a:defRPr sz="3600" b="1">
+                <a:solidFill>
+                  <a:srgbClr val="0D292E"/>
+                </a:solidFill>
+                <a:latin typeface="Arial"/>
+                <a:ea typeface="Arial"/>
+                <a:cs typeface="Arial"/>
+              </a:defRPr>
+            </a:pPr>
+            <a:r>
+              <a:rPr sz="3600" b="1">
+                <a:solidFill>
+                  <a:srgbClr val="0D292E"/>
+                </a:solidFill>
+                <a:latin typeface="Arial"/>
+                <a:ea typeface="Arial"/>
+                <a:cs typeface="Arial"/>
+              </a:rPr>
+              <a:t>Intake vs Delivery</a:t>
+            </a:r>
+          </a:p>
+        </p:txBody>
+      </p:sp>
+      <p:sp>
+        <p:nvSpPr>
+          <p:cNvPr id="2" name="appendix-text-6">
+            <a:extLst xmlns:a="http://schemas.openxmlformats.org/drawingml/2006/main">
+              <a:ext uri="{FF2B5EF4-FFF2-40B4-BE49-F238E27FC236}">
+                <a16:creationId xmlns:a16="http://schemas.microsoft.com/office/drawing/2014/main" id="{C8B0C27C-1623-42FC-9E38-B8BB2EDF9290}"/>
+              </a:ext>
+            </a:extLst>
+          </p:cNvPr>
+          <p:cNvSpPr>
+            <a:spLocks xmlns:a="http://schemas.openxmlformats.org/drawingml/2006/main" noGrp="1"/>
+          </p:cNvSpPr>
+          <p:nvPr/>
+        </p:nvSpPr>
+        <p:spPr>
+          <a:xfrm xmlns:a="http://schemas.openxmlformats.org/drawingml/2006/main">
+            <a:off x="685800" y="1381125"/>
+            <a:ext cx="10820400" cy="457200"/>
+          </a:xfrm>
+          <a:prstGeom xmlns:a="http://schemas.openxmlformats.org/drawingml/2006/main" prst="rect">
+            <a:avLst/>
+          </a:prstGeom>
+          <a:noFill xmlns:a="http://schemas.openxmlformats.org/drawingml/2006/main"/>
+          <a:ln xmlns:a="http://schemas.openxmlformats.org/drawingml/2006/main" w="0">
+            <a:noFill/>
+          </a:ln>
+        </p:spPr>
+        <p:txBody>
+          <a:bodyPr xmlns:a="http://schemas.openxmlformats.org/drawingml/2006/main" wrap="square" lIns="0" tIns="0" rIns="0" bIns="0" anchor="t">
+            <a:noAutofit/>
+          </a:bodyPr>
+          <a:lstStyle xmlns:a="http://schemas.openxmlformats.org/drawingml/2006/main">
+            <a:defPPr algn="l">
+              <a:defRPr sz="1875" b="0">
+                <a:solidFill>
+                  <a:srgbClr val="506367"/>
+                </a:solidFill>
+                <a:latin typeface="Arial"/>
+                <a:ea typeface="Arial"/>
+                <a:cs typeface="Arial"/>
+              </a:defRPr>
+            </a:defPPr>
+          </a:lstStyle>
+          <a:p xmlns:a="http://schemas.openxmlformats.org/drawingml/2006/main">
+            <a:pPr algn="l">
+              <a:defRPr sz="1875" b="0">
+                <a:solidFill>
+                  <a:srgbClr val="506367"/>
+                </a:solidFill>
+                <a:latin typeface="Arial"/>
+                <a:ea typeface="Arial"/>
+                <a:cs typeface="Arial"/>
+              </a:defRPr>
+            </a:pPr>
+            <a:r>
+              <a:rPr sz="1875" b="0">
+                <a:solidFill>
+                  <a:srgbClr val="506367"/>
+                </a:solidFill>
+                <a:latin typeface="Arial"/>
+                <a:ea typeface="Arial"/>
+                <a:cs typeface="Arial"/>
+              </a:rPr>
+              <a:t>Comparación de entradas y salidas de combustible</a:t>
+            </a:r>
+          </a:p>
+        </p:txBody>
+      </p:sp>
+      <p:pic>
+        <p:nvPicPr>
+          <p:cNvPr id="3" name="">
+            <a:extLst xmlns:a="http://schemas.openxmlformats.org/drawingml/2006/main">
+              <a:ext uri="{FF2B5EF4-FFF2-40B4-BE49-F238E27FC236}">
+                <a16:creationId xmlns:a16="http://schemas.microsoft.com/office/drawing/2014/main" id="{3412A858-16C6-4EF4-A918-B90ED2FD866C}"/>
+              </a:ext>
+            </a:extLst>
+          </p:cNvPr>
+          <p:cNvPicPr>
+            <a:picLocks xmlns:a="http://schemas.openxmlformats.org/drawingml/2006/main" noChangeAspect="1"/>
+          </p:cNvPicPr>
+          <p:nvPr/>
+        </p:nvPicPr>
+        <p:blipFill>
+          <a:blip xmlns:r="http://schemas.openxmlformats.org/officeDocument/2006/relationships" xmlns:a="http://schemas.openxmlformats.org/drawingml/2006/main" r:embed="Rc6d0c9b34d2b461e"/>
+          <a:stretch xmlns:a="http://schemas.openxmlformats.org/drawingml/2006/main"/>
+        </p:blipFill>
+        <p:spPr>
+          <a:xfrm xmlns:a="http://schemas.openxmlformats.org/drawingml/2006/main">
+            <a:off x="2773680" y="1885950"/>
+            <a:ext cx="6644640" cy="4152900"/>
+          </a:xfrm>
+          <a:prstGeom xmlns:a="http://schemas.openxmlformats.org/drawingml/2006/main" prst="rect">
+            <a:avLst/>
+          </a:prstGeom>
+        </p:spPr>
+      </p:pic>
+      <p:sp>
+        <p:nvSpPr>
+          <p:cNvPr id="4" name="appendix-text-7">
+            <a:extLst xmlns:a="http://schemas.openxmlformats.org/drawingml/2006/main">
+              <a:ext uri="{FF2B5EF4-FFF2-40B4-BE49-F238E27FC236}">
+                <a16:creationId xmlns:a16="http://schemas.microsoft.com/office/drawing/2014/main" id="{560E8CF9-D970-4BA0-9067-6C43A9FE488D}"/>
+              </a:ext>
+            </a:extLst>
+          </p:cNvPr>
+          <p:cNvSpPr>
+            <a:spLocks xmlns:a="http://schemas.openxmlformats.org/drawingml/2006/main" noGrp="1"/>
+          </p:cNvSpPr>
+          <p:nvPr/>
+        </p:nvSpPr>
+        <p:spPr>
+          <a:xfrm xmlns:a="http://schemas.openxmlformats.org/drawingml/2006/main">
+            <a:off x="685800" y="6191250"/>
+            <a:ext cx="9906000" cy="266700"/>
+          </a:xfrm>
+          <a:prstGeom xmlns:a="http://schemas.openxmlformats.org/drawingml/2006/main" prst="rect">
+            <a:avLst/>
+          </a:prstGeom>
+          <a:noFill xmlns:a="http://schemas.openxmlformats.org/drawingml/2006/main"/>
+          <a:ln xmlns:a="http://schemas.openxmlformats.org/drawingml/2006/main" w="0">
+            <a:noFill/>
+          </a:ln>
+        </p:spPr>
+        <p:txBody>
+          <a:bodyPr xmlns:a="http://schemas.openxmlformats.org/drawingml/2006/main" wrap="square" lIns="0" tIns="0" rIns="0" bIns="0" anchor="t">
+            <a:noAutofit/>
+          </a:bodyPr>
+          <a:lstStyle xmlns:a="http://schemas.openxmlformats.org/drawingml/2006/main">
+            <a:defPPr algn="l">
+              <a:defRPr sz="1575" b="0">
+                <a:solidFill>
+                  <a:srgbClr val="506367"/>
+                </a:solidFill>
+                <a:latin typeface="Arial"/>
+                <a:ea typeface="Arial"/>
+                <a:cs typeface="Arial"/>
+              </a:defRPr>
+            </a:defPPr>
+          </a:lstStyle>
+          <a:p xmlns:a="http://schemas.openxmlformats.org/drawingml/2006/main">
+            <a:pPr algn="l">
+              <a:defRPr sz="1575" b="0">
+                <a:solidFill>
+                  <a:srgbClr val="506367"/>
+                </a:solidFill>
+                <a:latin typeface="Arial"/>
+                <a:ea typeface="Arial"/>
+                <a:cs typeface="Arial"/>
+              </a:defRPr>
+            </a:pPr>
+            <a:r>
+              <a:rPr sz="1575" b="0">
+                <a:solidFill>
+                  <a:srgbClr val="506367"/>
+                </a:solidFill>
+                <a:latin typeface="Arial"/>
+                <a:ea typeface="Arial"/>
+                <a:cs typeface="Arial"/>
+              </a:rPr>
+              <a:t>Interfaz original funcionando con datos 100% sintéticos</a:t>
+            </a:r>
+          </a:p>
+        </p:txBody>
+      </p:sp>
+      <p:sp>
+        <p:nvSpPr>
+          <p:cNvPr id="5" name="appendix-text-8">
+            <a:extLst xmlns:a="http://schemas.openxmlformats.org/drawingml/2006/main">
+              <a:ext uri="{FF2B5EF4-FFF2-40B4-BE49-F238E27FC236}">
+                <a16:creationId xmlns:a16="http://schemas.microsoft.com/office/drawing/2014/main" id="{99C70E3F-9682-4B5F-9A46-BF10AD28810A}"/>
+              </a:ext>
+            </a:extLst>
+          </p:cNvPr>
+          <p:cNvSpPr>
+            <a:spLocks xmlns:a="http://schemas.openxmlformats.org/drawingml/2006/main" noGrp="1"/>
+          </p:cNvSpPr>
+          <p:nvPr/>
+        </p:nvSpPr>
+        <p:spPr>
+          <a:xfrm xmlns:a="http://schemas.openxmlformats.org/drawingml/2006/main">
+            <a:off x="10953750" y="6286500"/>
+            <a:ext cx="552450" cy="266700"/>
+          </a:xfrm>
+          <a:prstGeom xmlns:a="http://schemas.openxmlformats.org/drawingml/2006/main" prst="rect">
+            <a:avLst/>
+          </a:prstGeom>
+          <a:noFill xmlns:a="http://schemas.openxmlformats.org/drawingml/2006/main"/>
+          <a:ln xmlns:a="http://schemas.openxmlformats.org/drawingml/2006/main" w="0">
+            <a:noFill/>
+          </a:ln>
+        </p:spPr>
+        <p:txBody>
+          <a:bodyPr xmlns:a="http://schemas.openxmlformats.org/drawingml/2006/main" wrap="square" lIns="0" tIns="0" rIns="0" bIns="0" anchor="t">
+            <a:noAutofit/>
+          </a:bodyPr>
+          <a:lstStyle xmlns:a="http://schemas.openxmlformats.org/drawingml/2006/main">
+            <a:defPPr algn="r">
+              <a:defRPr sz="1500" b="0">
+                <a:solidFill>
+                  <a:srgbClr val="506367"/>
+                </a:solidFill>
+                <a:latin typeface="Arial"/>
+                <a:ea typeface="Arial"/>
+                <a:cs typeface="Arial"/>
+              </a:defRPr>
+            </a:defPPr>
+          </a:lstStyle>
+          <a:p xmlns:a="http://schemas.openxmlformats.org/drawingml/2006/main">
+            <a:pPr algn="r">
+              <a:defRPr sz="1500" b="0">
+                <a:solidFill>
+                  <a:srgbClr val="506367"/>
+                </a:solidFill>
+                <a:latin typeface="Arial"/>
+                <a:ea typeface="Arial"/>
+                <a:cs typeface="Arial"/>
+              </a:defRPr>
+            </a:pPr>
+            <a:r>
+              <a:rPr sz="1500" b="0">
+                <a:solidFill>
+                  <a:srgbClr val="506367"/>
+                </a:solidFill>
+                <a:latin typeface="Arial"/>
+                <a:ea typeface="Arial"/>
+                <a:cs typeface="Arial"/>
+              </a:rPr>
+              <a:t>15</a:t>
+            </a:r>
+          </a:p>
+        </p:txBody>
+      </p:sp>
+    </p:spTree>
+    <p:extLst>
+      <p:ext uri="{BB962C8B-B14F-4D97-AF65-F5344CB8AC3E}">
+        <p14:creationId xmlns:p14="http://schemas.microsoft.com/office/powerpoint/2010/main" val="385326777"/>
+      </p:ext>
+    </p:extLst>
+  </p:cSld>
+</p:sld>
+</file>
+
+<file path=ppt/slides/slide16.xml><?xml version="1.0" encoding="utf-8"?>
+<p:sld xmlns:p="http://schemas.openxmlformats.org/presentationml/2006/main">
+  <p:cSld>
+    <p:bg>
+      <p:bgPr>
+        <a:solidFill xmlns:a="http://schemas.openxmlformats.org/drawingml/2006/main">
+          <a:srgbClr val="F6F3EB"/>
+        </a:solidFill>
+      </p:bgPr>
+    </p:bg>
+    <p:spTree>
+      <p:nvGrpSpPr>
+        <p:cNvPr id="1" name=""/>
+        <p:cNvGrpSpPr/>
+        <p:nvPr/>
+      </p:nvGrpSpPr>
+      <p:grpSpPr>
+        <a:xfrm xmlns:a="http://schemas.openxmlformats.org/drawingml/2006/main"/>
+      </p:grpSpPr>
+      <p:sp>
+        <p:nvSpPr>
+          <p:cNvPr id="6" name="appendix-text-9">
+            <a:extLst xmlns:a="http://schemas.openxmlformats.org/drawingml/2006/main">
+              <a:ext uri="{FF2B5EF4-FFF2-40B4-BE49-F238E27FC236}">
+                <a16:creationId xmlns:a16="http://schemas.microsoft.com/office/drawing/2014/main" id="{B3F99DED-4771-477E-B1BC-9E42068B6F9B}"/>
+              </a:ext>
+            </a:extLst>
+          </p:cNvPr>
+          <p:cNvSpPr>
+            <a:spLocks xmlns:a="http://schemas.openxmlformats.org/drawingml/2006/main" noGrp="1"/>
+          </p:cNvSpPr>
+          <p:nvPr/>
+        </p:nvSpPr>
+        <p:spPr>
+          <a:xfrm xmlns:a="http://schemas.openxmlformats.org/drawingml/2006/main">
+            <a:off x="685800" y="514350"/>
+            <a:ext cx="10820400" cy="838200"/>
+          </a:xfrm>
+          <a:prstGeom xmlns:a="http://schemas.openxmlformats.org/drawingml/2006/main" prst="rect">
+            <a:avLst/>
+          </a:prstGeom>
+          <a:noFill xmlns:a="http://schemas.openxmlformats.org/drawingml/2006/main"/>
+          <a:ln xmlns:a="http://schemas.openxmlformats.org/drawingml/2006/main" w="0">
+            <a:noFill/>
+          </a:ln>
+        </p:spPr>
+        <p:txBody>
+          <a:bodyPr xmlns:a="http://schemas.openxmlformats.org/drawingml/2006/main" wrap="square" lIns="0" tIns="0" rIns="0" bIns="0" anchor="t">
+            <a:noAutofit/>
+          </a:bodyPr>
+          <a:lstStyle xmlns:a="http://schemas.openxmlformats.org/drawingml/2006/main">
+            <a:defPPr algn="l">
+              <a:defRPr sz="3600" b="1">
+                <a:solidFill>
+                  <a:srgbClr val="0D292E"/>
+                </a:solidFill>
+                <a:latin typeface="Arial"/>
+                <a:ea typeface="Arial"/>
+                <a:cs typeface="Arial"/>
+              </a:defRPr>
+            </a:defPPr>
+          </a:lstStyle>
+          <a:p xmlns:a="http://schemas.openxmlformats.org/drawingml/2006/main">
+            <a:pPr algn="l">
+              <a:defRPr sz="3600" b="1">
+                <a:solidFill>
+                  <a:srgbClr val="0D292E"/>
+                </a:solidFill>
+                <a:latin typeface="Arial"/>
+                <a:ea typeface="Arial"/>
+                <a:cs typeface="Arial"/>
+              </a:defRPr>
+            </a:pPr>
+            <a:r>
+              <a:rPr sz="3600" b="1">
+                <a:solidFill>
+                  <a:srgbClr val="0D292E"/>
+                </a:solidFill>
+                <a:latin typeface="Arial"/>
+                <a:ea typeface="Arial"/>
+                <a:cs typeface="Arial"/>
+              </a:rPr>
+              <a:t>Overfill SFL Spy</a:t>
+            </a:r>
+          </a:p>
+        </p:txBody>
+      </p:sp>
+      <p:sp>
+        <p:nvSpPr>
+          <p:cNvPr id="2" name="appendix-text-10">
+            <a:extLst xmlns:a="http://schemas.openxmlformats.org/drawingml/2006/main">
+              <a:ext uri="{FF2B5EF4-FFF2-40B4-BE49-F238E27FC236}">
+                <a16:creationId xmlns:a16="http://schemas.microsoft.com/office/drawing/2014/main" id="{3BCAB646-71B2-4246-A0E0-139BA415E19D}"/>
+              </a:ext>
+            </a:extLst>
+          </p:cNvPr>
+          <p:cNvSpPr>
+            <a:spLocks xmlns:a="http://schemas.openxmlformats.org/drawingml/2006/main" noGrp="1"/>
+          </p:cNvSpPr>
+          <p:nvPr/>
+        </p:nvSpPr>
+        <p:spPr>
+          <a:xfrm xmlns:a="http://schemas.openxmlformats.org/drawingml/2006/main">
+            <a:off x="685800" y="1381125"/>
+            <a:ext cx="10820400" cy="457200"/>
+          </a:xfrm>
+          <a:prstGeom xmlns:a="http://schemas.openxmlformats.org/drawingml/2006/main" prst="rect">
+            <a:avLst/>
+          </a:prstGeom>
+          <a:noFill xmlns:a="http://schemas.openxmlformats.org/drawingml/2006/main"/>
+          <a:ln xmlns:a="http://schemas.openxmlformats.org/drawingml/2006/main" w="0">
+            <a:noFill/>
+          </a:ln>
+        </p:spPr>
+        <p:txBody>
+          <a:bodyPr xmlns:a="http://schemas.openxmlformats.org/drawingml/2006/main" wrap="square" lIns="0" tIns="0" rIns="0" bIns="0" anchor="t">
+            <a:noAutofit/>
+          </a:bodyPr>
+          <a:lstStyle xmlns:a="http://schemas.openxmlformats.org/drawingml/2006/main">
+            <a:defPPr algn="l">
+              <a:defRPr sz="1875" b="0">
+                <a:solidFill>
+                  <a:srgbClr val="506367"/>
+                </a:solidFill>
+                <a:latin typeface="Arial"/>
+                <a:ea typeface="Arial"/>
+                <a:cs typeface="Arial"/>
+              </a:defRPr>
+            </a:defPPr>
+          </a:lstStyle>
+          <a:p xmlns:a="http://schemas.openxmlformats.org/drawingml/2006/main">
+            <a:pPr algn="l">
+              <a:defRPr sz="1875" b="0">
+                <a:solidFill>
+                  <a:srgbClr val="506367"/>
+                </a:solidFill>
+                <a:latin typeface="Arial"/>
+                <a:ea typeface="Arial"/>
+                <a:cs typeface="Arial"/>
+              </a:defRPr>
+            </a:pPr>
+            <a:r>
+              <a:rPr sz="1875" b="0">
+                <a:solidFill>
+                  <a:srgbClr val="506367"/>
+                </a:solidFill>
+                <a:latin typeface="Arial"/>
+                <a:ea typeface="Arial"/>
+                <a:cs typeface="Arial"/>
+              </a:rPr>
+              <a:t>Revisión de despachos frente al nivel seguro de llenado</a:t>
+            </a:r>
+          </a:p>
+        </p:txBody>
+      </p:sp>
+      <p:pic>
+        <p:nvPicPr>
+          <p:cNvPr id="3" name="">
+            <a:extLst xmlns:a="http://schemas.openxmlformats.org/drawingml/2006/main">
+              <a:ext uri="{FF2B5EF4-FFF2-40B4-BE49-F238E27FC236}">
+                <a16:creationId xmlns:a16="http://schemas.microsoft.com/office/drawing/2014/main" id="{2A625277-BC68-4B32-BA6F-CD41E6EF254D}"/>
+              </a:ext>
+            </a:extLst>
+          </p:cNvPr>
+          <p:cNvPicPr>
+            <a:picLocks xmlns:a="http://schemas.openxmlformats.org/drawingml/2006/main" noChangeAspect="1"/>
+          </p:cNvPicPr>
+          <p:nvPr/>
+        </p:nvPicPr>
+        <p:blipFill>
+          <a:blip xmlns:r="http://schemas.openxmlformats.org/officeDocument/2006/relationships" xmlns:a="http://schemas.openxmlformats.org/drawingml/2006/main" r:embed="R832afe34af9d4ffd"/>
+          <a:stretch xmlns:a="http://schemas.openxmlformats.org/drawingml/2006/main"/>
+        </p:blipFill>
+        <p:spPr>
+          <a:xfrm xmlns:a="http://schemas.openxmlformats.org/drawingml/2006/main">
+            <a:off x="2773680" y="1885950"/>
+            <a:ext cx="6644640" cy="4152900"/>
+          </a:xfrm>
+          <a:prstGeom xmlns:a="http://schemas.openxmlformats.org/drawingml/2006/main" prst="rect">
+            <a:avLst/>
+          </a:prstGeom>
+        </p:spPr>
+      </p:pic>
+      <p:sp>
+        <p:nvSpPr>
+          <p:cNvPr id="4" name="appendix-text-11">
+            <a:extLst xmlns:a="http://schemas.openxmlformats.org/drawingml/2006/main">
+              <a:ext uri="{FF2B5EF4-FFF2-40B4-BE49-F238E27FC236}">
+                <a16:creationId xmlns:a16="http://schemas.microsoft.com/office/drawing/2014/main" id="{41804B81-DF94-4C89-AC22-1F330AAB58CE}"/>
+              </a:ext>
+            </a:extLst>
+          </p:cNvPr>
+          <p:cNvSpPr>
+            <a:spLocks xmlns:a="http://schemas.openxmlformats.org/drawingml/2006/main" noGrp="1"/>
+          </p:cNvSpPr>
+          <p:nvPr/>
+        </p:nvSpPr>
+        <p:spPr>
+          <a:xfrm xmlns:a="http://schemas.openxmlformats.org/drawingml/2006/main">
+            <a:off x="685800" y="6191250"/>
+            <a:ext cx="9906000" cy="266700"/>
+          </a:xfrm>
+          <a:prstGeom xmlns:a="http://schemas.openxmlformats.org/drawingml/2006/main" prst="rect">
+            <a:avLst/>
+          </a:prstGeom>
+          <a:noFill xmlns:a="http://schemas.openxmlformats.org/drawingml/2006/main"/>
+          <a:ln xmlns:a="http://schemas.openxmlformats.org/drawingml/2006/main" w="0">
+            <a:noFill/>
+          </a:ln>
+        </p:spPr>
+        <p:txBody>
+          <a:bodyPr xmlns:a="http://schemas.openxmlformats.org/drawingml/2006/main" wrap="square" lIns="0" tIns="0" rIns="0" bIns="0" anchor="t">
+            <a:noAutofit/>
+          </a:bodyPr>
+          <a:lstStyle xmlns:a="http://schemas.openxmlformats.org/drawingml/2006/main">
+            <a:defPPr algn="l">
+              <a:defRPr sz="1575" b="0">
+                <a:solidFill>
+                  <a:srgbClr val="506367"/>
+                </a:solidFill>
+                <a:latin typeface="Arial"/>
+                <a:ea typeface="Arial"/>
+                <a:cs typeface="Arial"/>
+              </a:defRPr>
+            </a:defPPr>
+          </a:lstStyle>
+          <a:p xmlns:a="http://schemas.openxmlformats.org/drawingml/2006/main">
+            <a:pPr algn="l">
+              <a:defRPr sz="1575" b="0">
+                <a:solidFill>
+                  <a:srgbClr val="506367"/>
+                </a:solidFill>
+                <a:latin typeface="Arial"/>
+                <a:ea typeface="Arial"/>
+                <a:cs typeface="Arial"/>
+              </a:defRPr>
+            </a:pPr>
+            <a:r>
+              <a:rPr sz="1575" b="0">
+                <a:solidFill>
+                  <a:srgbClr val="506367"/>
+                </a:solidFill>
+                <a:latin typeface="Arial"/>
+                <a:ea typeface="Arial"/>
+                <a:cs typeface="Arial"/>
+              </a:rPr>
+              <a:t>Interfaz original funcionando con datos 100% sintéticos</a:t>
+            </a:r>
+          </a:p>
+        </p:txBody>
+      </p:sp>
+      <p:sp>
+        <p:nvSpPr>
+          <p:cNvPr id="5" name="appendix-text-12">
+            <a:extLst xmlns:a="http://schemas.openxmlformats.org/drawingml/2006/main">
+              <a:ext uri="{FF2B5EF4-FFF2-40B4-BE49-F238E27FC236}">
+                <a16:creationId xmlns:a16="http://schemas.microsoft.com/office/drawing/2014/main" id="{F3A89374-2DC6-413B-B410-B27C317D0034}"/>
+              </a:ext>
+            </a:extLst>
+          </p:cNvPr>
+          <p:cNvSpPr>
+            <a:spLocks xmlns:a="http://schemas.openxmlformats.org/drawingml/2006/main" noGrp="1"/>
+          </p:cNvSpPr>
+          <p:nvPr/>
+        </p:nvSpPr>
+        <p:spPr>
+          <a:xfrm xmlns:a="http://schemas.openxmlformats.org/drawingml/2006/main">
+            <a:off x="10953750" y="6286500"/>
+            <a:ext cx="552450" cy="266700"/>
+          </a:xfrm>
+          <a:prstGeom xmlns:a="http://schemas.openxmlformats.org/drawingml/2006/main" prst="rect">
+            <a:avLst/>
+          </a:prstGeom>
+          <a:noFill xmlns:a="http://schemas.openxmlformats.org/drawingml/2006/main"/>
+          <a:ln xmlns:a="http://schemas.openxmlformats.org/drawingml/2006/main" w="0">
+            <a:noFill/>
+          </a:ln>
+        </p:spPr>
+        <p:txBody>
+          <a:bodyPr xmlns:a="http://schemas.openxmlformats.org/drawingml/2006/main" wrap="square" lIns="0" tIns="0" rIns="0" bIns="0" anchor="t">
+            <a:noAutofit/>
+          </a:bodyPr>
+          <a:lstStyle xmlns:a="http://schemas.openxmlformats.org/drawingml/2006/main">
+            <a:defPPr algn="r">
+              <a:defRPr sz="1500" b="0">
+                <a:solidFill>
+                  <a:srgbClr val="506367"/>
+                </a:solidFill>
+                <a:latin typeface="Arial"/>
+                <a:ea typeface="Arial"/>
+                <a:cs typeface="Arial"/>
+              </a:defRPr>
+            </a:defPPr>
+          </a:lstStyle>
+          <a:p xmlns:a="http://schemas.openxmlformats.org/drawingml/2006/main">
+            <a:pPr algn="r">
+              <a:defRPr sz="1500" b="0">
+                <a:solidFill>
+                  <a:srgbClr val="506367"/>
+                </a:solidFill>
+                <a:latin typeface="Arial"/>
+                <a:ea typeface="Arial"/>
+                <a:cs typeface="Arial"/>
+              </a:defRPr>
+            </a:pPr>
+            <a:r>
+              <a:rPr sz="1500" b="0">
+                <a:solidFill>
+                  <a:srgbClr val="506367"/>
+                </a:solidFill>
+                <a:latin typeface="Arial"/>
+                <a:ea typeface="Arial"/>
+                <a:cs typeface="Arial"/>
+              </a:rPr>
+              <a:t>16</a:t>
+            </a:r>
+          </a:p>
+        </p:txBody>
+      </p:sp>
+    </p:spTree>
+    <p:extLst>
+      <p:ext uri="{BB962C8B-B14F-4D97-AF65-F5344CB8AC3E}">
+        <p14:creationId xmlns:p14="http://schemas.microsoft.com/office/powerpoint/2010/main" val="375406643"/>
+      </p:ext>
+    </p:extLst>
+  </p:cSld>
+</p:sld>
+</file>
+
+<file path=ppt/slides/slide17.xml><?xml version="1.0" encoding="utf-8"?>
+<p:sld xmlns:p="http://schemas.openxmlformats.org/presentationml/2006/main">
+  <p:cSld>
+    <p:bg>
+      <p:bgPr>
+        <a:solidFill xmlns:a="http://schemas.openxmlformats.org/drawingml/2006/main">
+          <a:srgbClr val="F6F3EB"/>
+        </a:solidFill>
+      </p:bgPr>
+    </p:bg>
+    <p:spTree>
+      <p:nvGrpSpPr>
+        <p:cNvPr id="1" name=""/>
+        <p:cNvGrpSpPr/>
+        <p:nvPr/>
+      </p:nvGrpSpPr>
+      <p:grpSpPr>
+        <a:xfrm xmlns:a="http://schemas.openxmlformats.org/drawingml/2006/main"/>
+      </p:grpSpPr>
+      <p:sp>
+        <p:nvSpPr>
+          <p:cNvPr id="6" name="appendix-text-13">
+            <a:extLst xmlns:a="http://schemas.openxmlformats.org/drawingml/2006/main">
+              <a:ext uri="{FF2B5EF4-FFF2-40B4-BE49-F238E27FC236}">
+                <a16:creationId xmlns:a16="http://schemas.microsoft.com/office/drawing/2014/main" id="{32B65665-1DA7-4F73-8561-35C06DAE42D5}"/>
+              </a:ext>
+            </a:extLst>
+          </p:cNvPr>
+          <p:cNvSpPr>
+            <a:spLocks xmlns:a="http://schemas.openxmlformats.org/drawingml/2006/main" noGrp="1"/>
+          </p:cNvSpPr>
+          <p:nvPr/>
+        </p:nvSpPr>
+        <p:spPr>
+          <a:xfrm xmlns:a="http://schemas.openxmlformats.org/drawingml/2006/main">
+            <a:off x="685800" y="514350"/>
+            <a:ext cx="10820400" cy="838200"/>
+          </a:xfrm>
+          <a:prstGeom xmlns:a="http://schemas.openxmlformats.org/drawingml/2006/main" prst="rect">
+            <a:avLst/>
+          </a:prstGeom>
+          <a:noFill xmlns:a="http://schemas.openxmlformats.org/drawingml/2006/main"/>
+          <a:ln xmlns:a="http://schemas.openxmlformats.org/drawingml/2006/main" w="0">
+            <a:noFill/>
+          </a:ln>
+        </p:spPr>
+        <p:txBody>
+          <a:bodyPr xmlns:a="http://schemas.openxmlformats.org/drawingml/2006/main" wrap="square" lIns="0" tIns="0" rIns="0" bIns="0" anchor="t">
+            <a:noAutofit/>
+          </a:bodyPr>
+          <a:lstStyle xmlns:a="http://schemas.openxmlformats.org/drawingml/2006/main">
+            <a:defPPr algn="l">
+              <a:defRPr sz="3600" b="1">
+                <a:solidFill>
+                  <a:srgbClr val="0D292E"/>
+                </a:solidFill>
+                <a:latin typeface="Arial"/>
+                <a:ea typeface="Arial"/>
+                <a:cs typeface="Arial"/>
+              </a:defRPr>
+            </a:defPPr>
+          </a:lstStyle>
+          <a:p xmlns:a="http://schemas.openxmlformats.org/drawingml/2006/main">
+            <a:pPr algn="l">
+              <a:defRPr sz="3600" b="1">
+                <a:solidFill>
+                  <a:srgbClr val="0D292E"/>
+                </a:solidFill>
+                <a:latin typeface="Arial"/>
+                <a:ea typeface="Arial"/>
+                <a:cs typeface="Arial"/>
+              </a:defRPr>
+            </a:pPr>
+            <a:r>
+              <a:rPr sz="3600" b="1">
+                <a:solidFill>
+                  <a:srgbClr val="0D292E"/>
+                </a:solidFill>
+                <a:latin typeface="Arial"/>
+                <a:ea typeface="Arial"/>
+                <a:cs typeface="Arial"/>
+              </a:rPr>
+              <a:t>Sweeper &amp; Mop</a:t>
+            </a:r>
+          </a:p>
+        </p:txBody>
+      </p:sp>
+      <p:sp>
+        <p:nvSpPr>
+          <p:cNvPr id="2" name="appendix-text-14">
+            <a:extLst xmlns:a="http://schemas.openxmlformats.org/drawingml/2006/main">
+              <a:ext uri="{FF2B5EF4-FFF2-40B4-BE49-F238E27FC236}">
+                <a16:creationId xmlns:a16="http://schemas.microsoft.com/office/drawing/2014/main" id="{63D3F940-4C1D-40A3-AB12-EAD39AEAAEB2}"/>
+              </a:ext>
+            </a:extLst>
+          </p:cNvPr>
+          <p:cNvSpPr>
+            <a:spLocks xmlns:a="http://schemas.openxmlformats.org/drawingml/2006/main" noGrp="1"/>
+          </p:cNvSpPr>
+          <p:nvPr/>
+        </p:nvSpPr>
+        <p:spPr>
+          <a:xfrm xmlns:a="http://schemas.openxmlformats.org/drawingml/2006/main">
+            <a:off x="685800" y="1381125"/>
+            <a:ext cx="10820400" cy="457200"/>
+          </a:xfrm>
+          <a:prstGeom xmlns:a="http://schemas.openxmlformats.org/drawingml/2006/main" prst="rect">
+            <a:avLst/>
+          </a:prstGeom>
+          <a:noFill xmlns:a="http://schemas.openxmlformats.org/drawingml/2006/main"/>
+          <a:ln xmlns:a="http://schemas.openxmlformats.org/drawingml/2006/main" w="0">
+            <a:noFill/>
+          </a:ln>
+        </p:spPr>
+        <p:txBody>
+          <a:bodyPr xmlns:a="http://schemas.openxmlformats.org/drawingml/2006/main" wrap="square" lIns="0" tIns="0" rIns="0" bIns="0" anchor="t">
+            <a:noAutofit/>
+          </a:bodyPr>
+          <a:lstStyle xmlns:a="http://schemas.openxmlformats.org/drawingml/2006/main">
+            <a:defPPr algn="l">
+              <a:defRPr sz="1875" b="0">
+                <a:solidFill>
+                  <a:srgbClr val="506367"/>
+                </a:solidFill>
+                <a:latin typeface="Arial"/>
+                <a:ea typeface="Arial"/>
+                <a:cs typeface="Arial"/>
+              </a:defRPr>
+            </a:defPPr>
+          </a:lstStyle>
+          <a:p xmlns:a="http://schemas.openxmlformats.org/drawingml/2006/main">
+            <a:pPr algn="l">
+              <a:defRPr sz="1875" b="0">
+                <a:solidFill>
+                  <a:srgbClr val="506367"/>
+                </a:solidFill>
+                <a:latin typeface="Arial"/>
+                <a:ea typeface="Arial"/>
+                <a:cs typeface="Arial"/>
+              </a:defRPr>
+            </a:pPr>
+            <a:r>
+              <a:rPr sz="1875" b="0">
+                <a:solidFill>
+                  <a:srgbClr val="506367"/>
+                </a:solidFill>
+                <a:latin typeface="Arial"/>
+                <a:ea typeface="Arial"/>
+                <a:cs typeface="Arial"/>
+              </a:rPr>
+              <a:t>Detección de incoherencias y propuestas de corrección</a:t>
+            </a:r>
+          </a:p>
+        </p:txBody>
+      </p:sp>
+      <p:pic>
+        <p:nvPicPr>
+          <p:cNvPr id="3" name="">
+            <a:extLst xmlns:a="http://schemas.openxmlformats.org/drawingml/2006/main">
+              <a:ext uri="{FF2B5EF4-FFF2-40B4-BE49-F238E27FC236}">
+                <a16:creationId xmlns:a16="http://schemas.microsoft.com/office/drawing/2014/main" id="{F33578D2-51F8-43D2-9843-A313973472C0}"/>
+              </a:ext>
+            </a:extLst>
+          </p:cNvPr>
+          <p:cNvPicPr>
+            <a:picLocks xmlns:a="http://schemas.openxmlformats.org/drawingml/2006/main" noChangeAspect="1"/>
+          </p:cNvPicPr>
+          <p:nvPr/>
+        </p:nvPicPr>
+        <p:blipFill>
+          <a:blip xmlns:r="http://schemas.openxmlformats.org/officeDocument/2006/relationships" xmlns:a="http://schemas.openxmlformats.org/drawingml/2006/main" r:embed="R7013174ecc874dde"/>
+          <a:stretch xmlns:a="http://schemas.openxmlformats.org/drawingml/2006/main"/>
+        </p:blipFill>
+        <p:spPr>
+          <a:xfrm xmlns:a="http://schemas.openxmlformats.org/drawingml/2006/main">
+            <a:off x="2773680" y="1885950"/>
+            <a:ext cx="6644640" cy="4152900"/>
+          </a:xfrm>
+          <a:prstGeom xmlns:a="http://schemas.openxmlformats.org/drawingml/2006/main" prst="rect">
+            <a:avLst/>
+          </a:prstGeom>
+        </p:spPr>
+      </p:pic>
+      <p:sp>
+        <p:nvSpPr>
+          <p:cNvPr id="4" name="appendix-text-15">
+            <a:extLst xmlns:a="http://schemas.openxmlformats.org/drawingml/2006/main">
+              <a:ext uri="{FF2B5EF4-FFF2-40B4-BE49-F238E27FC236}">
+                <a16:creationId xmlns:a16="http://schemas.microsoft.com/office/drawing/2014/main" id="{6310A7D4-7FBA-4494-A1FD-D24EBF2DAD30}"/>
+              </a:ext>
+            </a:extLst>
+          </p:cNvPr>
+          <p:cNvSpPr>
+            <a:spLocks xmlns:a="http://schemas.openxmlformats.org/drawingml/2006/main" noGrp="1"/>
+          </p:cNvSpPr>
+          <p:nvPr/>
+        </p:nvSpPr>
+        <p:spPr>
+          <a:xfrm xmlns:a="http://schemas.openxmlformats.org/drawingml/2006/main">
+            <a:off x="685800" y="6191250"/>
+            <a:ext cx="9906000" cy="266700"/>
+          </a:xfrm>
+          <a:prstGeom xmlns:a="http://schemas.openxmlformats.org/drawingml/2006/main" prst="rect">
+            <a:avLst/>
+          </a:prstGeom>
+          <a:noFill xmlns:a="http://schemas.openxmlformats.org/drawingml/2006/main"/>
+          <a:ln xmlns:a="http://schemas.openxmlformats.org/drawingml/2006/main" w="0">
+            <a:noFill/>
+          </a:ln>
+        </p:spPr>
+        <p:txBody>
+          <a:bodyPr xmlns:a="http://schemas.openxmlformats.org/drawingml/2006/main" wrap="square" lIns="0" tIns="0" rIns="0" bIns="0" anchor="t">
+            <a:noAutofit/>
+          </a:bodyPr>
+          <a:lstStyle xmlns:a="http://schemas.openxmlformats.org/drawingml/2006/main">
+            <a:defPPr algn="l">
+              <a:defRPr sz="1575" b="0">
+                <a:solidFill>
+                  <a:srgbClr val="506367"/>
+                </a:solidFill>
+                <a:latin typeface="Arial"/>
+                <a:ea typeface="Arial"/>
+                <a:cs typeface="Arial"/>
+              </a:defRPr>
+            </a:defPPr>
+          </a:lstStyle>
+          <a:p xmlns:a="http://schemas.openxmlformats.org/drawingml/2006/main">
+            <a:pPr algn="l">
+              <a:defRPr sz="1575" b="0">
+                <a:solidFill>
+                  <a:srgbClr val="506367"/>
+                </a:solidFill>
+                <a:latin typeface="Arial"/>
+                <a:ea typeface="Arial"/>
+                <a:cs typeface="Arial"/>
+              </a:defRPr>
+            </a:pPr>
+            <a:r>
+              <a:rPr sz="1575" b="0">
+                <a:solidFill>
+                  <a:srgbClr val="506367"/>
+                </a:solidFill>
+                <a:latin typeface="Arial"/>
+                <a:ea typeface="Arial"/>
+                <a:cs typeface="Arial"/>
+              </a:rPr>
+              <a:t>Interfaz original funcionando con datos 100% sintéticos</a:t>
+            </a:r>
+          </a:p>
+        </p:txBody>
+      </p:sp>
+      <p:sp>
+        <p:nvSpPr>
+          <p:cNvPr id="5" name="appendix-text-16">
+            <a:extLst xmlns:a="http://schemas.openxmlformats.org/drawingml/2006/main">
+              <a:ext uri="{FF2B5EF4-FFF2-40B4-BE49-F238E27FC236}">
+                <a16:creationId xmlns:a16="http://schemas.microsoft.com/office/drawing/2014/main" id="{95968312-1658-4783-887F-EB5477802E28}"/>
+              </a:ext>
+            </a:extLst>
+          </p:cNvPr>
+          <p:cNvSpPr>
+            <a:spLocks xmlns:a="http://schemas.openxmlformats.org/drawingml/2006/main" noGrp="1"/>
+          </p:cNvSpPr>
+          <p:nvPr/>
+        </p:nvSpPr>
+        <p:spPr>
+          <a:xfrm xmlns:a="http://schemas.openxmlformats.org/drawingml/2006/main">
+            <a:off x="10953750" y="6286500"/>
+            <a:ext cx="552450" cy="266700"/>
+          </a:xfrm>
+          <a:prstGeom xmlns:a="http://schemas.openxmlformats.org/drawingml/2006/main" prst="rect">
+            <a:avLst/>
+          </a:prstGeom>
+          <a:noFill xmlns:a="http://schemas.openxmlformats.org/drawingml/2006/main"/>
+          <a:ln xmlns:a="http://schemas.openxmlformats.org/drawingml/2006/main" w="0">
+            <a:noFill/>
+          </a:ln>
+        </p:spPr>
+        <p:txBody>
+          <a:bodyPr xmlns:a="http://schemas.openxmlformats.org/drawingml/2006/main" wrap="square" lIns="0" tIns="0" rIns="0" bIns="0" anchor="t">
+            <a:noAutofit/>
+          </a:bodyPr>
+          <a:lstStyle xmlns:a="http://schemas.openxmlformats.org/drawingml/2006/main">
+            <a:defPPr algn="r">
+              <a:defRPr sz="1500" b="0">
+                <a:solidFill>
+                  <a:srgbClr val="506367"/>
+                </a:solidFill>
+                <a:latin typeface="Arial"/>
+                <a:ea typeface="Arial"/>
+                <a:cs typeface="Arial"/>
+              </a:defRPr>
+            </a:defPPr>
+          </a:lstStyle>
+          <a:p xmlns:a="http://schemas.openxmlformats.org/drawingml/2006/main">
+            <a:pPr algn="r">
+              <a:defRPr sz="1500" b="0">
+                <a:solidFill>
+                  <a:srgbClr val="506367"/>
+                </a:solidFill>
+                <a:latin typeface="Arial"/>
+                <a:ea typeface="Arial"/>
+                <a:cs typeface="Arial"/>
+              </a:defRPr>
+            </a:pPr>
+            <a:r>
+              <a:rPr sz="1500" b="0">
+                <a:solidFill>
+                  <a:srgbClr val="506367"/>
+                </a:solidFill>
+                <a:latin typeface="Arial"/>
+                <a:ea typeface="Arial"/>
+                <a:cs typeface="Arial"/>
+              </a:rPr>
+              <a:t>17</a:t>
+            </a:r>
+          </a:p>
+        </p:txBody>
+      </p:sp>
+    </p:spTree>
+    <p:extLst>
+      <p:ext uri="{BB962C8B-B14F-4D97-AF65-F5344CB8AC3E}">
+        <p14:creationId xmlns:p14="http://schemas.microsoft.com/office/powerpoint/2010/main" val="436783925"/>
+      </p:ext>
+    </p:extLst>
+  </p:cSld>
+</p:sld>
+</file>
+
+<file path=ppt/slides/slide18.xml><?xml version="1.0" encoding="utf-8"?>
+<p:sld xmlns:p="http://schemas.openxmlformats.org/presentationml/2006/main">
+  <p:cSld>
+    <p:bg>
+      <p:bgPr>
+        <a:solidFill xmlns:a="http://schemas.openxmlformats.org/drawingml/2006/main">
+          <a:srgbClr val="F6F3EB"/>
+        </a:solidFill>
+      </p:bgPr>
+    </p:bg>
+    <p:spTree>
+      <p:nvGrpSpPr>
+        <p:cNvPr id="1" name=""/>
+        <p:cNvGrpSpPr/>
+        <p:nvPr/>
+      </p:nvGrpSpPr>
+      <p:grpSpPr>
+        <a:xfrm xmlns:a="http://schemas.openxmlformats.org/drawingml/2006/main"/>
+      </p:grpSpPr>
+      <p:sp>
+        <p:nvSpPr>
+          <p:cNvPr id="6" name="appendix-text-17">
+            <a:extLst xmlns:a="http://schemas.openxmlformats.org/drawingml/2006/main">
+              <a:ext uri="{FF2B5EF4-FFF2-40B4-BE49-F238E27FC236}">
+                <a16:creationId xmlns:a16="http://schemas.microsoft.com/office/drawing/2014/main" id="{2AF6316C-DEC2-478C-94C0-18767261D475}"/>
+              </a:ext>
+            </a:extLst>
+          </p:cNvPr>
+          <p:cNvSpPr>
+            <a:spLocks xmlns:a="http://schemas.openxmlformats.org/drawingml/2006/main" noGrp="1"/>
+          </p:cNvSpPr>
+          <p:nvPr/>
+        </p:nvSpPr>
+        <p:spPr>
+          <a:xfrm xmlns:a="http://schemas.openxmlformats.org/drawingml/2006/main">
+            <a:off x="685800" y="514350"/>
+            <a:ext cx="10820400" cy="838200"/>
+          </a:xfrm>
+          <a:prstGeom xmlns:a="http://schemas.openxmlformats.org/drawingml/2006/main" prst="rect">
+            <a:avLst/>
+          </a:prstGeom>
+          <a:noFill xmlns:a="http://schemas.openxmlformats.org/drawingml/2006/main"/>
+          <a:ln xmlns:a="http://schemas.openxmlformats.org/drawingml/2006/main" w="0">
+            <a:noFill/>
+          </a:ln>
+        </p:spPr>
+        <p:txBody>
+          <a:bodyPr xmlns:a="http://schemas.openxmlformats.org/drawingml/2006/main" wrap="square" lIns="0" tIns="0" rIns="0" bIns="0" anchor="t">
+            <a:noAutofit/>
+          </a:bodyPr>
+          <a:lstStyle xmlns:a="http://schemas.openxmlformats.org/drawingml/2006/main">
+            <a:defPPr algn="l">
+              <a:defRPr sz="3600" b="1">
+                <a:solidFill>
+                  <a:srgbClr val="0D292E"/>
+                </a:solidFill>
+                <a:latin typeface="Arial"/>
+                <a:ea typeface="Arial"/>
+                <a:cs typeface="Arial"/>
+              </a:defRPr>
+            </a:defPPr>
+          </a:lstStyle>
+          <a:p xmlns:a="http://schemas.openxmlformats.org/drawingml/2006/main">
+            <a:pPr algn="l">
+              <a:defRPr sz="3600" b="1">
+                <a:solidFill>
+                  <a:srgbClr val="0D292E"/>
+                </a:solidFill>
+                <a:latin typeface="Arial"/>
+                <a:ea typeface="Arial"/>
+                <a:cs typeface="Arial"/>
+              </a:defRPr>
+            </a:pPr>
+            <a:r>
+              <a:rPr sz="3600" b="1">
+                <a:solidFill>
+                  <a:srgbClr val="0D292E"/>
+                </a:solidFill>
+                <a:latin typeface="Arial"/>
+                <a:ea typeface="Arial"/>
+                <a:cs typeface="Arial"/>
+              </a:rPr>
+              <a:t>HMI Tank</a:t>
+            </a:r>
+          </a:p>
+        </p:txBody>
+      </p:sp>
+      <p:sp>
+        <p:nvSpPr>
+          <p:cNvPr id="2" name="appendix-text-18">
+            <a:extLst xmlns:a="http://schemas.openxmlformats.org/drawingml/2006/main">
+              <a:ext uri="{FF2B5EF4-FFF2-40B4-BE49-F238E27FC236}">
+                <a16:creationId xmlns:a16="http://schemas.microsoft.com/office/drawing/2014/main" id="{69D9CC76-0764-460A-B08F-A12E3EF04D15}"/>
+              </a:ext>
+            </a:extLst>
+          </p:cNvPr>
+          <p:cNvSpPr>
+            <a:spLocks xmlns:a="http://schemas.openxmlformats.org/drawingml/2006/main" noGrp="1"/>
+          </p:cNvSpPr>
+          <p:nvPr/>
+        </p:nvSpPr>
+        <p:spPr>
+          <a:xfrm xmlns:a="http://schemas.openxmlformats.org/drawingml/2006/main">
+            <a:off x="685800" y="1381125"/>
+            <a:ext cx="10820400" cy="457200"/>
+          </a:xfrm>
+          <a:prstGeom xmlns:a="http://schemas.openxmlformats.org/drawingml/2006/main" prst="rect">
+            <a:avLst/>
+          </a:prstGeom>
+          <a:noFill xmlns:a="http://schemas.openxmlformats.org/drawingml/2006/main"/>
+          <a:ln xmlns:a="http://schemas.openxmlformats.org/drawingml/2006/main" w="0">
+            <a:noFill/>
+          </a:ln>
+        </p:spPr>
+        <p:txBody>
+          <a:bodyPr xmlns:a="http://schemas.openxmlformats.org/drawingml/2006/main" wrap="square" lIns="0" tIns="0" rIns="0" bIns="0" anchor="t">
+            <a:noAutofit/>
+          </a:bodyPr>
+          <a:lstStyle xmlns:a="http://schemas.openxmlformats.org/drawingml/2006/main">
+            <a:defPPr algn="l">
+              <a:defRPr sz="1875" b="0">
+                <a:solidFill>
+                  <a:srgbClr val="506367"/>
+                </a:solidFill>
+                <a:latin typeface="Arial"/>
+                <a:ea typeface="Arial"/>
+                <a:cs typeface="Arial"/>
+              </a:defRPr>
+            </a:defPPr>
+          </a:lstStyle>
+          <a:p xmlns:a="http://schemas.openxmlformats.org/drawingml/2006/main">
+            <a:pPr algn="l">
+              <a:defRPr sz="1875" b="0">
+                <a:solidFill>
+                  <a:srgbClr val="506367"/>
+                </a:solidFill>
+                <a:latin typeface="Arial"/>
+                <a:ea typeface="Arial"/>
+                <a:cs typeface="Arial"/>
+              </a:defRPr>
+            </a:pPr>
+            <a:r>
+              <a:rPr sz="1875" b="0">
+                <a:solidFill>
+                  <a:srgbClr val="506367"/>
+                </a:solidFill>
+                <a:latin typeface="Arial"/>
+                <a:ea typeface="Arial"/>
+                <a:cs typeface="Arial"/>
+              </a:rPr>
+              <a:t>Niveles, movimientos y conciliación de combustible</a:t>
+            </a:r>
+          </a:p>
+        </p:txBody>
+      </p:sp>
+      <p:pic>
+        <p:nvPicPr>
+          <p:cNvPr id="3" name="">
+            <a:extLst xmlns:a="http://schemas.openxmlformats.org/drawingml/2006/main">
+              <a:ext uri="{FF2B5EF4-FFF2-40B4-BE49-F238E27FC236}">
+                <a16:creationId xmlns:a16="http://schemas.microsoft.com/office/drawing/2014/main" id="{A811E6F3-1C53-4C2F-A47F-AA18454F120D}"/>
+              </a:ext>
+            </a:extLst>
+          </p:cNvPr>
+          <p:cNvPicPr>
+            <a:picLocks xmlns:a="http://schemas.openxmlformats.org/drawingml/2006/main" noChangeAspect="1"/>
+          </p:cNvPicPr>
+          <p:nvPr/>
+        </p:nvPicPr>
+        <p:blipFill>
+          <a:blip xmlns:r="http://schemas.openxmlformats.org/officeDocument/2006/relationships" xmlns:a="http://schemas.openxmlformats.org/drawingml/2006/main" r:embed="Rae1c9bd513e84435"/>
+          <a:stretch xmlns:a="http://schemas.openxmlformats.org/drawingml/2006/main"/>
+        </p:blipFill>
+        <p:spPr>
+          <a:xfrm xmlns:a="http://schemas.openxmlformats.org/drawingml/2006/main">
+            <a:off x="3250161" y="1885950"/>
+            <a:ext cx="5691678" cy="4152900"/>
+          </a:xfrm>
+          <a:prstGeom xmlns:a="http://schemas.openxmlformats.org/drawingml/2006/main" prst="rect">
+            <a:avLst/>
+          </a:prstGeom>
+        </p:spPr>
+      </p:pic>
+      <p:sp>
+        <p:nvSpPr>
+          <p:cNvPr id="4" name="appendix-text-19">
+            <a:extLst xmlns:a="http://schemas.openxmlformats.org/drawingml/2006/main">
+              <a:ext uri="{FF2B5EF4-FFF2-40B4-BE49-F238E27FC236}">
+                <a16:creationId xmlns:a16="http://schemas.microsoft.com/office/drawing/2014/main" id="{B215D9E8-91AC-448B-8A5F-2FA74AA0033E}"/>
+              </a:ext>
+            </a:extLst>
+          </p:cNvPr>
+          <p:cNvSpPr>
+            <a:spLocks xmlns:a="http://schemas.openxmlformats.org/drawingml/2006/main" noGrp="1"/>
+          </p:cNvSpPr>
+          <p:nvPr/>
+        </p:nvSpPr>
+        <p:spPr>
+          <a:xfrm xmlns:a="http://schemas.openxmlformats.org/drawingml/2006/main">
+            <a:off x="685800" y="6191250"/>
+            <a:ext cx="9906000" cy="266700"/>
+          </a:xfrm>
+          <a:prstGeom xmlns:a="http://schemas.openxmlformats.org/drawingml/2006/main" prst="rect">
+            <a:avLst/>
+          </a:prstGeom>
+          <a:noFill xmlns:a="http://schemas.openxmlformats.org/drawingml/2006/main"/>
+          <a:ln xmlns:a="http://schemas.openxmlformats.org/drawingml/2006/main" w="0">
+            <a:noFill/>
+          </a:ln>
+        </p:spPr>
+        <p:txBody>
+          <a:bodyPr xmlns:a="http://schemas.openxmlformats.org/drawingml/2006/main" wrap="square" lIns="0" tIns="0" rIns="0" bIns="0" anchor="t">
+            <a:noAutofit/>
+          </a:bodyPr>
+          <a:lstStyle xmlns:a="http://schemas.openxmlformats.org/drawingml/2006/main">
+            <a:defPPr algn="l">
+              <a:defRPr sz="1575" b="0">
+                <a:solidFill>
+                  <a:srgbClr val="506367"/>
+                </a:solidFill>
+                <a:latin typeface="Arial"/>
+                <a:ea typeface="Arial"/>
+                <a:cs typeface="Arial"/>
+              </a:defRPr>
+            </a:defPPr>
+          </a:lstStyle>
+          <a:p xmlns:a="http://schemas.openxmlformats.org/drawingml/2006/main">
+            <a:pPr algn="l">
+              <a:defRPr sz="1575" b="0">
+                <a:solidFill>
+                  <a:srgbClr val="506367"/>
+                </a:solidFill>
+                <a:latin typeface="Arial"/>
+                <a:ea typeface="Arial"/>
+                <a:cs typeface="Arial"/>
+              </a:defRPr>
+            </a:pPr>
+            <a:r>
+              <a:rPr sz="1575" b="0">
+                <a:solidFill>
+                  <a:srgbClr val="506367"/>
+                </a:solidFill>
+                <a:latin typeface="Arial"/>
+                <a:ea typeface="Arial"/>
+                <a:cs typeface="Arial"/>
+              </a:rPr>
+              <a:t>Interfaz original funcionando con datos 100% sintéticos</a:t>
+            </a:r>
+          </a:p>
+        </p:txBody>
+      </p:sp>
+      <p:sp>
+        <p:nvSpPr>
+          <p:cNvPr id="5" name="appendix-text-20">
+            <a:extLst xmlns:a="http://schemas.openxmlformats.org/drawingml/2006/main">
+              <a:ext uri="{FF2B5EF4-FFF2-40B4-BE49-F238E27FC236}">
+                <a16:creationId xmlns:a16="http://schemas.microsoft.com/office/drawing/2014/main" id="{C35FEFB6-E7CC-4541-9FE0-9D2B9EE904BE}"/>
+              </a:ext>
+            </a:extLst>
+          </p:cNvPr>
+          <p:cNvSpPr>
+            <a:spLocks xmlns:a="http://schemas.openxmlformats.org/drawingml/2006/main" noGrp="1"/>
+          </p:cNvSpPr>
+          <p:nvPr/>
+        </p:nvSpPr>
+        <p:spPr>
+          <a:xfrm xmlns:a="http://schemas.openxmlformats.org/drawingml/2006/main">
+            <a:off x="10953750" y="6286500"/>
+            <a:ext cx="552450" cy="266700"/>
+          </a:xfrm>
+          <a:prstGeom xmlns:a="http://schemas.openxmlformats.org/drawingml/2006/main" prst="rect">
+            <a:avLst/>
+          </a:prstGeom>
+          <a:noFill xmlns:a="http://schemas.openxmlformats.org/drawingml/2006/main"/>
+          <a:ln xmlns:a="http://schemas.openxmlformats.org/drawingml/2006/main" w="0">
+            <a:noFill/>
+          </a:ln>
+        </p:spPr>
+        <p:txBody>
+          <a:bodyPr xmlns:a="http://schemas.openxmlformats.org/drawingml/2006/main" wrap="square" lIns="0" tIns="0" rIns="0" bIns="0" anchor="t">
+            <a:noAutofit/>
+          </a:bodyPr>
+          <a:lstStyle xmlns:a="http://schemas.openxmlformats.org/drawingml/2006/main">
+            <a:defPPr algn="r">
+              <a:defRPr sz="1500" b="0">
+                <a:solidFill>
+                  <a:srgbClr val="506367"/>
+                </a:solidFill>
+                <a:latin typeface="Arial"/>
+                <a:ea typeface="Arial"/>
+                <a:cs typeface="Arial"/>
+              </a:defRPr>
+            </a:defPPr>
+          </a:lstStyle>
+          <a:p xmlns:a="http://schemas.openxmlformats.org/drawingml/2006/main">
+            <a:pPr algn="r">
+              <a:defRPr sz="1500" b="0">
+                <a:solidFill>
+                  <a:srgbClr val="506367"/>
+                </a:solidFill>
+                <a:latin typeface="Arial"/>
+                <a:ea typeface="Arial"/>
+                <a:cs typeface="Arial"/>
+              </a:defRPr>
+            </a:pPr>
+            <a:r>
+              <a:rPr sz="1500" b="0">
+                <a:solidFill>
+                  <a:srgbClr val="506367"/>
+                </a:solidFill>
+                <a:latin typeface="Arial"/>
+                <a:ea typeface="Arial"/>
+                <a:cs typeface="Arial"/>
+              </a:rPr>
+              <a:t>18</a:t>
+            </a:r>
+          </a:p>
+        </p:txBody>
+      </p:sp>
+    </p:spTree>
+    <p:extLst>
+      <p:ext uri="{BB962C8B-B14F-4D97-AF65-F5344CB8AC3E}">
+        <p14:creationId xmlns:p14="http://schemas.microsoft.com/office/powerpoint/2010/main" val="846569595"/>
+      </p:ext>
+    </p:extLst>
+  </p:cSld>
+</p:sld>
+</file>
+
 <file path=ppt/slides/slide2.xml><?xml version="1.0" encoding="utf-8"?>
 <p:sld xmlns:p="http://schemas.openxmlformats.org/presentationml/2006/main">
   <p:cSld>

</xml_diff>

<commit_message>
Update PowerPoint education status and SENA programs
</commit_message>
<xml_diff>
--- a/materiales/Jose_David_Gomez_Diametral.pptx
+++ b/materiales/Jose_David_Gomez_Diametral.pptx
@@ -4,10 +4,12 @@
   <p:sldMasterIdLst>
     <p:sldMasterId xmlns:r="http://schemas.openxmlformats.org/officeDocument/2006/relationships" id="2147483648" r:id="R62417724679e43ae"/>
     <p:sldMasterId id="2147483649" r:id="rIdAppendixMaster0"/>
+    <p:sldMasterId id="2147483650" r:id="rIdEducationMaster0"/>
   </p:sldMasterIdLst>
   <p:sldIdLst>
     <p:sldId xmlns:r="http://schemas.openxmlformats.org/officeDocument/2006/relationships" id="256" r:id="R0d5a77deffe94144"/>
     <p:sldId xmlns:r="http://schemas.openxmlformats.org/officeDocument/2006/relationships" id="257" r:id="Rb5144a83c0fb42b1"/>
+    <p:sldId id="274" r:id="rIdEducationSlide"/>
     <p:sldId xmlns:r="http://schemas.openxmlformats.org/officeDocument/2006/relationships" id="258" r:id="Rbc683572738f4a36"/>
     <p:sldId xmlns:r="http://schemas.openxmlformats.org/officeDocument/2006/relationships" id="259" r:id="R212f26cda77c4ab8"/>
     <p:sldId xmlns:r="http://schemas.openxmlformats.org/officeDocument/2006/relationships" id="260" r:id="Rb64e8e6557a542e8"/>
@@ -2520,6 +2522,2496 @@
 </a:theme>
 </file>
 
+<file path=ppt/education/presProps.xml><?xml version="1.0" encoding="utf-8"?>
+<p:presentationPr xmlns:p="http://schemas.openxmlformats.org/presentationml/2006/main">
+  <p:extLst>
+    <p:ext xmlns:p14="http://schemas.microsoft.com/office/powerpoint/2010/main" uri="{E76CE94A-603C-4142-B9EB-6D1370010A27}">
+      <p14:discardImageEditData val="0"/>
+    </p:ext>
+    <p:ext xmlns:p14="http://schemas.microsoft.com/office/powerpoint/2010/main" uri="{D31A062A-798A-4329-ABDD-BBA856620510}">
+      <p14:defaultImageDpi val="32767"/>
+    </p:ext>
+    <p:ext xmlns:p15="http://schemas.microsoft.com/office/powerpoint/2012/main" uri="{FD5EFAAD-0ECE-453E-9831-46B23BE46B34}">
+      <p15:chartTrackingRefBased val="1"/>
+    </p:ext>
+  </p:extLst>
+</p:presentationPr>
+</file>
+
+<file path=ppt/education/slideLayouts/slideLayout1.xml><?xml version="1.0" encoding="utf-8"?>
+<p:sldLayout xmlns:p="http://schemas.openxmlformats.org/presentationml/2006/main" type="title">
+  <p:cSld name="Title Slide">
+    <p:spTree>
+      <p:nvGrpSpPr>
+        <p:cNvPr id="1" name=""/>
+        <p:cNvGrpSpPr/>
+        <p:nvPr/>
+      </p:nvGrpSpPr>
+      <p:grpSpPr>
+        <a:xfrm xmlns:a="http://schemas.openxmlformats.org/drawingml/2006/main"/>
+      </p:grpSpPr>
+      <p:sp>
+        <p:nvSpPr>
+          <p:cNvPr id="3" name="Title">
+            <a:extLst xmlns:a="http://schemas.openxmlformats.org/drawingml/2006/main">
+              <a:ext uri="{FF2B5EF4-FFF2-40B4-BE49-F238E27FC236}">
+                <a16:creationId xmlns:a16="http://schemas.microsoft.com/office/drawing/2014/main" id="{75ED4980-4B42-4C0E-A8D3-807DB82F432D}"/>
+              </a:ext>
+            </a:extLst>
+          </p:cNvPr>
+          <p:cNvSpPr>
+            <a:spLocks xmlns:a="http://schemas.openxmlformats.org/drawingml/2006/main" noGrp="1"/>
+          </p:cNvSpPr>
+          <p:nvPr>
+            <p:ph type="title" idx="0"/>
+          </p:nvPr>
+        </p:nvSpPr>
+        <p:spPr>
+          <a:xfrm xmlns:a="http://schemas.openxmlformats.org/drawingml/2006/main">
+            <a:off x="1219200" y="2590800"/>
+            <a:ext cx="9753600" cy="990600"/>
+          </a:xfrm>
+          <a:prstGeom xmlns:a="http://schemas.openxmlformats.org/drawingml/2006/main" prst="rect">
+            <a:avLst/>
+          </a:prstGeom>
+          <a:noFill xmlns:a="http://schemas.openxmlformats.org/drawingml/2006/main"/>
+          <a:ln xmlns:a="http://schemas.openxmlformats.org/drawingml/2006/main">
+            <a:noFill/>
+            <a:prstDash val="solid"/>
+          </a:ln>
+        </p:spPr>
+        <p:txBody>
+          <a:bodyPr xmlns:a="http://schemas.openxmlformats.org/drawingml/2006/main" wrap="square" lIns="0" tIns="0" rIns="0" bIns="0" anchor="ctr">
+            <a:normAutofit/>
+          </a:bodyPr>
+          <a:lstStyle xmlns:a="http://schemas.openxmlformats.org/drawingml/2006/main">
+            <a:defPPr algn="ctr">
+              <a:defRPr sz="4800" b="1">
+                <a:solidFill>
+                  <a:schemeClr val="tx1"/>
+                </a:solidFill>
+                <a:latin typeface="+mj-lt"/>
+                <a:ea typeface="+mj-lt"/>
+                <a:cs typeface="+mj-lt"/>
+              </a:defRPr>
+            </a:defPPr>
+            <a:lvl1pPr marL="0" indent="0">
+              <a:lnSpc>
+                <a:spcPct val="110000"/>
+              </a:lnSpc>
+              <a:spcBef>
+                <a:spcPts val="0"/>
+              </a:spcBef>
+              <a:spcAft>
+                <a:spcPts val="0"/>
+              </a:spcAft>
+              <a:buNone/>
+            </a:lvl1pPr>
+            <a:lvl2pPr marL="0" indent="0">
+              <a:lnSpc>
+                <a:spcPct val="110000"/>
+              </a:lnSpc>
+              <a:spcBef>
+                <a:spcPts val="0"/>
+              </a:spcBef>
+              <a:spcAft>
+                <a:spcPts val="0"/>
+              </a:spcAft>
+              <a:buNone/>
+            </a:lvl2pPr>
+            <a:lvl3pPr marL="0" indent="0">
+              <a:lnSpc>
+                <a:spcPct val="110000"/>
+              </a:lnSpc>
+              <a:spcBef>
+                <a:spcPts val="0"/>
+              </a:spcBef>
+              <a:spcAft>
+                <a:spcPts val="0"/>
+              </a:spcAft>
+              <a:buNone/>
+            </a:lvl3pPr>
+            <a:lvl4pPr marL="0" indent="0">
+              <a:lnSpc>
+                <a:spcPct val="110000"/>
+              </a:lnSpc>
+              <a:spcBef>
+                <a:spcPts val="0"/>
+              </a:spcBef>
+              <a:spcAft>
+                <a:spcPts val="0"/>
+              </a:spcAft>
+              <a:buNone/>
+            </a:lvl4pPr>
+            <a:lvl5pPr marL="0" indent="0">
+              <a:lnSpc>
+                <a:spcPct val="110000"/>
+              </a:lnSpc>
+              <a:spcBef>
+                <a:spcPts val="0"/>
+              </a:spcBef>
+              <a:spcAft>
+                <a:spcPts val="0"/>
+              </a:spcAft>
+              <a:buNone/>
+            </a:lvl5pPr>
+            <a:lvl6pPr marL="0" indent="0">
+              <a:lnSpc>
+                <a:spcPct val="110000"/>
+              </a:lnSpc>
+              <a:spcBef>
+                <a:spcPts val="0"/>
+              </a:spcBef>
+              <a:spcAft>
+                <a:spcPts val="0"/>
+              </a:spcAft>
+              <a:buNone/>
+            </a:lvl6pPr>
+            <a:lvl7pPr marL="0" indent="0">
+              <a:lnSpc>
+                <a:spcPct val="110000"/>
+              </a:lnSpc>
+              <a:spcBef>
+                <a:spcPts val="0"/>
+              </a:spcBef>
+              <a:spcAft>
+                <a:spcPts val="0"/>
+              </a:spcAft>
+              <a:buNone/>
+            </a:lvl7pPr>
+            <a:lvl8pPr marL="0" indent="0">
+              <a:lnSpc>
+                <a:spcPct val="110000"/>
+              </a:lnSpc>
+              <a:spcBef>
+                <a:spcPts val="0"/>
+              </a:spcBef>
+              <a:spcAft>
+                <a:spcPts val="0"/>
+              </a:spcAft>
+              <a:buNone/>
+            </a:lvl8pPr>
+            <a:lvl9pPr marL="0" indent="0">
+              <a:lnSpc>
+                <a:spcPct val="110000"/>
+              </a:lnSpc>
+              <a:spcBef>
+                <a:spcPts val="0"/>
+              </a:spcBef>
+              <a:spcAft>
+                <a:spcPts val="0"/>
+              </a:spcAft>
+              <a:buNone/>
+            </a:lvl9pPr>
+          </a:lstStyle>
+          <a:p xmlns:a="http://schemas.openxmlformats.org/drawingml/2006/main"/>
+        </p:txBody>
+      </p:sp>
+      <p:sp>
+        <p:nvSpPr>
+          <p:cNvPr id="2" name="Subtitle">
+            <a:extLst xmlns:a="http://schemas.openxmlformats.org/drawingml/2006/main">
+              <a:ext uri="{FF2B5EF4-FFF2-40B4-BE49-F238E27FC236}">
+                <a16:creationId xmlns:a16="http://schemas.microsoft.com/office/drawing/2014/main" id="{F7D169C7-89BE-4C53-919D-D15D0F4882EA}"/>
+              </a:ext>
+            </a:extLst>
+          </p:cNvPr>
+          <p:cNvSpPr>
+            <a:spLocks xmlns:a="http://schemas.openxmlformats.org/drawingml/2006/main" noGrp="1"/>
+          </p:cNvSpPr>
+          <p:nvPr>
+            <p:ph type="subTitle" idx="1"/>
+          </p:nvPr>
+        </p:nvSpPr>
+        <p:spPr>
+          <a:xfrm xmlns:a="http://schemas.openxmlformats.org/drawingml/2006/main">
+            <a:off x="1828800" y="3771900"/>
+            <a:ext cx="8534400" cy="762000"/>
+          </a:xfrm>
+          <a:prstGeom xmlns:a="http://schemas.openxmlformats.org/drawingml/2006/main" prst="rect">
+            <a:avLst/>
+          </a:prstGeom>
+          <a:noFill xmlns:a="http://schemas.openxmlformats.org/drawingml/2006/main"/>
+          <a:ln xmlns:a="http://schemas.openxmlformats.org/drawingml/2006/main">
+            <a:noFill/>
+            <a:prstDash val="solid"/>
+          </a:ln>
+        </p:spPr>
+        <p:txBody>
+          <a:bodyPr xmlns:a="http://schemas.openxmlformats.org/drawingml/2006/main" wrap="square" lIns="0" tIns="0" rIns="0" bIns="0" anchor="ctr">
+            <a:normAutofit/>
+          </a:bodyPr>
+          <a:lstStyle xmlns:a="http://schemas.openxmlformats.org/drawingml/2006/main">
+            <a:defPPr algn="ctr">
+              <a:defRPr sz="2100" b="0">
+                <a:solidFill>
+                  <a:schemeClr val="tx1"/>
+                </a:solidFill>
+                <a:latin typeface="+mn-lt"/>
+                <a:ea typeface="+mn-lt"/>
+                <a:cs typeface="+mn-lt"/>
+              </a:defRPr>
+            </a:defPPr>
+            <a:lvl1pPr marL="0" indent="0">
+              <a:lnSpc>
+                <a:spcPct val="110000"/>
+              </a:lnSpc>
+              <a:spcBef>
+                <a:spcPts val="0"/>
+              </a:spcBef>
+              <a:spcAft>
+                <a:spcPts val="0"/>
+              </a:spcAft>
+              <a:buNone/>
+            </a:lvl1pPr>
+            <a:lvl2pPr marL="0" indent="0">
+              <a:lnSpc>
+                <a:spcPct val="110000"/>
+              </a:lnSpc>
+              <a:spcBef>
+                <a:spcPts val="0"/>
+              </a:spcBef>
+              <a:spcAft>
+                <a:spcPts val="0"/>
+              </a:spcAft>
+              <a:buNone/>
+            </a:lvl2pPr>
+            <a:lvl3pPr marL="0" indent="0">
+              <a:lnSpc>
+                <a:spcPct val="110000"/>
+              </a:lnSpc>
+              <a:spcBef>
+                <a:spcPts val="0"/>
+              </a:spcBef>
+              <a:spcAft>
+                <a:spcPts val="0"/>
+              </a:spcAft>
+              <a:buNone/>
+            </a:lvl3pPr>
+            <a:lvl4pPr marL="0" indent="0">
+              <a:lnSpc>
+                <a:spcPct val="110000"/>
+              </a:lnSpc>
+              <a:spcBef>
+                <a:spcPts val="0"/>
+              </a:spcBef>
+              <a:spcAft>
+                <a:spcPts val="0"/>
+              </a:spcAft>
+              <a:buNone/>
+            </a:lvl4pPr>
+            <a:lvl5pPr marL="0" indent="0">
+              <a:lnSpc>
+                <a:spcPct val="110000"/>
+              </a:lnSpc>
+              <a:spcBef>
+                <a:spcPts val="0"/>
+              </a:spcBef>
+              <a:spcAft>
+                <a:spcPts val="0"/>
+              </a:spcAft>
+              <a:buNone/>
+            </a:lvl5pPr>
+            <a:lvl6pPr marL="0" indent="0">
+              <a:lnSpc>
+                <a:spcPct val="110000"/>
+              </a:lnSpc>
+              <a:spcBef>
+                <a:spcPts val="0"/>
+              </a:spcBef>
+              <a:spcAft>
+                <a:spcPts val="0"/>
+              </a:spcAft>
+              <a:buNone/>
+            </a:lvl6pPr>
+            <a:lvl7pPr marL="0" indent="0">
+              <a:lnSpc>
+                <a:spcPct val="110000"/>
+              </a:lnSpc>
+              <a:spcBef>
+                <a:spcPts val="0"/>
+              </a:spcBef>
+              <a:spcAft>
+                <a:spcPts val="0"/>
+              </a:spcAft>
+              <a:buNone/>
+            </a:lvl7pPr>
+            <a:lvl8pPr marL="0" indent="0">
+              <a:lnSpc>
+                <a:spcPct val="110000"/>
+              </a:lnSpc>
+              <a:spcBef>
+                <a:spcPts val="0"/>
+              </a:spcBef>
+              <a:spcAft>
+                <a:spcPts val="0"/>
+              </a:spcAft>
+              <a:buNone/>
+            </a:lvl8pPr>
+            <a:lvl9pPr marL="0" indent="0">
+              <a:lnSpc>
+                <a:spcPct val="110000"/>
+              </a:lnSpc>
+              <a:spcBef>
+                <a:spcPts val="0"/>
+              </a:spcBef>
+              <a:spcAft>
+                <a:spcPts val="0"/>
+              </a:spcAft>
+              <a:buNone/>
+            </a:lvl9pPr>
+          </a:lstStyle>
+          <a:p xmlns:a="http://schemas.openxmlformats.org/drawingml/2006/main"/>
+        </p:txBody>
+      </p:sp>
+    </p:spTree>
+  </p:cSld>
+</p:sldLayout>
+</file>
+
+<file path=ppt/education/slideLayouts/slideLayout2.xml><?xml version="1.0" encoding="utf-8"?>
+<p:sldLayout xmlns:p="http://schemas.openxmlformats.org/presentationml/2006/main">
+  <p:cSld name="Section Header">
+    <p:spTree>
+      <p:nvGrpSpPr>
+        <p:cNvPr id="1" name=""/>
+        <p:cNvGrpSpPr/>
+        <p:nvPr/>
+      </p:nvGrpSpPr>
+      <p:grpSpPr>
+        <a:xfrm xmlns:a="http://schemas.openxmlformats.org/drawingml/2006/main"/>
+      </p:grpSpPr>
+      <p:sp>
+        <p:nvSpPr>
+          <p:cNvPr id="2" name="Section title">
+            <a:extLst xmlns:a="http://schemas.openxmlformats.org/drawingml/2006/main">
+              <a:ext uri="{FF2B5EF4-FFF2-40B4-BE49-F238E27FC236}">
+                <a16:creationId xmlns:a16="http://schemas.microsoft.com/office/drawing/2014/main" id="{3ACE4273-A1C0-48D3-8998-79AC20F52EF1}"/>
+              </a:ext>
+            </a:extLst>
+          </p:cNvPr>
+          <p:cNvSpPr>
+            <a:spLocks xmlns:a="http://schemas.openxmlformats.org/drawingml/2006/main" noGrp="1"/>
+          </p:cNvSpPr>
+          <p:nvPr>
+            <p:ph type="title" idx="0"/>
+          </p:nvPr>
+        </p:nvSpPr>
+        <p:spPr>
+          <a:xfrm xmlns:a="http://schemas.openxmlformats.org/drawingml/2006/main">
+            <a:off x="1219200" y="2857500"/>
+            <a:ext cx="9753600" cy="1143000"/>
+          </a:xfrm>
+          <a:prstGeom xmlns:a="http://schemas.openxmlformats.org/drawingml/2006/main" prst="rect">
+            <a:avLst/>
+          </a:prstGeom>
+          <a:noFill xmlns:a="http://schemas.openxmlformats.org/drawingml/2006/main"/>
+          <a:ln xmlns:a="http://schemas.openxmlformats.org/drawingml/2006/main">
+            <a:noFill/>
+            <a:prstDash val="solid"/>
+          </a:ln>
+        </p:spPr>
+        <p:txBody>
+          <a:bodyPr xmlns:a="http://schemas.openxmlformats.org/drawingml/2006/main" wrap="square" lIns="0" tIns="0" rIns="0" bIns="0" anchor="ctr">
+            <a:normAutofit/>
+          </a:bodyPr>
+          <a:lstStyle xmlns:a="http://schemas.openxmlformats.org/drawingml/2006/main">
+            <a:defPPr algn="ctr">
+              <a:defRPr sz="4200" b="1">
+                <a:solidFill>
+                  <a:schemeClr val="tx1"/>
+                </a:solidFill>
+                <a:latin typeface="+mj-lt"/>
+                <a:ea typeface="+mj-lt"/>
+                <a:cs typeface="+mj-lt"/>
+              </a:defRPr>
+            </a:defPPr>
+            <a:lvl1pPr marL="0" indent="0">
+              <a:lnSpc>
+                <a:spcPct val="110000"/>
+              </a:lnSpc>
+              <a:spcBef>
+                <a:spcPts val="0"/>
+              </a:spcBef>
+              <a:spcAft>
+                <a:spcPts val="0"/>
+              </a:spcAft>
+              <a:buNone/>
+            </a:lvl1pPr>
+            <a:lvl2pPr marL="0" indent="0">
+              <a:lnSpc>
+                <a:spcPct val="110000"/>
+              </a:lnSpc>
+              <a:spcBef>
+                <a:spcPts val="0"/>
+              </a:spcBef>
+              <a:spcAft>
+                <a:spcPts val="0"/>
+              </a:spcAft>
+              <a:buNone/>
+            </a:lvl2pPr>
+            <a:lvl3pPr marL="0" indent="0">
+              <a:lnSpc>
+                <a:spcPct val="110000"/>
+              </a:lnSpc>
+              <a:spcBef>
+                <a:spcPts val="0"/>
+              </a:spcBef>
+              <a:spcAft>
+                <a:spcPts val="0"/>
+              </a:spcAft>
+              <a:buNone/>
+            </a:lvl3pPr>
+            <a:lvl4pPr marL="0" indent="0">
+              <a:lnSpc>
+                <a:spcPct val="110000"/>
+              </a:lnSpc>
+              <a:spcBef>
+                <a:spcPts val="0"/>
+              </a:spcBef>
+              <a:spcAft>
+                <a:spcPts val="0"/>
+              </a:spcAft>
+              <a:buNone/>
+            </a:lvl4pPr>
+            <a:lvl5pPr marL="0" indent="0">
+              <a:lnSpc>
+                <a:spcPct val="110000"/>
+              </a:lnSpc>
+              <a:spcBef>
+                <a:spcPts val="0"/>
+              </a:spcBef>
+              <a:spcAft>
+                <a:spcPts val="0"/>
+              </a:spcAft>
+              <a:buNone/>
+            </a:lvl5pPr>
+            <a:lvl6pPr marL="0" indent="0">
+              <a:lnSpc>
+                <a:spcPct val="110000"/>
+              </a:lnSpc>
+              <a:spcBef>
+                <a:spcPts val="0"/>
+              </a:spcBef>
+              <a:spcAft>
+                <a:spcPts val="0"/>
+              </a:spcAft>
+              <a:buNone/>
+            </a:lvl6pPr>
+            <a:lvl7pPr marL="0" indent="0">
+              <a:lnSpc>
+                <a:spcPct val="110000"/>
+              </a:lnSpc>
+              <a:spcBef>
+                <a:spcPts val="0"/>
+              </a:spcBef>
+              <a:spcAft>
+                <a:spcPts val="0"/>
+              </a:spcAft>
+              <a:buNone/>
+            </a:lvl7pPr>
+            <a:lvl8pPr marL="0" indent="0">
+              <a:lnSpc>
+                <a:spcPct val="110000"/>
+              </a:lnSpc>
+              <a:spcBef>
+                <a:spcPts val="0"/>
+              </a:spcBef>
+              <a:spcAft>
+                <a:spcPts val="0"/>
+              </a:spcAft>
+              <a:buNone/>
+            </a:lvl8pPr>
+            <a:lvl9pPr marL="0" indent="0">
+              <a:lnSpc>
+                <a:spcPct val="110000"/>
+              </a:lnSpc>
+              <a:spcBef>
+                <a:spcPts val="0"/>
+              </a:spcBef>
+              <a:spcAft>
+                <a:spcPts val="0"/>
+              </a:spcAft>
+              <a:buNone/>
+            </a:lvl9pPr>
+          </a:lstStyle>
+          <a:p xmlns:a="http://schemas.openxmlformats.org/drawingml/2006/main"/>
+        </p:txBody>
+      </p:sp>
+    </p:spTree>
+  </p:cSld>
+</p:sldLayout>
+</file>
+
+<file path=ppt/education/slideLayouts/slideLayout3.xml><?xml version="1.0" encoding="utf-8"?>
+<p:sldLayout xmlns:p="http://schemas.openxmlformats.org/presentationml/2006/main">
+  <p:cSld name="Title and Body">
+    <p:spTree>
+      <p:nvGrpSpPr>
+        <p:cNvPr id="1" name=""/>
+        <p:cNvGrpSpPr/>
+        <p:nvPr/>
+      </p:nvGrpSpPr>
+      <p:grpSpPr>
+        <a:xfrm xmlns:a="http://schemas.openxmlformats.org/drawingml/2006/main"/>
+      </p:grpSpPr>
+      <p:sp>
+        <p:nvSpPr>
+          <p:cNvPr id="3" name="Title">
+            <a:extLst xmlns:a="http://schemas.openxmlformats.org/drawingml/2006/main">
+              <a:ext uri="{FF2B5EF4-FFF2-40B4-BE49-F238E27FC236}">
+                <a16:creationId xmlns:a16="http://schemas.microsoft.com/office/drawing/2014/main" id="{43070933-6764-48C3-AE30-891CFC1391F4}"/>
+              </a:ext>
+            </a:extLst>
+          </p:cNvPr>
+          <p:cNvSpPr>
+            <a:spLocks xmlns:a="http://schemas.openxmlformats.org/drawingml/2006/main" noGrp="1"/>
+          </p:cNvSpPr>
+          <p:nvPr>
+            <p:ph type="title" idx="0"/>
+          </p:nvPr>
+        </p:nvSpPr>
+        <p:spPr>
+          <a:xfrm xmlns:a="http://schemas.openxmlformats.org/drawingml/2006/main">
+            <a:off x="685800" y="533400"/>
+            <a:ext cx="10820400" cy="838200"/>
+          </a:xfrm>
+          <a:prstGeom xmlns:a="http://schemas.openxmlformats.org/drawingml/2006/main" prst="rect">
+            <a:avLst/>
+          </a:prstGeom>
+          <a:noFill xmlns:a="http://schemas.openxmlformats.org/drawingml/2006/main"/>
+          <a:ln xmlns:a="http://schemas.openxmlformats.org/drawingml/2006/main">
+            <a:noFill/>
+            <a:prstDash val="solid"/>
+          </a:ln>
+        </p:spPr>
+        <p:txBody>
+          <a:bodyPr xmlns:a="http://schemas.openxmlformats.org/drawingml/2006/main" wrap="square" lIns="0" tIns="0" rIns="0" bIns="0" anchor="t">
+            <a:normAutofit/>
+          </a:bodyPr>
+          <a:lstStyle xmlns:a="http://schemas.openxmlformats.org/drawingml/2006/main">
+            <a:defPPr algn="l">
+              <a:defRPr sz="3300" b="1">
+                <a:solidFill>
+                  <a:schemeClr val="tx1"/>
+                </a:solidFill>
+                <a:latin typeface="+mj-lt"/>
+                <a:ea typeface="+mj-lt"/>
+                <a:cs typeface="+mj-lt"/>
+              </a:defRPr>
+            </a:defPPr>
+            <a:lvl1pPr marL="0" indent="0">
+              <a:lnSpc>
+                <a:spcPct val="110000"/>
+              </a:lnSpc>
+              <a:spcBef>
+                <a:spcPts val="0"/>
+              </a:spcBef>
+              <a:spcAft>
+                <a:spcPts val="0"/>
+              </a:spcAft>
+              <a:buNone/>
+            </a:lvl1pPr>
+            <a:lvl2pPr marL="0" indent="0">
+              <a:lnSpc>
+                <a:spcPct val="110000"/>
+              </a:lnSpc>
+              <a:spcBef>
+                <a:spcPts val="0"/>
+              </a:spcBef>
+              <a:spcAft>
+                <a:spcPts val="0"/>
+              </a:spcAft>
+              <a:buNone/>
+            </a:lvl2pPr>
+            <a:lvl3pPr marL="0" indent="0">
+              <a:lnSpc>
+                <a:spcPct val="110000"/>
+              </a:lnSpc>
+              <a:spcBef>
+                <a:spcPts val="0"/>
+              </a:spcBef>
+              <a:spcAft>
+                <a:spcPts val="0"/>
+              </a:spcAft>
+              <a:buNone/>
+            </a:lvl3pPr>
+            <a:lvl4pPr marL="0" indent="0">
+              <a:lnSpc>
+                <a:spcPct val="110000"/>
+              </a:lnSpc>
+              <a:spcBef>
+                <a:spcPts val="0"/>
+              </a:spcBef>
+              <a:spcAft>
+                <a:spcPts val="0"/>
+              </a:spcAft>
+              <a:buNone/>
+            </a:lvl4pPr>
+            <a:lvl5pPr marL="0" indent="0">
+              <a:lnSpc>
+                <a:spcPct val="110000"/>
+              </a:lnSpc>
+              <a:spcBef>
+                <a:spcPts val="0"/>
+              </a:spcBef>
+              <a:spcAft>
+                <a:spcPts val="0"/>
+              </a:spcAft>
+              <a:buNone/>
+            </a:lvl5pPr>
+            <a:lvl6pPr marL="0" indent="0">
+              <a:lnSpc>
+                <a:spcPct val="110000"/>
+              </a:lnSpc>
+              <a:spcBef>
+                <a:spcPts val="0"/>
+              </a:spcBef>
+              <a:spcAft>
+                <a:spcPts val="0"/>
+              </a:spcAft>
+              <a:buNone/>
+            </a:lvl6pPr>
+            <a:lvl7pPr marL="0" indent="0">
+              <a:lnSpc>
+                <a:spcPct val="110000"/>
+              </a:lnSpc>
+              <a:spcBef>
+                <a:spcPts val="0"/>
+              </a:spcBef>
+              <a:spcAft>
+                <a:spcPts val="0"/>
+              </a:spcAft>
+              <a:buNone/>
+            </a:lvl7pPr>
+            <a:lvl8pPr marL="0" indent="0">
+              <a:lnSpc>
+                <a:spcPct val="110000"/>
+              </a:lnSpc>
+              <a:spcBef>
+                <a:spcPts val="0"/>
+              </a:spcBef>
+              <a:spcAft>
+                <a:spcPts val="0"/>
+              </a:spcAft>
+              <a:buNone/>
+            </a:lvl8pPr>
+            <a:lvl9pPr marL="0" indent="0">
+              <a:lnSpc>
+                <a:spcPct val="110000"/>
+              </a:lnSpc>
+              <a:spcBef>
+                <a:spcPts val="0"/>
+              </a:spcBef>
+              <a:spcAft>
+                <a:spcPts val="0"/>
+              </a:spcAft>
+              <a:buNone/>
+            </a:lvl9pPr>
+          </a:lstStyle>
+          <a:p xmlns:a="http://schemas.openxmlformats.org/drawingml/2006/main"/>
+        </p:txBody>
+      </p:sp>
+      <p:sp>
+        <p:nvSpPr>
+          <p:cNvPr id="2" name="Body">
+            <a:extLst xmlns:a="http://schemas.openxmlformats.org/drawingml/2006/main">
+              <a:ext uri="{FF2B5EF4-FFF2-40B4-BE49-F238E27FC236}">
+                <a16:creationId xmlns:a16="http://schemas.microsoft.com/office/drawing/2014/main" id="{17B4EF72-FB31-448C-8A26-16019F670DF1}"/>
+              </a:ext>
+            </a:extLst>
+          </p:cNvPr>
+          <p:cNvSpPr>
+            <a:spLocks xmlns:a="http://schemas.openxmlformats.org/drawingml/2006/main" noGrp="1"/>
+          </p:cNvSpPr>
+          <p:nvPr>
+            <p:ph type="body" idx="1"/>
+          </p:nvPr>
+        </p:nvSpPr>
+        <p:spPr>
+          <a:xfrm xmlns:a="http://schemas.openxmlformats.org/drawingml/2006/main">
+            <a:off x="685800" y="1905000"/>
+            <a:ext cx="10820400" cy="4267200"/>
+          </a:xfrm>
+          <a:prstGeom xmlns:a="http://schemas.openxmlformats.org/drawingml/2006/main" prst="rect">
+            <a:avLst/>
+          </a:prstGeom>
+          <a:noFill xmlns:a="http://schemas.openxmlformats.org/drawingml/2006/main"/>
+          <a:ln xmlns:a="http://schemas.openxmlformats.org/drawingml/2006/main">
+            <a:noFill/>
+            <a:prstDash val="solid"/>
+          </a:ln>
+        </p:spPr>
+        <p:txBody>
+          <a:bodyPr xmlns:a="http://schemas.openxmlformats.org/drawingml/2006/main" wrap="square" lIns="0" tIns="0" rIns="0" bIns="0" anchor="t">
+            <a:normAutofit/>
+          </a:bodyPr>
+          <a:lstStyle xmlns:a="http://schemas.openxmlformats.org/drawingml/2006/main">
+            <a:defPPr algn="l">
+              <a:defRPr sz="2250" b="0">
+                <a:solidFill>
+                  <a:schemeClr val="tx1"/>
+                </a:solidFill>
+                <a:latin typeface="+mn-lt"/>
+                <a:ea typeface="+mn-lt"/>
+                <a:cs typeface="+mn-lt"/>
+              </a:defRPr>
+            </a:defPPr>
+            <a:lvl1pPr marL="228600" indent="-228600">
+              <a:lnSpc>
+                <a:spcPct val="110000"/>
+              </a:lnSpc>
+              <a:spcBef>
+                <a:spcPts val="0"/>
+              </a:spcBef>
+              <a:spcAft>
+                <a:spcPts val="1200"/>
+              </a:spcAft>
+              <a:buChar char="•"/>
+            </a:lvl1pPr>
+            <a:lvl2pPr marL="533400" indent="-228600">
+              <a:lnSpc>
+                <a:spcPct val="110000"/>
+              </a:lnSpc>
+              <a:spcBef>
+                <a:spcPts val="0"/>
+              </a:spcBef>
+              <a:spcAft>
+                <a:spcPts val="1200"/>
+              </a:spcAft>
+              <a:buChar char="•"/>
+            </a:lvl2pPr>
+            <a:lvl3pPr marL="838200" indent="-228600">
+              <a:lnSpc>
+                <a:spcPct val="110000"/>
+              </a:lnSpc>
+              <a:spcBef>
+                <a:spcPts val="0"/>
+              </a:spcBef>
+              <a:spcAft>
+                <a:spcPts val="1200"/>
+              </a:spcAft>
+              <a:buChar char="•"/>
+            </a:lvl3pPr>
+            <a:lvl4pPr marL="1143000" indent="-228600">
+              <a:lnSpc>
+                <a:spcPct val="110000"/>
+              </a:lnSpc>
+              <a:spcBef>
+                <a:spcPts val="0"/>
+              </a:spcBef>
+              <a:spcAft>
+                <a:spcPts val="1200"/>
+              </a:spcAft>
+              <a:buChar char="•"/>
+            </a:lvl4pPr>
+            <a:lvl5pPr marL="1447800" indent="-228600">
+              <a:lnSpc>
+                <a:spcPct val="110000"/>
+              </a:lnSpc>
+              <a:spcBef>
+                <a:spcPts val="0"/>
+              </a:spcBef>
+              <a:spcAft>
+                <a:spcPts val="1200"/>
+              </a:spcAft>
+              <a:buChar char="•"/>
+            </a:lvl5pPr>
+            <a:lvl6pPr marL="1752600" indent="-228600">
+              <a:lnSpc>
+                <a:spcPct val="110000"/>
+              </a:lnSpc>
+              <a:spcBef>
+                <a:spcPts val="0"/>
+              </a:spcBef>
+              <a:spcAft>
+                <a:spcPts val="1200"/>
+              </a:spcAft>
+              <a:buChar char="•"/>
+            </a:lvl6pPr>
+            <a:lvl7pPr marL="2057400" indent="-228600">
+              <a:lnSpc>
+                <a:spcPct val="110000"/>
+              </a:lnSpc>
+              <a:spcBef>
+                <a:spcPts val="0"/>
+              </a:spcBef>
+              <a:spcAft>
+                <a:spcPts val="1200"/>
+              </a:spcAft>
+              <a:buChar char="•"/>
+            </a:lvl7pPr>
+            <a:lvl8pPr marL="2362200" indent="-228600">
+              <a:lnSpc>
+                <a:spcPct val="110000"/>
+              </a:lnSpc>
+              <a:spcBef>
+                <a:spcPts val="0"/>
+              </a:spcBef>
+              <a:spcAft>
+                <a:spcPts val="1200"/>
+              </a:spcAft>
+              <a:buChar char="•"/>
+            </a:lvl8pPr>
+            <a:lvl9pPr marL="2667000" indent="-228600">
+              <a:lnSpc>
+                <a:spcPct val="110000"/>
+              </a:lnSpc>
+              <a:spcBef>
+                <a:spcPts val="0"/>
+              </a:spcBef>
+              <a:spcAft>
+                <a:spcPts val="1200"/>
+              </a:spcAft>
+              <a:buChar char="•"/>
+            </a:lvl9pPr>
+          </a:lstStyle>
+          <a:p xmlns:a="http://schemas.openxmlformats.org/drawingml/2006/main"/>
+        </p:txBody>
+      </p:sp>
+    </p:spTree>
+  </p:cSld>
+</p:sldLayout>
+</file>
+
+<file path=ppt/education/slideLayouts/slideLayout4.xml><?xml version="1.0" encoding="utf-8"?>
+<p:sldLayout xmlns:p="http://schemas.openxmlformats.org/presentationml/2006/main">
+  <p:cSld name="Title and Two Column">
+    <p:spTree>
+      <p:nvGrpSpPr>
+        <p:cNvPr id="1" name=""/>
+        <p:cNvGrpSpPr/>
+        <p:nvPr/>
+      </p:nvGrpSpPr>
+      <p:grpSpPr>
+        <a:xfrm xmlns:a="http://schemas.openxmlformats.org/drawingml/2006/main"/>
+      </p:grpSpPr>
+      <p:sp>
+        <p:nvSpPr>
+          <p:cNvPr id="4" name="Title">
+            <a:extLst xmlns:a="http://schemas.openxmlformats.org/drawingml/2006/main">
+              <a:ext uri="{FF2B5EF4-FFF2-40B4-BE49-F238E27FC236}">
+                <a16:creationId xmlns:a16="http://schemas.microsoft.com/office/drawing/2014/main" id="{8FBE63FC-2045-42E6-90C8-8C69500665D3}"/>
+              </a:ext>
+            </a:extLst>
+          </p:cNvPr>
+          <p:cNvSpPr>
+            <a:spLocks xmlns:a="http://schemas.openxmlformats.org/drawingml/2006/main" noGrp="1"/>
+          </p:cNvSpPr>
+          <p:nvPr>
+            <p:ph type="title" idx="0"/>
+          </p:nvPr>
+        </p:nvSpPr>
+        <p:spPr>
+          <a:xfrm xmlns:a="http://schemas.openxmlformats.org/drawingml/2006/main">
+            <a:off x="685800" y="533400"/>
+            <a:ext cx="10820400" cy="838200"/>
+          </a:xfrm>
+          <a:prstGeom xmlns:a="http://schemas.openxmlformats.org/drawingml/2006/main" prst="rect">
+            <a:avLst/>
+          </a:prstGeom>
+          <a:noFill xmlns:a="http://schemas.openxmlformats.org/drawingml/2006/main"/>
+          <a:ln xmlns:a="http://schemas.openxmlformats.org/drawingml/2006/main">
+            <a:noFill/>
+            <a:prstDash val="solid"/>
+          </a:ln>
+        </p:spPr>
+        <p:txBody>
+          <a:bodyPr xmlns:a="http://schemas.openxmlformats.org/drawingml/2006/main" wrap="square" lIns="0" tIns="0" rIns="0" bIns="0" anchor="t">
+            <a:normAutofit/>
+          </a:bodyPr>
+          <a:lstStyle xmlns:a="http://schemas.openxmlformats.org/drawingml/2006/main">
+            <a:defPPr algn="l">
+              <a:defRPr sz="3300" b="1">
+                <a:solidFill>
+                  <a:schemeClr val="tx1"/>
+                </a:solidFill>
+                <a:latin typeface="+mj-lt"/>
+                <a:ea typeface="+mj-lt"/>
+                <a:cs typeface="+mj-lt"/>
+              </a:defRPr>
+            </a:defPPr>
+            <a:lvl1pPr marL="0" indent="0">
+              <a:lnSpc>
+                <a:spcPct val="110000"/>
+              </a:lnSpc>
+              <a:spcBef>
+                <a:spcPts val="0"/>
+              </a:spcBef>
+              <a:spcAft>
+                <a:spcPts val="0"/>
+              </a:spcAft>
+              <a:buNone/>
+            </a:lvl1pPr>
+            <a:lvl2pPr marL="0" indent="0">
+              <a:lnSpc>
+                <a:spcPct val="110000"/>
+              </a:lnSpc>
+              <a:spcBef>
+                <a:spcPts val="0"/>
+              </a:spcBef>
+              <a:spcAft>
+                <a:spcPts val="0"/>
+              </a:spcAft>
+              <a:buNone/>
+            </a:lvl2pPr>
+            <a:lvl3pPr marL="0" indent="0">
+              <a:lnSpc>
+                <a:spcPct val="110000"/>
+              </a:lnSpc>
+              <a:spcBef>
+                <a:spcPts val="0"/>
+              </a:spcBef>
+              <a:spcAft>
+                <a:spcPts val="0"/>
+              </a:spcAft>
+              <a:buNone/>
+            </a:lvl3pPr>
+            <a:lvl4pPr marL="0" indent="0">
+              <a:lnSpc>
+                <a:spcPct val="110000"/>
+              </a:lnSpc>
+              <a:spcBef>
+                <a:spcPts val="0"/>
+              </a:spcBef>
+              <a:spcAft>
+                <a:spcPts val="0"/>
+              </a:spcAft>
+              <a:buNone/>
+            </a:lvl4pPr>
+            <a:lvl5pPr marL="0" indent="0">
+              <a:lnSpc>
+                <a:spcPct val="110000"/>
+              </a:lnSpc>
+              <a:spcBef>
+                <a:spcPts val="0"/>
+              </a:spcBef>
+              <a:spcAft>
+                <a:spcPts val="0"/>
+              </a:spcAft>
+              <a:buNone/>
+            </a:lvl5pPr>
+            <a:lvl6pPr marL="0" indent="0">
+              <a:lnSpc>
+                <a:spcPct val="110000"/>
+              </a:lnSpc>
+              <a:spcBef>
+                <a:spcPts val="0"/>
+              </a:spcBef>
+              <a:spcAft>
+                <a:spcPts val="0"/>
+              </a:spcAft>
+              <a:buNone/>
+            </a:lvl6pPr>
+            <a:lvl7pPr marL="0" indent="0">
+              <a:lnSpc>
+                <a:spcPct val="110000"/>
+              </a:lnSpc>
+              <a:spcBef>
+                <a:spcPts val="0"/>
+              </a:spcBef>
+              <a:spcAft>
+                <a:spcPts val="0"/>
+              </a:spcAft>
+              <a:buNone/>
+            </a:lvl7pPr>
+            <a:lvl8pPr marL="0" indent="0">
+              <a:lnSpc>
+                <a:spcPct val="110000"/>
+              </a:lnSpc>
+              <a:spcBef>
+                <a:spcPts val="0"/>
+              </a:spcBef>
+              <a:spcAft>
+                <a:spcPts val="0"/>
+              </a:spcAft>
+              <a:buNone/>
+            </a:lvl8pPr>
+            <a:lvl9pPr marL="0" indent="0">
+              <a:lnSpc>
+                <a:spcPct val="110000"/>
+              </a:lnSpc>
+              <a:spcBef>
+                <a:spcPts val="0"/>
+              </a:spcBef>
+              <a:spcAft>
+                <a:spcPts val="0"/>
+              </a:spcAft>
+              <a:buNone/>
+            </a:lvl9pPr>
+          </a:lstStyle>
+          <a:p xmlns:a="http://schemas.openxmlformats.org/drawingml/2006/main"/>
+        </p:txBody>
+      </p:sp>
+      <p:sp>
+        <p:nvSpPr>
+          <p:cNvPr id="2" name="Left column">
+            <a:extLst xmlns:a="http://schemas.openxmlformats.org/drawingml/2006/main">
+              <a:ext uri="{FF2B5EF4-FFF2-40B4-BE49-F238E27FC236}">
+                <a16:creationId xmlns:a16="http://schemas.microsoft.com/office/drawing/2014/main" id="{8AE534D6-FBE1-4F17-B28F-8727AEDE8B53}"/>
+              </a:ext>
+            </a:extLst>
+          </p:cNvPr>
+          <p:cNvSpPr>
+            <a:spLocks xmlns:a="http://schemas.openxmlformats.org/drawingml/2006/main" noGrp="1"/>
+          </p:cNvSpPr>
+          <p:nvPr>
+            <p:ph type="body" idx="1"/>
+          </p:nvPr>
+        </p:nvSpPr>
+        <p:spPr>
+          <a:xfrm xmlns:a="http://schemas.openxmlformats.org/drawingml/2006/main">
+            <a:off x="685800" y="1905000"/>
+            <a:ext cx="5029200" cy="4267200"/>
+          </a:xfrm>
+          <a:prstGeom xmlns:a="http://schemas.openxmlformats.org/drawingml/2006/main" prst="rect">
+            <a:avLst/>
+          </a:prstGeom>
+          <a:noFill xmlns:a="http://schemas.openxmlformats.org/drawingml/2006/main"/>
+          <a:ln xmlns:a="http://schemas.openxmlformats.org/drawingml/2006/main">
+            <a:noFill/>
+            <a:prstDash val="solid"/>
+          </a:ln>
+        </p:spPr>
+        <p:txBody>
+          <a:bodyPr xmlns:a="http://schemas.openxmlformats.org/drawingml/2006/main" wrap="square" lIns="0" tIns="0" rIns="0" bIns="0" anchor="t">
+            <a:normAutofit/>
+          </a:bodyPr>
+          <a:lstStyle xmlns:a="http://schemas.openxmlformats.org/drawingml/2006/main">
+            <a:defPPr algn="l">
+              <a:defRPr sz="2100" b="0">
+                <a:solidFill>
+                  <a:schemeClr val="tx1"/>
+                </a:solidFill>
+                <a:latin typeface="+mn-lt"/>
+                <a:ea typeface="+mn-lt"/>
+                <a:cs typeface="+mn-lt"/>
+              </a:defRPr>
+            </a:defPPr>
+            <a:lvl1pPr marL="228600" indent="-228600">
+              <a:lnSpc>
+                <a:spcPct val="110000"/>
+              </a:lnSpc>
+              <a:spcBef>
+                <a:spcPts val="0"/>
+              </a:spcBef>
+              <a:spcAft>
+                <a:spcPts val="1200"/>
+              </a:spcAft>
+              <a:buChar char="•"/>
+            </a:lvl1pPr>
+            <a:lvl2pPr marL="533400" indent="-228600">
+              <a:lnSpc>
+                <a:spcPct val="110000"/>
+              </a:lnSpc>
+              <a:spcBef>
+                <a:spcPts val="0"/>
+              </a:spcBef>
+              <a:spcAft>
+                <a:spcPts val="1200"/>
+              </a:spcAft>
+              <a:buChar char="•"/>
+            </a:lvl2pPr>
+            <a:lvl3pPr marL="838200" indent="-228600">
+              <a:lnSpc>
+                <a:spcPct val="110000"/>
+              </a:lnSpc>
+              <a:spcBef>
+                <a:spcPts val="0"/>
+              </a:spcBef>
+              <a:spcAft>
+                <a:spcPts val="1200"/>
+              </a:spcAft>
+              <a:buChar char="•"/>
+            </a:lvl3pPr>
+            <a:lvl4pPr marL="1143000" indent="-228600">
+              <a:lnSpc>
+                <a:spcPct val="110000"/>
+              </a:lnSpc>
+              <a:spcBef>
+                <a:spcPts val="0"/>
+              </a:spcBef>
+              <a:spcAft>
+                <a:spcPts val="1200"/>
+              </a:spcAft>
+              <a:buChar char="•"/>
+            </a:lvl4pPr>
+            <a:lvl5pPr marL="1447800" indent="-228600">
+              <a:lnSpc>
+                <a:spcPct val="110000"/>
+              </a:lnSpc>
+              <a:spcBef>
+                <a:spcPts val="0"/>
+              </a:spcBef>
+              <a:spcAft>
+                <a:spcPts val="1200"/>
+              </a:spcAft>
+              <a:buChar char="•"/>
+            </a:lvl5pPr>
+            <a:lvl6pPr marL="1752600" indent="-228600">
+              <a:lnSpc>
+                <a:spcPct val="110000"/>
+              </a:lnSpc>
+              <a:spcBef>
+                <a:spcPts val="0"/>
+              </a:spcBef>
+              <a:spcAft>
+                <a:spcPts val="1200"/>
+              </a:spcAft>
+              <a:buChar char="•"/>
+            </a:lvl6pPr>
+            <a:lvl7pPr marL="2057400" indent="-228600">
+              <a:lnSpc>
+                <a:spcPct val="110000"/>
+              </a:lnSpc>
+              <a:spcBef>
+                <a:spcPts val="0"/>
+              </a:spcBef>
+              <a:spcAft>
+                <a:spcPts val="1200"/>
+              </a:spcAft>
+              <a:buChar char="•"/>
+            </a:lvl7pPr>
+            <a:lvl8pPr marL="2362200" indent="-228600">
+              <a:lnSpc>
+                <a:spcPct val="110000"/>
+              </a:lnSpc>
+              <a:spcBef>
+                <a:spcPts val="0"/>
+              </a:spcBef>
+              <a:spcAft>
+                <a:spcPts val="1200"/>
+              </a:spcAft>
+              <a:buChar char="•"/>
+            </a:lvl8pPr>
+            <a:lvl9pPr marL="2667000" indent="-228600">
+              <a:lnSpc>
+                <a:spcPct val="110000"/>
+              </a:lnSpc>
+              <a:spcBef>
+                <a:spcPts val="0"/>
+              </a:spcBef>
+              <a:spcAft>
+                <a:spcPts val="1200"/>
+              </a:spcAft>
+              <a:buChar char="•"/>
+            </a:lvl9pPr>
+          </a:lstStyle>
+          <a:p xmlns:a="http://schemas.openxmlformats.org/drawingml/2006/main"/>
+        </p:txBody>
+      </p:sp>
+      <p:sp>
+        <p:nvSpPr>
+          <p:cNvPr id="3" name="Right column">
+            <a:extLst xmlns:a="http://schemas.openxmlformats.org/drawingml/2006/main">
+              <a:ext uri="{FF2B5EF4-FFF2-40B4-BE49-F238E27FC236}">
+                <a16:creationId xmlns:a16="http://schemas.microsoft.com/office/drawing/2014/main" id="{925BBCD0-229F-4C25-829D-3AB1ADC390C5}"/>
+              </a:ext>
+            </a:extLst>
+          </p:cNvPr>
+          <p:cNvSpPr>
+            <a:spLocks xmlns:a="http://schemas.openxmlformats.org/drawingml/2006/main" noGrp="1"/>
+          </p:cNvSpPr>
+          <p:nvPr>
+            <p:ph type="body" idx="2"/>
+          </p:nvPr>
+        </p:nvSpPr>
+        <p:spPr>
+          <a:xfrm xmlns:a="http://schemas.openxmlformats.org/drawingml/2006/main">
+            <a:off x="6477000" y="1905000"/>
+            <a:ext cx="5029200" cy="4267200"/>
+          </a:xfrm>
+          <a:prstGeom xmlns:a="http://schemas.openxmlformats.org/drawingml/2006/main" prst="rect">
+            <a:avLst/>
+          </a:prstGeom>
+          <a:noFill xmlns:a="http://schemas.openxmlformats.org/drawingml/2006/main"/>
+          <a:ln xmlns:a="http://schemas.openxmlformats.org/drawingml/2006/main">
+            <a:noFill/>
+            <a:prstDash val="solid"/>
+          </a:ln>
+        </p:spPr>
+        <p:txBody>
+          <a:bodyPr xmlns:a="http://schemas.openxmlformats.org/drawingml/2006/main" wrap="square" lIns="0" tIns="0" rIns="0" bIns="0" anchor="t">
+            <a:normAutofit/>
+          </a:bodyPr>
+          <a:lstStyle xmlns:a="http://schemas.openxmlformats.org/drawingml/2006/main">
+            <a:defPPr algn="l">
+              <a:defRPr sz="2100" b="0">
+                <a:solidFill>
+                  <a:schemeClr val="tx1"/>
+                </a:solidFill>
+                <a:latin typeface="+mn-lt"/>
+                <a:ea typeface="+mn-lt"/>
+                <a:cs typeface="+mn-lt"/>
+              </a:defRPr>
+            </a:defPPr>
+            <a:lvl1pPr marL="228600" indent="-228600">
+              <a:lnSpc>
+                <a:spcPct val="110000"/>
+              </a:lnSpc>
+              <a:spcBef>
+                <a:spcPts val="0"/>
+              </a:spcBef>
+              <a:spcAft>
+                <a:spcPts val="1200"/>
+              </a:spcAft>
+              <a:buChar char="•"/>
+            </a:lvl1pPr>
+            <a:lvl2pPr marL="533400" indent="-228600">
+              <a:lnSpc>
+                <a:spcPct val="110000"/>
+              </a:lnSpc>
+              <a:spcBef>
+                <a:spcPts val="0"/>
+              </a:spcBef>
+              <a:spcAft>
+                <a:spcPts val="1200"/>
+              </a:spcAft>
+              <a:buChar char="•"/>
+            </a:lvl2pPr>
+            <a:lvl3pPr marL="838200" indent="-228600">
+              <a:lnSpc>
+                <a:spcPct val="110000"/>
+              </a:lnSpc>
+              <a:spcBef>
+                <a:spcPts val="0"/>
+              </a:spcBef>
+              <a:spcAft>
+                <a:spcPts val="1200"/>
+              </a:spcAft>
+              <a:buChar char="•"/>
+            </a:lvl3pPr>
+            <a:lvl4pPr marL="1143000" indent="-228600">
+              <a:lnSpc>
+                <a:spcPct val="110000"/>
+              </a:lnSpc>
+              <a:spcBef>
+                <a:spcPts val="0"/>
+              </a:spcBef>
+              <a:spcAft>
+                <a:spcPts val="1200"/>
+              </a:spcAft>
+              <a:buChar char="•"/>
+            </a:lvl4pPr>
+            <a:lvl5pPr marL="1447800" indent="-228600">
+              <a:lnSpc>
+                <a:spcPct val="110000"/>
+              </a:lnSpc>
+              <a:spcBef>
+                <a:spcPts val="0"/>
+              </a:spcBef>
+              <a:spcAft>
+                <a:spcPts val="1200"/>
+              </a:spcAft>
+              <a:buChar char="•"/>
+            </a:lvl5pPr>
+            <a:lvl6pPr marL="1752600" indent="-228600">
+              <a:lnSpc>
+                <a:spcPct val="110000"/>
+              </a:lnSpc>
+              <a:spcBef>
+                <a:spcPts val="0"/>
+              </a:spcBef>
+              <a:spcAft>
+                <a:spcPts val="1200"/>
+              </a:spcAft>
+              <a:buChar char="•"/>
+            </a:lvl6pPr>
+            <a:lvl7pPr marL="2057400" indent="-228600">
+              <a:lnSpc>
+                <a:spcPct val="110000"/>
+              </a:lnSpc>
+              <a:spcBef>
+                <a:spcPts val="0"/>
+              </a:spcBef>
+              <a:spcAft>
+                <a:spcPts val="1200"/>
+              </a:spcAft>
+              <a:buChar char="•"/>
+            </a:lvl7pPr>
+            <a:lvl8pPr marL="2362200" indent="-228600">
+              <a:lnSpc>
+                <a:spcPct val="110000"/>
+              </a:lnSpc>
+              <a:spcBef>
+                <a:spcPts val="0"/>
+              </a:spcBef>
+              <a:spcAft>
+                <a:spcPts val="1200"/>
+              </a:spcAft>
+              <a:buChar char="•"/>
+            </a:lvl8pPr>
+            <a:lvl9pPr marL="2667000" indent="-228600">
+              <a:lnSpc>
+                <a:spcPct val="110000"/>
+              </a:lnSpc>
+              <a:spcBef>
+                <a:spcPts val="0"/>
+              </a:spcBef>
+              <a:spcAft>
+                <a:spcPts val="1200"/>
+              </a:spcAft>
+              <a:buChar char="•"/>
+            </a:lvl9pPr>
+          </a:lstStyle>
+          <a:p xmlns:a="http://schemas.openxmlformats.org/drawingml/2006/main"/>
+        </p:txBody>
+      </p:sp>
+    </p:spTree>
+  </p:cSld>
+</p:sldLayout>
+</file>
+
+<file path=ppt/education/slideLayouts/slideLayout5.xml><?xml version="1.0" encoding="utf-8"?>
+<p:sldLayout xmlns:p="http://schemas.openxmlformats.org/presentationml/2006/main">
+  <p:cSld name="Title and One Column">
+    <p:spTree>
+      <p:nvGrpSpPr>
+        <p:cNvPr id="1" name=""/>
+        <p:cNvGrpSpPr/>
+        <p:nvPr/>
+      </p:nvGrpSpPr>
+      <p:grpSpPr>
+        <a:xfrm xmlns:a="http://schemas.openxmlformats.org/drawingml/2006/main"/>
+      </p:grpSpPr>
+      <p:sp>
+        <p:nvSpPr>
+          <p:cNvPr id="3" name="Title">
+            <a:extLst xmlns:a="http://schemas.openxmlformats.org/drawingml/2006/main">
+              <a:ext uri="{FF2B5EF4-FFF2-40B4-BE49-F238E27FC236}">
+                <a16:creationId xmlns:a16="http://schemas.microsoft.com/office/drawing/2014/main" id="{2A49E3AF-112C-4647-A044-EF0F7651B810}"/>
+              </a:ext>
+            </a:extLst>
+          </p:cNvPr>
+          <p:cNvSpPr>
+            <a:spLocks xmlns:a="http://schemas.openxmlformats.org/drawingml/2006/main" noGrp="1"/>
+          </p:cNvSpPr>
+          <p:nvPr>
+            <p:ph type="title" idx="0"/>
+          </p:nvPr>
+        </p:nvSpPr>
+        <p:spPr>
+          <a:xfrm xmlns:a="http://schemas.openxmlformats.org/drawingml/2006/main">
+            <a:off x="685800" y="533400"/>
+            <a:ext cx="10820400" cy="838200"/>
+          </a:xfrm>
+          <a:prstGeom xmlns:a="http://schemas.openxmlformats.org/drawingml/2006/main" prst="rect">
+            <a:avLst/>
+          </a:prstGeom>
+          <a:noFill xmlns:a="http://schemas.openxmlformats.org/drawingml/2006/main"/>
+          <a:ln xmlns:a="http://schemas.openxmlformats.org/drawingml/2006/main">
+            <a:noFill/>
+            <a:prstDash val="solid"/>
+          </a:ln>
+        </p:spPr>
+        <p:txBody>
+          <a:bodyPr xmlns:a="http://schemas.openxmlformats.org/drawingml/2006/main" wrap="square" lIns="0" tIns="0" rIns="0" bIns="0" anchor="t">
+            <a:normAutofit/>
+          </a:bodyPr>
+          <a:lstStyle xmlns:a="http://schemas.openxmlformats.org/drawingml/2006/main">
+            <a:defPPr algn="l">
+              <a:defRPr sz="3300" b="1">
+                <a:solidFill>
+                  <a:schemeClr val="tx1"/>
+                </a:solidFill>
+                <a:latin typeface="+mj-lt"/>
+                <a:ea typeface="+mj-lt"/>
+                <a:cs typeface="+mj-lt"/>
+              </a:defRPr>
+            </a:defPPr>
+            <a:lvl1pPr marL="0" indent="0">
+              <a:lnSpc>
+                <a:spcPct val="110000"/>
+              </a:lnSpc>
+              <a:spcBef>
+                <a:spcPts val="0"/>
+              </a:spcBef>
+              <a:spcAft>
+                <a:spcPts val="0"/>
+              </a:spcAft>
+              <a:buNone/>
+            </a:lvl1pPr>
+            <a:lvl2pPr marL="0" indent="0">
+              <a:lnSpc>
+                <a:spcPct val="110000"/>
+              </a:lnSpc>
+              <a:spcBef>
+                <a:spcPts val="0"/>
+              </a:spcBef>
+              <a:spcAft>
+                <a:spcPts val="0"/>
+              </a:spcAft>
+              <a:buNone/>
+            </a:lvl2pPr>
+            <a:lvl3pPr marL="0" indent="0">
+              <a:lnSpc>
+                <a:spcPct val="110000"/>
+              </a:lnSpc>
+              <a:spcBef>
+                <a:spcPts val="0"/>
+              </a:spcBef>
+              <a:spcAft>
+                <a:spcPts val="0"/>
+              </a:spcAft>
+              <a:buNone/>
+            </a:lvl3pPr>
+            <a:lvl4pPr marL="0" indent="0">
+              <a:lnSpc>
+                <a:spcPct val="110000"/>
+              </a:lnSpc>
+              <a:spcBef>
+                <a:spcPts val="0"/>
+              </a:spcBef>
+              <a:spcAft>
+                <a:spcPts val="0"/>
+              </a:spcAft>
+              <a:buNone/>
+            </a:lvl4pPr>
+            <a:lvl5pPr marL="0" indent="0">
+              <a:lnSpc>
+                <a:spcPct val="110000"/>
+              </a:lnSpc>
+              <a:spcBef>
+                <a:spcPts val="0"/>
+              </a:spcBef>
+              <a:spcAft>
+                <a:spcPts val="0"/>
+              </a:spcAft>
+              <a:buNone/>
+            </a:lvl5pPr>
+            <a:lvl6pPr marL="0" indent="0">
+              <a:lnSpc>
+                <a:spcPct val="110000"/>
+              </a:lnSpc>
+              <a:spcBef>
+                <a:spcPts val="0"/>
+              </a:spcBef>
+              <a:spcAft>
+                <a:spcPts val="0"/>
+              </a:spcAft>
+              <a:buNone/>
+            </a:lvl6pPr>
+            <a:lvl7pPr marL="0" indent="0">
+              <a:lnSpc>
+                <a:spcPct val="110000"/>
+              </a:lnSpc>
+              <a:spcBef>
+                <a:spcPts val="0"/>
+              </a:spcBef>
+              <a:spcAft>
+                <a:spcPts val="0"/>
+              </a:spcAft>
+              <a:buNone/>
+            </a:lvl7pPr>
+            <a:lvl8pPr marL="0" indent="0">
+              <a:lnSpc>
+                <a:spcPct val="110000"/>
+              </a:lnSpc>
+              <a:spcBef>
+                <a:spcPts val="0"/>
+              </a:spcBef>
+              <a:spcAft>
+                <a:spcPts val="0"/>
+              </a:spcAft>
+              <a:buNone/>
+            </a:lvl8pPr>
+            <a:lvl9pPr marL="0" indent="0">
+              <a:lnSpc>
+                <a:spcPct val="110000"/>
+              </a:lnSpc>
+              <a:spcBef>
+                <a:spcPts val="0"/>
+              </a:spcBef>
+              <a:spcAft>
+                <a:spcPts val="0"/>
+              </a:spcAft>
+              <a:buNone/>
+            </a:lvl9pPr>
+          </a:lstStyle>
+          <a:p xmlns:a="http://schemas.openxmlformats.org/drawingml/2006/main"/>
+        </p:txBody>
+      </p:sp>
+      <p:sp>
+        <p:nvSpPr>
+          <p:cNvPr id="2" name="Left column">
+            <a:extLst xmlns:a="http://schemas.openxmlformats.org/drawingml/2006/main">
+              <a:ext uri="{FF2B5EF4-FFF2-40B4-BE49-F238E27FC236}">
+                <a16:creationId xmlns:a16="http://schemas.microsoft.com/office/drawing/2014/main" id="{0E8CF8C3-160F-4345-9254-1CB079A61683}"/>
+              </a:ext>
+            </a:extLst>
+          </p:cNvPr>
+          <p:cNvSpPr>
+            <a:spLocks xmlns:a="http://schemas.openxmlformats.org/drawingml/2006/main" noGrp="1"/>
+          </p:cNvSpPr>
+          <p:nvPr>
+            <p:ph type="body" idx="1"/>
+          </p:nvPr>
+        </p:nvSpPr>
+        <p:spPr>
+          <a:xfrm xmlns:a="http://schemas.openxmlformats.org/drawingml/2006/main">
+            <a:off x="685800" y="1905000"/>
+            <a:ext cx="5029200" cy="4267200"/>
+          </a:xfrm>
+          <a:prstGeom xmlns:a="http://schemas.openxmlformats.org/drawingml/2006/main" prst="rect">
+            <a:avLst/>
+          </a:prstGeom>
+          <a:noFill xmlns:a="http://schemas.openxmlformats.org/drawingml/2006/main"/>
+          <a:ln xmlns:a="http://schemas.openxmlformats.org/drawingml/2006/main">
+            <a:noFill/>
+            <a:prstDash val="solid"/>
+          </a:ln>
+        </p:spPr>
+        <p:txBody>
+          <a:bodyPr xmlns:a="http://schemas.openxmlformats.org/drawingml/2006/main" wrap="square" lIns="0" tIns="0" rIns="0" bIns="0" anchor="t">
+            <a:normAutofit/>
+          </a:bodyPr>
+          <a:lstStyle xmlns:a="http://schemas.openxmlformats.org/drawingml/2006/main">
+            <a:defPPr algn="l">
+              <a:defRPr sz="2250" b="0">
+                <a:solidFill>
+                  <a:schemeClr val="tx1"/>
+                </a:solidFill>
+                <a:latin typeface="+mn-lt"/>
+                <a:ea typeface="+mn-lt"/>
+                <a:cs typeface="+mn-lt"/>
+              </a:defRPr>
+            </a:defPPr>
+            <a:lvl1pPr marL="228600" indent="-228600">
+              <a:lnSpc>
+                <a:spcPct val="110000"/>
+              </a:lnSpc>
+              <a:spcBef>
+                <a:spcPts val="0"/>
+              </a:spcBef>
+              <a:spcAft>
+                <a:spcPts val="1200"/>
+              </a:spcAft>
+              <a:buChar char="•"/>
+            </a:lvl1pPr>
+            <a:lvl2pPr marL="533400" indent="-228600">
+              <a:lnSpc>
+                <a:spcPct val="110000"/>
+              </a:lnSpc>
+              <a:spcBef>
+                <a:spcPts val="0"/>
+              </a:spcBef>
+              <a:spcAft>
+                <a:spcPts val="1200"/>
+              </a:spcAft>
+              <a:buChar char="•"/>
+            </a:lvl2pPr>
+            <a:lvl3pPr marL="838200" indent="-228600">
+              <a:lnSpc>
+                <a:spcPct val="110000"/>
+              </a:lnSpc>
+              <a:spcBef>
+                <a:spcPts val="0"/>
+              </a:spcBef>
+              <a:spcAft>
+                <a:spcPts val="1200"/>
+              </a:spcAft>
+              <a:buChar char="•"/>
+            </a:lvl3pPr>
+            <a:lvl4pPr marL="1143000" indent="-228600">
+              <a:lnSpc>
+                <a:spcPct val="110000"/>
+              </a:lnSpc>
+              <a:spcBef>
+                <a:spcPts val="0"/>
+              </a:spcBef>
+              <a:spcAft>
+                <a:spcPts val="1200"/>
+              </a:spcAft>
+              <a:buChar char="•"/>
+            </a:lvl4pPr>
+            <a:lvl5pPr marL="1447800" indent="-228600">
+              <a:lnSpc>
+                <a:spcPct val="110000"/>
+              </a:lnSpc>
+              <a:spcBef>
+                <a:spcPts val="0"/>
+              </a:spcBef>
+              <a:spcAft>
+                <a:spcPts val="1200"/>
+              </a:spcAft>
+              <a:buChar char="•"/>
+            </a:lvl5pPr>
+            <a:lvl6pPr marL="1752600" indent="-228600">
+              <a:lnSpc>
+                <a:spcPct val="110000"/>
+              </a:lnSpc>
+              <a:spcBef>
+                <a:spcPts val="0"/>
+              </a:spcBef>
+              <a:spcAft>
+                <a:spcPts val="1200"/>
+              </a:spcAft>
+              <a:buChar char="•"/>
+            </a:lvl6pPr>
+            <a:lvl7pPr marL="2057400" indent="-228600">
+              <a:lnSpc>
+                <a:spcPct val="110000"/>
+              </a:lnSpc>
+              <a:spcBef>
+                <a:spcPts val="0"/>
+              </a:spcBef>
+              <a:spcAft>
+                <a:spcPts val="1200"/>
+              </a:spcAft>
+              <a:buChar char="•"/>
+            </a:lvl7pPr>
+            <a:lvl8pPr marL="2362200" indent="-228600">
+              <a:lnSpc>
+                <a:spcPct val="110000"/>
+              </a:lnSpc>
+              <a:spcBef>
+                <a:spcPts val="0"/>
+              </a:spcBef>
+              <a:spcAft>
+                <a:spcPts val="1200"/>
+              </a:spcAft>
+              <a:buChar char="•"/>
+            </a:lvl8pPr>
+            <a:lvl9pPr marL="2667000" indent="-228600">
+              <a:lnSpc>
+                <a:spcPct val="110000"/>
+              </a:lnSpc>
+              <a:spcBef>
+                <a:spcPts val="0"/>
+              </a:spcBef>
+              <a:spcAft>
+                <a:spcPts val="1200"/>
+              </a:spcAft>
+              <a:buChar char="•"/>
+            </a:lvl9pPr>
+          </a:lstStyle>
+          <a:p xmlns:a="http://schemas.openxmlformats.org/drawingml/2006/main"/>
+        </p:txBody>
+      </p:sp>
+    </p:spTree>
+  </p:cSld>
+</p:sldLayout>
+</file>
+
+<file path=ppt/education/slideLayouts/slideLayout6.xml><?xml version="1.0" encoding="utf-8"?>
+<p:sldLayout xmlns:p="http://schemas.openxmlformats.org/presentationml/2006/main" type="blank">
+  <p:cSld name="Blank">
+    <p:spTree>
+      <p:nvGrpSpPr>
+        <p:cNvPr id="1" name=""/>
+        <p:cNvGrpSpPr/>
+        <p:nvPr/>
+      </p:nvGrpSpPr>
+      <p:grpSpPr>
+        <a:xfrm xmlns:a="http://schemas.openxmlformats.org/drawingml/2006/main"/>
+      </p:grpSpPr>
+    </p:spTree>
+  </p:cSld>
+</p:sldLayout>
+</file>
+
+<file path=ppt/education/slideMasters/slideMaster1.xml><?xml version="1.0" encoding="utf-8"?>
+<p:sldMaster xmlns:p="http://schemas.openxmlformats.org/presentationml/2006/main">
+  <p:cSld name="Master">
+    <p:bg>
+      <p:bgRef idx="1001">
+        <a:schemeClr xmlns:a="http://schemas.openxmlformats.org/drawingml/2006/main" val="bg1"/>
+      </p:bgRef>
+    </p:bg>
+    <p:spTree>
+      <p:nvGrpSpPr>
+        <p:cNvPr id="1" name=""/>
+        <p:cNvGrpSpPr/>
+        <p:nvPr/>
+      </p:nvGrpSpPr>
+      <p:grpSpPr>
+        <a:xfrm xmlns:a="http://schemas.openxmlformats.org/drawingml/2006/main"/>
+      </p:grpSpPr>
+    </p:spTree>
+  </p:cSld>
+  <p:clrMap bg1="lt1" tx1="dk1" bg2="lt2" tx2="dk2" accent1="accent1" accent2="accent2" accent3="accent3" accent4="accent4" accent5="accent5" accent6="accent6" hlink="hlink" folHlink="folHlink"/>
+  <p:sldLayoutIdLst>
+    <p:sldLayoutId xmlns:r="http://schemas.openxmlformats.org/officeDocument/2006/relationships" id="2147483649" r:id="R77d258eeede346dc"/>
+    <p:sldLayoutId xmlns:r="http://schemas.openxmlformats.org/officeDocument/2006/relationships" id="2147483650" r:id="Ra29607ae12674cb1"/>
+    <p:sldLayoutId xmlns:r="http://schemas.openxmlformats.org/officeDocument/2006/relationships" id="2147483651" r:id="Rc0012fb074194888"/>
+    <p:sldLayoutId xmlns:r="http://schemas.openxmlformats.org/officeDocument/2006/relationships" id="2147483652" r:id="R240a1c8fb294468b"/>
+    <p:sldLayoutId xmlns:r="http://schemas.openxmlformats.org/officeDocument/2006/relationships" id="2147483653" r:id="Rdafe99eda13b4e2a"/>
+    <p:sldLayoutId xmlns:r="http://schemas.openxmlformats.org/officeDocument/2006/relationships" id="2147483654" r:id="R02d83a30736c4a7d"/>
+  </p:sldLayoutIdLst>
+  <p:txStyles>
+    <p:titleStyle>
+      <a:lvl1pPr xmlns:a="http://schemas.openxmlformats.org/drawingml/2006/main" algn="l">
+        <a:lnSpc>
+          <a:spcPct val="90000"/>
+        </a:lnSpc>
+        <a:spcBef>
+          <a:spcPts val="0"/>
+        </a:spcBef>
+        <a:buNone/>
+        <a:defRPr sz="4400">
+          <a:solidFill>
+            <a:schemeClr val="tx1"/>
+          </a:solidFill>
+          <a:latin typeface="+mj-lt"/>
+          <a:ea typeface="+mj-lt"/>
+          <a:cs typeface="+mj-lt"/>
+        </a:defRPr>
+      </a:lvl1pPr>
+    </p:titleStyle>
+    <p:bodyStyle>
+      <a:lvl1pPr xmlns:a="http://schemas.openxmlformats.org/drawingml/2006/main" marL="228600" indent="-228600" algn="l">
+        <a:lnSpc>
+          <a:spcPct val="90000"/>
+        </a:lnSpc>
+        <a:spcBef>
+          <a:spcPts val="1000"/>
+        </a:spcBef>
+        <a:buChar char="•"/>
+        <a:defRPr sz="2800">
+          <a:solidFill>
+            <a:schemeClr val="tx1"/>
+          </a:solidFill>
+          <a:latin typeface="+mn-lt"/>
+          <a:ea typeface="+mn-lt"/>
+          <a:cs typeface="+mn-lt"/>
+        </a:defRPr>
+      </a:lvl1pPr>
+      <a:lvl2pPr xmlns:a="http://schemas.openxmlformats.org/drawingml/2006/main" marL="685800" indent="-228600" algn="l">
+        <a:lnSpc>
+          <a:spcPct val="90000"/>
+        </a:lnSpc>
+        <a:spcBef>
+          <a:spcPts val="500"/>
+        </a:spcBef>
+        <a:buChar char="•"/>
+        <a:defRPr sz="2400">
+          <a:solidFill>
+            <a:schemeClr val="tx1"/>
+          </a:solidFill>
+          <a:latin typeface="+mn-lt"/>
+          <a:ea typeface="+mn-lt"/>
+          <a:cs typeface="+mn-lt"/>
+        </a:defRPr>
+      </a:lvl2pPr>
+      <a:lvl3pPr xmlns:a="http://schemas.openxmlformats.org/drawingml/2006/main" marL="1143000" indent="-228600" algn="l">
+        <a:lnSpc>
+          <a:spcPct val="90000"/>
+        </a:lnSpc>
+        <a:spcBef>
+          <a:spcPts val="500"/>
+        </a:spcBef>
+        <a:buChar char="•"/>
+        <a:defRPr sz="2000">
+          <a:solidFill>
+            <a:schemeClr val="tx1"/>
+          </a:solidFill>
+          <a:latin typeface="+mn-lt"/>
+          <a:ea typeface="+mn-lt"/>
+          <a:cs typeface="+mn-lt"/>
+        </a:defRPr>
+      </a:lvl3pPr>
+      <a:lvl4pPr xmlns:a="http://schemas.openxmlformats.org/drawingml/2006/main" marL="1600200" indent="-228600" algn="l">
+        <a:lnSpc>
+          <a:spcPct val="90000"/>
+        </a:lnSpc>
+        <a:spcBef>
+          <a:spcPts val="500"/>
+        </a:spcBef>
+        <a:buChar char="•"/>
+        <a:defRPr sz="1800">
+          <a:solidFill>
+            <a:schemeClr val="tx1"/>
+          </a:solidFill>
+          <a:latin typeface="+mn-lt"/>
+          <a:ea typeface="+mn-lt"/>
+          <a:cs typeface="+mn-lt"/>
+        </a:defRPr>
+      </a:lvl4pPr>
+      <a:lvl5pPr xmlns:a="http://schemas.openxmlformats.org/drawingml/2006/main" marL="2057400" indent="-228600" algn="l">
+        <a:lnSpc>
+          <a:spcPct val="90000"/>
+        </a:lnSpc>
+        <a:spcBef>
+          <a:spcPts val="500"/>
+        </a:spcBef>
+        <a:buChar char="•"/>
+        <a:defRPr sz="1800">
+          <a:solidFill>
+            <a:schemeClr val="tx1"/>
+          </a:solidFill>
+          <a:latin typeface="+mn-lt"/>
+          <a:ea typeface="+mn-lt"/>
+          <a:cs typeface="+mn-lt"/>
+        </a:defRPr>
+      </a:lvl5pPr>
+      <a:lvl6pPr xmlns:a="http://schemas.openxmlformats.org/drawingml/2006/main" marL="2514600" indent="-228600" algn="l">
+        <a:lnSpc>
+          <a:spcPct val="90000"/>
+        </a:lnSpc>
+        <a:spcBef>
+          <a:spcPts val="500"/>
+        </a:spcBef>
+        <a:buChar char="•"/>
+        <a:defRPr sz="1800">
+          <a:solidFill>
+            <a:schemeClr val="tx1"/>
+          </a:solidFill>
+          <a:latin typeface="+mn-lt"/>
+          <a:ea typeface="+mn-lt"/>
+          <a:cs typeface="+mn-lt"/>
+        </a:defRPr>
+      </a:lvl6pPr>
+      <a:lvl7pPr xmlns:a="http://schemas.openxmlformats.org/drawingml/2006/main" marL="2971800" indent="-228600" algn="l">
+        <a:lnSpc>
+          <a:spcPct val="90000"/>
+        </a:lnSpc>
+        <a:spcBef>
+          <a:spcPts val="500"/>
+        </a:spcBef>
+        <a:buChar char="•"/>
+        <a:defRPr sz="1800">
+          <a:solidFill>
+            <a:schemeClr val="tx1"/>
+          </a:solidFill>
+          <a:latin typeface="+mn-lt"/>
+          <a:ea typeface="+mn-lt"/>
+          <a:cs typeface="+mn-lt"/>
+        </a:defRPr>
+      </a:lvl7pPr>
+      <a:lvl8pPr xmlns:a="http://schemas.openxmlformats.org/drawingml/2006/main" marL="3429000" indent="-228600" algn="l">
+        <a:lnSpc>
+          <a:spcPct val="90000"/>
+        </a:lnSpc>
+        <a:spcBef>
+          <a:spcPts val="500"/>
+        </a:spcBef>
+        <a:buChar char="•"/>
+        <a:defRPr sz="1800">
+          <a:solidFill>
+            <a:schemeClr val="tx1"/>
+          </a:solidFill>
+          <a:latin typeface="+mn-lt"/>
+          <a:ea typeface="+mn-lt"/>
+          <a:cs typeface="+mn-lt"/>
+        </a:defRPr>
+      </a:lvl8pPr>
+      <a:lvl9pPr xmlns:a="http://schemas.openxmlformats.org/drawingml/2006/main" marL="3886200" indent="-228600" algn="l">
+        <a:lnSpc>
+          <a:spcPct val="90000"/>
+        </a:lnSpc>
+        <a:spcBef>
+          <a:spcPts val="500"/>
+        </a:spcBef>
+        <a:buChar char="•"/>
+        <a:defRPr sz="1800">
+          <a:solidFill>
+            <a:schemeClr val="tx1"/>
+          </a:solidFill>
+          <a:latin typeface="+mn-lt"/>
+          <a:ea typeface="+mn-lt"/>
+          <a:cs typeface="+mn-lt"/>
+        </a:defRPr>
+      </a:lvl9pPr>
+    </p:bodyStyle>
+    <p:otherStyle>
+      <a:lvl1pPr xmlns:a="http://schemas.openxmlformats.org/drawingml/2006/main" marL="0" algn="l">
+        <a:buNone/>
+        <a:defRPr sz="1800">
+          <a:solidFill>
+            <a:schemeClr val="tx1"/>
+          </a:solidFill>
+          <a:latin typeface="+mn-lt"/>
+          <a:ea typeface="+mn-lt"/>
+          <a:cs typeface="+mn-lt"/>
+        </a:defRPr>
+      </a:lvl1pPr>
+      <a:lvl2pPr xmlns:a="http://schemas.openxmlformats.org/drawingml/2006/main" marL="457200" algn="l">
+        <a:buNone/>
+        <a:defRPr sz="1800">
+          <a:solidFill>
+            <a:schemeClr val="tx1"/>
+          </a:solidFill>
+          <a:latin typeface="+mn-lt"/>
+          <a:ea typeface="+mn-lt"/>
+          <a:cs typeface="+mn-lt"/>
+        </a:defRPr>
+      </a:lvl2pPr>
+      <a:lvl3pPr xmlns:a="http://schemas.openxmlformats.org/drawingml/2006/main" marL="914400" algn="l">
+        <a:buNone/>
+        <a:defRPr sz="1800">
+          <a:solidFill>
+            <a:schemeClr val="tx1"/>
+          </a:solidFill>
+          <a:latin typeface="+mn-lt"/>
+          <a:ea typeface="+mn-lt"/>
+          <a:cs typeface="+mn-lt"/>
+        </a:defRPr>
+      </a:lvl3pPr>
+      <a:lvl4pPr xmlns:a="http://schemas.openxmlformats.org/drawingml/2006/main" marL="1371600" algn="l">
+        <a:buNone/>
+        <a:defRPr sz="1800">
+          <a:solidFill>
+            <a:schemeClr val="tx1"/>
+          </a:solidFill>
+          <a:latin typeface="+mn-lt"/>
+          <a:ea typeface="+mn-lt"/>
+          <a:cs typeface="+mn-lt"/>
+        </a:defRPr>
+      </a:lvl4pPr>
+      <a:lvl5pPr xmlns:a="http://schemas.openxmlformats.org/drawingml/2006/main" marL="1828800" algn="l">
+        <a:buNone/>
+        <a:defRPr sz="1800">
+          <a:solidFill>
+            <a:schemeClr val="tx1"/>
+          </a:solidFill>
+          <a:latin typeface="+mn-lt"/>
+          <a:ea typeface="+mn-lt"/>
+          <a:cs typeface="+mn-lt"/>
+        </a:defRPr>
+      </a:lvl5pPr>
+      <a:lvl6pPr xmlns:a="http://schemas.openxmlformats.org/drawingml/2006/main" marL="2286000" algn="l">
+        <a:buNone/>
+        <a:defRPr sz="1800">
+          <a:solidFill>
+            <a:schemeClr val="tx1"/>
+          </a:solidFill>
+          <a:latin typeface="+mn-lt"/>
+          <a:ea typeface="+mn-lt"/>
+          <a:cs typeface="+mn-lt"/>
+        </a:defRPr>
+      </a:lvl6pPr>
+      <a:lvl7pPr xmlns:a="http://schemas.openxmlformats.org/drawingml/2006/main" marL="2743200" algn="l">
+        <a:buNone/>
+        <a:defRPr sz="1800">
+          <a:solidFill>
+            <a:schemeClr val="tx1"/>
+          </a:solidFill>
+          <a:latin typeface="+mn-lt"/>
+          <a:ea typeface="+mn-lt"/>
+          <a:cs typeface="+mn-lt"/>
+        </a:defRPr>
+      </a:lvl7pPr>
+      <a:lvl8pPr xmlns:a="http://schemas.openxmlformats.org/drawingml/2006/main" marL="3200400" algn="l">
+        <a:buNone/>
+        <a:defRPr sz="1800">
+          <a:solidFill>
+            <a:schemeClr val="tx1"/>
+          </a:solidFill>
+          <a:latin typeface="+mn-lt"/>
+          <a:ea typeface="+mn-lt"/>
+          <a:cs typeface="+mn-lt"/>
+        </a:defRPr>
+      </a:lvl8pPr>
+      <a:lvl9pPr xmlns:a="http://schemas.openxmlformats.org/drawingml/2006/main" marL="3657600" algn="l">
+        <a:buNone/>
+        <a:defRPr sz="1800">
+          <a:solidFill>
+            <a:schemeClr val="tx1"/>
+          </a:solidFill>
+          <a:latin typeface="+mn-lt"/>
+          <a:ea typeface="+mn-lt"/>
+          <a:cs typeface="+mn-lt"/>
+        </a:defRPr>
+      </a:lvl9pPr>
+    </p:otherStyle>
+  </p:txStyles>
+</p:sldMaster>
+</file>
+
+<file path=ppt/education/slideMasters/theme/theme2.xml><?xml version="1.0" encoding="utf-8"?>
+<a:theme xmlns:a="http://schemas.openxmlformats.org/drawingml/2006/main" name="ChatGPT">
+  <a:themeElements>
+    <a:clrScheme name="ChatGPT">
+      <a:dk1>
+        <a:srgbClr val="000000"/>
+      </a:dk1>
+      <a:lt1>
+        <a:srgbClr val="FFFFFF"/>
+      </a:lt1>
+      <a:dk2>
+        <a:srgbClr val="0E2841"/>
+      </a:dk2>
+      <a:lt2>
+        <a:srgbClr val="E8E8E8"/>
+      </a:lt2>
+      <a:accent1>
+        <a:srgbClr val="156082"/>
+      </a:accent1>
+      <a:accent2>
+        <a:srgbClr val="E97132"/>
+      </a:accent2>
+      <a:accent3>
+        <a:srgbClr val="196B24"/>
+      </a:accent3>
+      <a:accent4>
+        <a:srgbClr val="0F9ED5"/>
+      </a:accent4>
+      <a:accent5>
+        <a:srgbClr val="A02B93"/>
+      </a:accent5>
+      <a:accent6>
+        <a:srgbClr val="4EA72E"/>
+      </a:accent6>
+      <a:hlink>
+        <a:srgbClr val="467886"/>
+      </a:hlink>
+      <a:folHlink>
+        <a:srgbClr val="96607D"/>
+      </a:folHlink>
+    </a:clrScheme>
+    <a:fontScheme name="">
+      <a:majorFont>
+        <a:latin typeface="Aptos"/>
+        <a:ea typeface=""/>
+        <a:cs typeface=""/>
+      </a:majorFont>
+      <a:minorFont>
+        <a:latin typeface="Aptos"/>
+        <a:ea typeface=""/>
+        <a:cs typeface=""/>
+      </a:minorFont>
+    </a:fontScheme>
+    <a:fmtScheme name="ChatGPT">
+      <a:fillStyleLst>
+        <a:solidFill>
+          <a:schemeClr val="phClr"/>
+        </a:solidFill>
+        <a:gradFill>
+          <a:gsLst>
+            <a:gs pos="0">
+              <a:schemeClr val="phClr">
+                <a:tint val="67000"/>
+                <a:lumMod val="110000"/>
+                <a:satMod val="105000"/>
+              </a:schemeClr>
+            </a:gs>
+            <a:gs pos="50000">
+              <a:schemeClr val="phClr">
+                <a:tint val="73000"/>
+                <a:lumMod val="105000"/>
+                <a:satMod val="103000"/>
+              </a:schemeClr>
+            </a:gs>
+            <a:gs pos="100000">
+              <a:schemeClr val="phClr">
+                <a:tint val="81000"/>
+                <a:lumMod val="105000"/>
+                <a:satMod val="109000"/>
+              </a:schemeClr>
+            </a:gs>
+          </a:gsLst>
+          <a:lin ang="5400000" scaled="0"/>
+        </a:gradFill>
+        <a:gradFill>
+          <a:gsLst>
+            <a:gs pos="0">
+              <a:schemeClr val="phClr">
+                <a:tint val="94000"/>
+                <a:lumMod val="102000"/>
+                <a:satMod val="103000"/>
+              </a:schemeClr>
+            </a:gs>
+            <a:gs pos="50000">
+              <a:schemeClr val="phClr">
+                <a:shade val="100000"/>
+                <a:lumMod val="100000"/>
+                <a:satMod val="110000"/>
+              </a:schemeClr>
+            </a:gs>
+            <a:gs pos="100000">
+              <a:schemeClr val="phClr">
+                <a:shade val="78000"/>
+                <a:lumMod val="99000"/>
+                <a:satMod val="120000"/>
+              </a:schemeClr>
+            </a:gs>
+          </a:gsLst>
+          <a:lin ang="5400000" scaled="0"/>
+        </a:gradFill>
+      </a:fillStyleLst>
+      <a:lnStyleLst>
+        <a:ln w="12700">
+          <a:solidFill>
+            <a:schemeClr val="phClr"/>
+          </a:solidFill>
+          <a:prstDash val="solid"/>
+        </a:ln>
+        <a:ln w="19050">
+          <a:solidFill>
+            <a:schemeClr val="phClr"/>
+          </a:solidFill>
+          <a:prstDash val="solid"/>
+        </a:ln>
+        <a:ln w="25400">
+          <a:solidFill>
+            <a:schemeClr val="phClr"/>
+          </a:solidFill>
+          <a:prstDash val="solid"/>
+        </a:ln>
+      </a:lnStyleLst>
+      <a:effectStyleLst>
+        <a:effectStyle>
+          <a:effectLst/>
+        </a:effectStyle>
+        <a:effectStyle>
+          <a:effectLst/>
+        </a:effectStyle>
+        <a:effectStyle>
+          <a:effectLst>
+            <a:outerShdw blurRad="57150" dist="19050" dir="5400000">
+              <a:srgbClr val="000000">
+                <a:alpha val="16000"/>
+              </a:srgbClr>
+            </a:outerShdw>
+          </a:effectLst>
+        </a:effectStyle>
+        <a:effectStyle>
+          <a:effectLst>
+            <a:outerShdw blurRad="19050" dist="9525" dir="5400000">
+              <a:srgbClr val="000000">
+                <a:alpha val="6000"/>
+              </a:srgbClr>
+            </a:outerShdw>
+          </a:effectLst>
+        </a:effectStyle>
+        <a:effectStyle>
+          <a:effectLst>
+            <a:outerShdw blurRad="28575" dist="9525" dir="5400000">
+              <a:srgbClr val="000000">
+                <a:alpha val="8000"/>
+              </a:srgbClr>
+            </a:outerShdw>
+          </a:effectLst>
+        </a:effectStyle>
+        <a:effectStyle>
+          <a:effectLst>
+            <a:outerShdw blurRad="57150" dist="19050" dir="5400000">
+              <a:srgbClr val="000000">
+                <a:alpha val="10000"/>
+              </a:srgbClr>
+            </a:outerShdw>
+          </a:effectLst>
+        </a:effectStyle>
+        <a:effectStyle>
+          <a:effectLst>
+            <a:outerShdw blurRad="114300" dist="38100" dir="5400000">
+              <a:srgbClr val="000000">
+                <a:alpha val="12000"/>
+              </a:srgbClr>
+            </a:outerShdw>
+          </a:effectLst>
+        </a:effectStyle>
+        <a:effectStyle>
+          <a:effectLst>
+            <a:outerShdw blurRad="171450" dist="57150" dir="5400000">
+              <a:srgbClr val="000000">
+                <a:alpha val="16000"/>
+              </a:srgbClr>
+            </a:outerShdw>
+          </a:effectLst>
+        </a:effectStyle>
+        <a:effectStyle>
+          <a:effectLst>
+            <a:outerShdw blurRad="266700" dist="95250" dir="5400000">
+              <a:srgbClr val="000000">
+                <a:alpha val="24000"/>
+              </a:srgbClr>
+            </a:outerShdw>
+          </a:effectLst>
+        </a:effectStyle>
+      </a:effectStyleLst>
+      <a:bgFillStyleLst>
+        <a:solidFill>
+          <a:schemeClr val="phClr"/>
+        </a:solidFill>
+        <a:solidFill>
+          <a:schemeClr val="phClr">
+            <a:tint val="95000"/>
+            <a:satMod val="170000"/>
+          </a:schemeClr>
+        </a:solidFill>
+        <a:gradFill>
+          <a:gsLst>
+            <a:gs pos="0">
+              <a:schemeClr val="phClr">
+                <a:tint val="93000"/>
+                <a:shade val="98000"/>
+                <a:lumMod val="102000"/>
+                <a:satMod val="150000"/>
+              </a:schemeClr>
+            </a:gs>
+            <a:gs pos="50000">
+              <a:schemeClr val="phClr">
+                <a:tint val="98000"/>
+                <a:shade val="90000"/>
+                <a:lumMod val="103000"/>
+                <a:satMod val="130000"/>
+              </a:schemeClr>
+            </a:gs>
+            <a:gs pos="100000">
+              <a:schemeClr val="phClr">
+                <a:shade val="63000"/>
+                <a:satMod val="120000"/>
+              </a:schemeClr>
+            </a:gs>
+          </a:gsLst>
+          <a:lin ang="5400000" scaled="0"/>
+        </a:gradFill>
+      </a:bgFillStyleLst>
+    </a:fmtScheme>
+  </a:themeElements>
+</a:theme>
+</file>
+
+<file path=ppt/education/tableStyles.xml><?xml version="1.0" encoding="utf-8"?>
+<a:tblStyleLst xmlns:a="http://schemas.openxmlformats.org/drawingml/2006/main" def="{5C22544A-7EE6-4342-B048-85BDC9FD1C3A}"/>
+</file>
+
+<file path=ppt/education/theme/theme1.xml><?xml version="1.0" encoding="utf-8"?>
+<a:theme xmlns:a="http://schemas.openxmlformats.org/drawingml/2006/main" name="ChatGPT">
+  <a:themeElements>
+    <a:clrScheme name="ChatGPT">
+      <a:dk1>
+        <a:srgbClr val="000000"/>
+      </a:dk1>
+      <a:lt1>
+        <a:srgbClr val="FFFFFF"/>
+      </a:lt1>
+      <a:dk2>
+        <a:srgbClr val="0E2841"/>
+      </a:dk2>
+      <a:lt2>
+        <a:srgbClr val="E8E8E8"/>
+      </a:lt2>
+      <a:accent1>
+        <a:srgbClr val="156082"/>
+      </a:accent1>
+      <a:accent2>
+        <a:srgbClr val="E97132"/>
+      </a:accent2>
+      <a:accent3>
+        <a:srgbClr val="196B24"/>
+      </a:accent3>
+      <a:accent4>
+        <a:srgbClr val="0F9ED5"/>
+      </a:accent4>
+      <a:accent5>
+        <a:srgbClr val="A02B93"/>
+      </a:accent5>
+      <a:accent6>
+        <a:srgbClr val="4EA72E"/>
+      </a:accent6>
+      <a:hlink>
+        <a:srgbClr val="467886"/>
+      </a:hlink>
+      <a:folHlink>
+        <a:srgbClr val="96607D"/>
+      </a:folHlink>
+    </a:clrScheme>
+    <a:fontScheme name="">
+      <a:majorFont>
+        <a:latin typeface="Aptos"/>
+        <a:ea typeface=""/>
+        <a:cs typeface=""/>
+      </a:majorFont>
+      <a:minorFont>
+        <a:latin typeface="Aptos"/>
+        <a:ea typeface=""/>
+        <a:cs typeface=""/>
+      </a:minorFont>
+    </a:fontScheme>
+    <a:fmtScheme name="ChatGPT">
+      <a:fillStyleLst>
+        <a:solidFill>
+          <a:schemeClr val="phClr"/>
+        </a:solidFill>
+        <a:gradFill>
+          <a:gsLst>
+            <a:gs pos="0">
+              <a:schemeClr val="phClr">
+                <a:tint val="67000"/>
+                <a:lumMod val="110000"/>
+                <a:satMod val="105000"/>
+              </a:schemeClr>
+            </a:gs>
+            <a:gs pos="50000">
+              <a:schemeClr val="phClr">
+                <a:tint val="73000"/>
+                <a:lumMod val="105000"/>
+                <a:satMod val="103000"/>
+              </a:schemeClr>
+            </a:gs>
+            <a:gs pos="100000">
+              <a:schemeClr val="phClr">
+                <a:tint val="81000"/>
+                <a:lumMod val="105000"/>
+                <a:satMod val="109000"/>
+              </a:schemeClr>
+            </a:gs>
+          </a:gsLst>
+          <a:lin ang="5400000" scaled="0"/>
+        </a:gradFill>
+        <a:gradFill>
+          <a:gsLst>
+            <a:gs pos="0">
+              <a:schemeClr val="phClr">
+                <a:tint val="94000"/>
+                <a:lumMod val="102000"/>
+                <a:satMod val="103000"/>
+              </a:schemeClr>
+            </a:gs>
+            <a:gs pos="50000">
+              <a:schemeClr val="phClr">
+                <a:shade val="100000"/>
+                <a:lumMod val="100000"/>
+                <a:satMod val="110000"/>
+              </a:schemeClr>
+            </a:gs>
+            <a:gs pos="100000">
+              <a:schemeClr val="phClr">
+                <a:shade val="78000"/>
+                <a:lumMod val="99000"/>
+                <a:satMod val="120000"/>
+              </a:schemeClr>
+            </a:gs>
+          </a:gsLst>
+          <a:lin ang="5400000" scaled="0"/>
+        </a:gradFill>
+      </a:fillStyleLst>
+      <a:lnStyleLst>
+        <a:ln w="12700">
+          <a:solidFill>
+            <a:schemeClr val="phClr"/>
+          </a:solidFill>
+          <a:prstDash val="solid"/>
+        </a:ln>
+        <a:ln w="19050">
+          <a:solidFill>
+            <a:schemeClr val="phClr"/>
+          </a:solidFill>
+          <a:prstDash val="solid"/>
+        </a:ln>
+        <a:ln w="25400">
+          <a:solidFill>
+            <a:schemeClr val="phClr"/>
+          </a:solidFill>
+          <a:prstDash val="solid"/>
+        </a:ln>
+      </a:lnStyleLst>
+      <a:effectStyleLst>
+        <a:effectStyle>
+          <a:effectLst/>
+        </a:effectStyle>
+        <a:effectStyle>
+          <a:effectLst/>
+        </a:effectStyle>
+        <a:effectStyle>
+          <a:effectLst>
+            <a:outerShdw blurRad="57150" dist="19050" dir="5400000">
+              <a:srgbClr val="000000">
+                <a:alpha val="16000"/>
+              </a:srgbClr>
+            </a:outerShdw>
+          </a:effectLst>
+        </a:effectStyle>
+        <a:effectStyle>
+          <a:effectLst>
+            <a:outerShdw blurRad="19050" dist="9525" dir="5400000">
+              <a:srgbClr val="000000">
+                <a:alpha val="6000"/>
+              </a:srgbClr>
+            </a:outerShdw>
+          </a:effectLst>
+        </a:effectStyle>
+        <a:effectStyle>
+          <a:effectLst>
+            <a:outerShdw blurRad="28575" dist="9525" dir="5400000">
+              <a:srgbClr val="000000">
+                <a:alpha val="8000"/>
+              </a:srgbClr>
+            </a:outerShdw>
+          </a:effectLst>
+        </a:effectStyle>
+        <a:effectStyle>
+          <a:effectLst>
+            <a:outerShdw blurRad="57150" dist="19050" dir="5400000">
+              <a:srgbClr val="000000">
+                <a:alpha val="10000"/>
+              </a:srgbClr>
+            </a:outerShdw>
+          </a:effectLst>
+        </a:effectStyle>
+        <a:effectStyle>
+          <a:effectLst>
+            <a:outerShdw blurRad="114300" dist="38100" dir="5400000">
+              <a:srgbClr val="000000">
+                <a:alpha val="12000"/>
+              </a:srgbClr>
+            </a:outerShdw>
+          </a:effectLst>
+        </a:effectStyle>
+        <a:effectStyle>
+          <a:effectLst>
+            <a:outerShdw blurRad="171450" dist="57150" dir="5400000">
+              <a:srgbClr val="000000">
+                <a:alpha val="16000"/>
+              </a:srgbClr>
+            </a:outerShdw>
+          </a:effectLst>
+        </a:effectStyle>
+        <a:effectStyle>
+          <a:effectLst>
+            <a:outerShdw blurRad="266700" dist="95250" dir="5400000">
+              <a:srgbClr val="000000">
+                <a:alpha val="24000"/>
+              </a:srgbClr>
+            </a:outerShdw>
+          </a:effectLst>
+        </a:effectStyle>
+      </a:effectStyleLst>
+      <a:bgFillStyleLst>
+        <a:solidFill>
+          <a:schemeClr val="phClr"/>
+        </a:solidFill>
+        <a:solidFill>
+          <a:schemeClr val="phClr">
+            <a:tint val="95000"/>
+            <a:satMod val="170000"/>
+          </a:schemeClr>
+        </a:solidFill>
+        <a:gradFill>
+          <a:gsLst>
+            <a:gs pos="0">
+              <a:schemeClr val="phClr">
+                <a:tint val="93000"/>
+                <a:shade val="98000"/>
+                <a:lumMod val="102000"/>
+                <a:satMod val="150000"/>
+              </a:schemeClr>
+            </a:gs>
+            <a:gs pos="50000">
+              <a:schemeClr val="phClr">
+                <a:tint val="98000"/>
+                <a:shade val="90000"/>
+                <a:lumMod val="103000"/>
+                <a:satMod val="130000"/>
+              </a:schemeClr>
+            </a:gs>
+            <a:gs pos="100000">
+              <a:schemeClr val="phClr">
+                <a:shade val="63000"/>
+                <a:satMod val="120000"/>
+              </a:schemeClr>
+            </a:gs>
+          </a:gsLst>
+          <a:lin ang="5400000" scaled="0"/>
+        </a:gradFill>
+      </a:bgFillStyleLst>
+    </a:fmtScheme>
+  </a:themeElements>
+</a:theme>
+</file>
+
 <file path=ppt/slideLayouts/slideLayout1.xml><?xml version="1.0" encoding="utf-8"?>
 <p:sldLayout xmlns:p="http://schemas.openxmlformats.org/presentationml/2006/main" type="title">
   <p:cSld name="Title Slide">
@@ -6124,7 +8616,7 @@
                 <a:ea typeface="Arial"/>
                 <a:cs typeface="Arial"/>
               </a:rPr>
-              <a:t>10</a:t>
+              <a:t>11</a:t>
             </a:r>
           </a:p>
         </p:txBody>
@@ -6606,7 +9098,7 @@
                 <a:ea typeface="Arial"/>
                 <a:cs typeface="Arial"/>
               </a:rPr>
-              <a:t>11</a:t>
+              <a:t>12</a:t>
             </a:r>
           </a:p>
         </p:txBody>
@@ -7520,7 +10012,7 @@
                 <a:ea typeface="Arial"/>
                 <a:cs typeface="Arial"/>
               </a:rPr>
-              <a:t>12</a:t>
+              <a:t>13</a:t>
             </a:r>
           </a:p>
         </p:txBody>
@@ -8801,7 +11293,7 @@
                 <a:ea typeface="Arial"/>
                 <a:cs typeface="Arial"/>
               </a:rPr>
-              <a:t>14</a:t>
+              <a:t>15</a:t>
             </a:r>
           </a:p>
         </p:txBody>
@@ -9130,7 +11622,7 @@
                 <a:ea typeface="Arial"/>
                 <a:cs typeface="Arial"/>
               </a:rPr>
-              <a:t>15</a:t>
+              <a:t>16</a:t>
             </a:r>
           </a:p>
         </p:txBody>
@@ -9459,7 +11951,7 @@
                 <a:ea typeface="Arial"/>
                 <a:cs typeface="Arial"/>
               </a:rPr>
-              <a:t>16</a:t>
+              <a:t>17</a:t>
             </a:r>
           </a:p>
         </p:txBody>
@@ -9788,7 +12280,7 @@
                 <a:ea typeface="Arial"/>
                 <a:cs typeface="Arial"/>
               </a:rPr>
-              <a:t>17</a:t>
+              <a:t>18</a:t>
             </a:r>
           </a:p>
         </p:txBody>
@@ -10117,7 +12609,7 @@
                 <a:ea typeface="Arial"/>
                 <a:cs typeface="Arial"/>
               </a:rPr>
-              <a:t>18</a:t>
+              <a:t>19</a:t>
             </a:r>
           </a:p>
         </p:txBody>
@@ -10126,6 +12618,670 @@
     <p:extLst>
       <p:ext uri="{BB962C8B-B14F-4D97-AF65-F5344CB8AC3E}">
         <p14:creationId xmlns:p14="http://schemas.microsoft.com/office/powerpoint/2010/main" val="846569595"/>
+      </p:ext>
+    </p:extLst>
+  </p:cSld>
+</p:sld>
+</file>
+
+<file path=ppt/slides/slide19.xml><?xml version="1.0" encoding="utf-8"?>
+<p:sld xmlns:p="http://schemas.openxmlformats.org/presentationml/2006/main">
+  <p:cSld>
+    <p:bg>
+      <p:bgPr>
+        <a:solidFill xmlns:a="http://schemas.openxmlformats.org/drawingml/2006/main">
+          <a:srgbClr val="F6F3EB"/>
+        </a:solidFill>
+      </p:bgPr>
+    </p:bg>
+    <p:spTree>
+      <p:nvGrpSpPr>
+        <p:cNvPr id="1" name=""/>
+        <p:cNvGrpSpPr/>
+        <p:nvPr/>
+      </p:nvGrpSpPr>
+      <p:grpSpPr>
+        <a:xfrm xmlns:a="http://schemas.openxmlformats.org/drawingml/2006/main"/>
+      </p:grpSpPr>
+      <p:sp>
+        <p:nvSpPr>
+          <p:cNvPr id="10" name="education-text-1">
+            <a:extLst xmlns:a="http://schemas.openxmlformats.org/drawingml/2006/main">
+              <a:ext uri="{FF2B5EF4-FFF2-40B4-BE49-F238E27FC236}">
+                <a16:creationId xmlns:a16="http://schemas.microsoft.com/office/drawing/2014/main" id="{4B73C685-2362-4294-8082-3CDAB32F41EF}"/>
+              </a:ext>
+            </a:extLst>
+          </p:cNvPr>
+          <p:cNvSpPr>
+            <a:spLocks xmlns:a="http://schemas.openxmlformats.org/drawingml/2006/main" noGrp="1"/>
+          </p:cNvSpPr>
+          <p:nvPr/>
+        </p:nvSpPr>
+        <p:spPr>
+          <a:xfrm xmlns:a="http://schemas.openxmlformats.org/drawingml/2006/main">
+            <a:off x="685800" y="514350"/>
+            <a:ext cx="10820400" cy="838200"/>
+          </a:xfrm>
+          <a:prstGeom xmlns:a="http://schemas.openxmlformats.org/drawingml/2006/main" prst="rect">
+            <a:avLst/>
+          </a:prstGeom>
+          <a:noFill xmlns:a="http://schemas.openxmlformats.org/drawingml/2006/main"/>
+          <a:ln xmlns:a="http://schemas.openxmlformats.org/drawingml/2006/main" w="0">
+            <a:noFill/>
+          </a:ln>
+        </p:spPr>
+        <p:txBody>
+          <a:bodyPr xmlns:a="http://schemas.openxmlformats.org/drawingml/2006/main" wrap="square" lIns="0" tIns="0" rIns="0" bIns="0" anchor="t">
+            <a:noAutofit/>
+          </a:bodyPr>
+          <a:lstStyle xmlns:a="http://schemas.openxmlformats.org/drawingml/2006/main">
+            <a:defPPr algn="l">
+              <a:defRPr sz="3600" b="1">
+                <a:solidFill>
+                  <a:srgbClr val="0D292E"/>
+                </a:solidFill>
+                <a:latin typeface="Arial"/>
+                <a:ea typeface="Arial"/>
+                <a:cs typeface="Arial"/>
+              </a:defRPr>
+            </a:defPPr>
+          </a:lstStyle>
+          <a:p xmlns:a="http://schemas.openxmlformats.org/drawingml/2006/main">
+            <a:pPr algn="l">
+              <a:defRPr sz="3600" b="1">
+                <a:solidFill>
+                  <a:srgbClr val="0D292E"/>
+                </a:solidFill>
+                <a:latin typeface="Arial"/>
+                <a:ea typeface="Arial"/>
+                <a:cs typeface="Arial"/>
+              </a:defRPr>
+            </a:pPr>
+            <a:r>
+              <a:rPr sz="3600" b="1">
+                <a:solidFill>
+                  <a:srgbClr val="0D292E"/>
+                </a:solidFill>
+                <a:latin typeface="Arial"/>
+                <a:ea typeface="Arial"/>
+                <a:cs typeface="Arial"/>
+              </a:rPr>
+              <a:t>Formación SENA</a:t>
+            </a:r>
+          </a:p>
+        </p:txBody>
+      </p:sp>
+      <p:sp>
+        <p:nvSpPr>
+          <p:cNvPr id="2" name="education-text-2">
+            <a:extLst xmlns:a="http://schemas.openxmlformats.org/drawingml/2006/main">
+              <a:ext uri="{FF2B5EF4-FFF2-40B4-BE49-F238E27FC236}">
+                <a16:creationId xmlns:a16="http://schemas.microsoft.com/office/drawing/2014/main" id="{703C2C8E-BEEC-408C-B8DC-E2C370B61063}"/>
+              </a:ext>
+            </a:extLst>
+          </p:cNvPr>
+          <p:cNvSpPr>
+            <a:spLocks xmlns:a="http://schemas.openxmlformats.org/drawingml/2006/main" noGrp="1"/>
+          </p:cNvSpPr>
+          <p:nvPr/>
+        </p:nvSpPr>
+        <p:spPr>
+          <a:xfrm xmlns:a="http://schemas.openxmlformats.org/drawingml/2006/main">
+            <a:off x="685800" y="1381125"/>
+            <a:ext cx="10820400" cy="457200"/>
+          </a:xfrm>
+          <a:prstGeom xmlns:a="http://schemas.openxmlformats.org/drawingml/2006/main" prst="rect">
+            <a:avLst/>
+          </a:prstGeom>
+          <a:noFill xmlns:a="http://schemas.openxmlformats.org/drawingml/2006/main"/>
+          <a:ln xmlns:a="http://schemas.openxmlformats.org/drawingml/2006/main" w="0">
+            <a:noFill/>
+          </a:ln>
+        </p:spPr>
+        <p:txBody>
+          <a:bodyPr xmlns:a="http://schemas.openxmlformats.org/drawingml/2006/main" wrap="square" lIns="0" tIns="0" rIns="0" bIns="0" anchor="t">
+            <a:noAutofit/>
+          </a:bodyPr>
+          <a:lstStyle xmlns:a="http://schemas.openxmlformats.org/drawingml/2006/main">
+            <a:defPPr algn="l">
+              <a:defRPr sz="1875" b="0">
+                <a:solidFill>
+                  <a:srgbClr val="506367"/>
+                </a:solidFill>
+                <a:latin typeface="Arial"/>
+                <a:ea typeface="Arial"/>
+                <a:cs typeface="Arial"/>
+              </a:defRPr>
+            </a:defPPr>
+          </a:lstStyle>
+          <a:p xmlns:a="http://schemas.openxmlformats.org/drawingml/2006/main">
+            <a:pPr algn="l">
+              <a:defRPr sz="1875" b="0">
+                <a:solidFill>
+                  <a:srgbClr val="506367"/>
+                </a:solidFill>
+                <a:latin typeface="Arial"/>
+                <a:ea typeface="Arial"/>
+                <a:cs typeface="Arial"/>
+              </a:defRPr>
+            </a:pPr>
+            <a:r>
+              <a:rPr sz="1875" b="0">
+                <a:solidFill>
+                  <a:srgbClr val="506367"/>
+                </a:solidFill>
+                <a:latin typeface="Arial"/>
+                <a:ea typeface="Arial"/>
+                <a:cs typeface="Arial"/>
+              </a:rPr>
+              <a:t>Estudios técnicos y tecnológicos</a:t>
+            </a:r>
+          </a:p>
+        </p:txBody>
+      </p:sp>
+      <p:sp>
+        <p:nvSpPr>
+          <p:cNvPr id="3" name="education-text-3">
+            <a:extLst xmlns:a="http://schemas.openxmlformats.org/drawingml/2006/main">
+              <a:ext uri="{FF2B5EF4-FFF2-40B4-BE49-F238E27FC236}">
+                <a16:creationId xmlns:a16="http://schemas.microsoft.com/office/drawing/2014/main" id="{BFDB4AC4-FBEB-4650-8505-5ECDC3DD7DD6}"/>
+              </a:ext>
+            </a:extLst>
+          </p:cNvPr>
+          <p:cNvSpPr>
+            <a:spLocks xmlns:a="http://schemas.openxmlformats.org/drawingml/2006/main" noGrp="1"/>
+          </p:cNvSpPr>
+          <p:nvPr/>
+        </p:nvSpPr>
+        <p:spPr>
+          <a:xfrm xmlns:a="http://schemas.openxmlformats.org/drawingml/2006/main">
+            <a:off x="685800" y="2095500"/>
+            <a:ext cx="10820400" cy="304800"/>
+          </a:xfrm>
+          <a:prstGeom xmlns:a="http://schemas.openxmlformats.org/drawingml/2006/main" prst="rect">
+            <a:avLst/>
+          </a:prstGeom>
+          <a:noFill xmlns:a="http://schemas.openxmlformats.org/drawingml/2006/main"/>
+          <a:ln xmlns:a="http://schemas.openxmlformats.org/drawingml/2006/main" w="0">
+            <a:noFill/>
+          </a:ln>
+        </p:spPr>
+        <p:txBody>
+          <a:bodyPr xmlns:a="http://schemas.openxmlformats.org/drawingml/2006/main" wrap="square" lIns="0" tIns="0" rIns="0" bIns="0" anchor="t">
+            <a:noAutofit/>
+          </a:bodyPr>
+          <a:lstStyle xmlns:a="http://schemas.openxmlformats.org/drawingml/2006/main">
+            <a:defPPr algn="l">
+              <a:defRPr sz="1725" b="1">
+                <a:solidFill>
+                  <a:srgbClr val="137C76"/>
+                </a:solidFill>
+                <a:latin typeface="Arial"/>
+                <a:ea typeface="Arial"/>
+                <a:cs typeface="Arial"/>
+              </a:defRPr>
+            </a:defPPr>
+          </a:lstStyle>
+          <a:p xmlns:a="http://schemas.openxmlformats.org/drawingml/2006/main">
+            <a:pPr algn="l">
+              <a:defRPr sz="1725" b="1">
+                <a:solidFill>
+                  <a:srgbClr val="137C76"/>
+                </a:solidFill>
+                <a:latin typeface="Arial"/>
+                <a:ea typeface="Arial"/>
+                <a:cs typeface="Arial"/>
+              </a:defRPr>
+            </a:pPr>
+            <a:r>
+              <a:rPr sz="1725" b="1">
+                <a:solidFill>
+                  <a:srgbClr val="137C76"/>
+                </a:solidFill>
+                <a:latin typeface="Arial"/>
+                <a:ea typeface="Arial"/>
+                <a:cs typeface="Arial"/>
+              </a:rPr>
+              <a:t>Finalizado</a:t>
+            </a:r>
+          </a:p>
+        </p:txBody>
+      </p:sp>
+      <p:sp>
+        <p:nvSpPr>
+          <p:cNvPr id="4" name="education-text-4">
+            <a:extLst xmlns:a="http://schemas.openxmlformats.org/drawingml/2006/main">
+              <a:ext uri="{FF2B5EF4-FFF2-40B4-BE49-F238E27FC236}">
+                <a16:creationId xmlns:a16="http://schemas.microsoft.com/office/drawing/2014/main" id="{C92BCBF9-784A-4B28-B2C6-3F42A5CFCDCA}"/>
+              </a:ext>
+            </a:extLst>
+          </p:cNvPr>
+          <p:cNvSpPr>
+            <a:spLocks xmlns:a="http://schemas.openxmlformats.org/drawingml/2006/main" noGrp="1"/>
+          </p:cNvSpPr>
+          <p:nvPr/>
+        </p:nvSpPr>
+        <p:spPr>
+          <a:xfrm xmlns:a="http://schemas.openxmlformats.org/drawingml/2006/main">
+            <a:off x="685800" y="2505075"/>
+            <a:ext cx="10820400" cy="857250"/>
+          </a:xfrm>
+          <a:prstGeom xmlns:a="http://schemas.openxmlformats.org/drawingml/2006/main" prst="rect">
+            <a:avLst/>
+          </a:prstGeom>
+          <a:noFill xmlns:a="http://schemas.openxmlformats.org/drawingml/2006/main"/>
+          <a:ln xmlns:a="http://schemas.openxmlformats.org/drawingml/2006/main" w="0">
+            <a:noFill/>
+          </a:ln>
+        </p:spPr>
+        <p:txBody>
+          <a:bodyPr xmlns:a="http://schemas.openxmlformats.org/drawingml/2006/main" wrap="square" lIns="0" tIns="0" rIns="0" bIns="0" anchor="t">
+            <a:noAutofit/>
+          </a:bodyPr>
+          <a:lstStyle xmlns:a="http://schemas.openxmlformats.org/drawingml/2006/main">
+            <a:defPPr algn="l">
+              <a:defRPr sz="2550" b="1">
+                <a:solidFill>
+                  <a:srgbClr val="0D292E"/>
+                </a:solidFill>
+                <a:latin typeface="Arial"/>
+                <a:ea typeface="Arial"/>
+                <a:cs typeface="Arial"/>
+              </a:defRPr>
+            </a:defPPr>
+          </a:lstStyle>
+          <a:p xmlns:a="http://schemas.openxmlformats.org/drawingml/2006/main">
+            <a:pPr algn="l">
+              <a:defRPr sz="2550" b="1">
+                <a:solidFill>
+                  <a:srgbClr val="0D292E"/>
+                </a:solidFill>
+                <a:latin typeface="Arial"/>
+                <a:ea typeface="Arial"/>
+                <a:cs typeface="Arial"/>
+              </a:defRPr>
+            </a:pPr>
+            <a:r>
+              <a:rPr sz="2550" b="1">
+                <a:solidFill>
+                  <a:srgbClr val="0D292E"/>
+                </a:solidFill>
+                <a:latin typeface="Arial"/>
+                <a:ea typeface="Arial"/>
+                <a:cs typeface="Arial"/>
+              </a:rPr>
+              <a:t>Técnico en Programación de Aplicaciones</a:t>
+            </a:r>
+          </a:p>
+          <a:p xmlns:a="http://schemas.openxmlformats.org/drawingml/2006/main">
+            <a:pPr algn="l">
+              <a:defRPr sz="2550" b="1">
+                <a:solidFill>
+                  <a:srgbClr val="0D292E"/>
+                </a:solidFill>
+                <a:latin typeface="Arial"/>
+                <a:ea typeface="Arial"/>
+                <a:cs typeface="Arial"/>
+              </a:defRPr>
+            </a:pPr>
+            <a:r>
+              <a:rPr sz="2550" b="1">
+                <a:solidFill>
+                  <a:srgbClr val="0D292E"/>
+                </a:solidFill>
+                <a:latin typeface="Arial"/>
+                <a:ea typeface="Arial"/>
+                <a:cs typeface="Arial"/>
+              </a:rPr>
+              <a:t>para Dispositivos Móviles</a:t>
+            </a:r>
+          </a:p>
+        </p:txBody>
+      </p:sp>
+      <p:sp>
+        <p:nvSpPr>
+          <p:cNvPr id="5" name="education-text-5">
+            <a:extLst xmlns:a="http://schemas.openxmlformats.org/drawingml/2006/main">
+              <a:ext uri="{FF2B5EF4-FFF2-40B4-BE49-F238E27FC236}">
+                <a16:creationId xmlns:a16="http://schemas.microsoft.com/office/drawing/2014/main" id="{1AC61D9D-A379-4A4D-AFBE-9FC8C6D24301}"/>
+              </a:ext>
+            </a:extLst>
+          </p:cNvPr>
+          <p:cNvSpPr>
+            <a:spLocks xmlns:a="http://schemas.openxmlformats.org/drawingml/2006/main" noGrp="1"/>
+          </p:cNvSpPr>
+          <p:nvPr/>
+        </p:nvSpPr>
+        <p:spPr>
+          <a:xfrm xmlns:a="http://schemas.openxmlformats.org/drawingml/2006/main">
+            <a:off x="685800" y="3457575"/>
+            <a:ext cx="10820400" cy="400050"/>
+          </a:xfrm>
+          <a:prstGeom xmlns:a="http://schemas.openxmlformats.org/drawingml/2006/main" prst="rect">
+            <a:avLst/>
+          </a:prstGeom>
+          <a:noFill xmlns:a="http://schemas.openxmlformats.org/drawingml/2006/main"/>
+          <a:ln xmlns:a="http://schemas.openxmlformats.org/drawingml/2006/main" w="0">
+            <a:noFill/>
+          </a:ln>
+        </p:spPr>
+        <p:txBody>
+          <a:bodyPr xmlns:a="http://schemas.openxmlformats.org/drawingml/2006/main" wrap="square" lIns="0" tIns="0" rIns="0" bIns="0" anchor="t">
+            <a:noAutofit/>
+          </a:bodyPr>
+          <a:lstStyle xmlns:a="http://schemas.openxmlformats.org/drawingml/2006/main">
+            <a:defPPr algn="l">
+              <a:defRPr sz="2025" b="0">
+                <a:solidFill>
+                  <a:srgbClr val="506367"/>
+                </a:solidFill>
+                <a:latin typeface="Arial"/>
+                <a:ea typeface="Arial"/>
+                <a:cs typeface="Arial"/>
+              </a:defRPr>
+            </a:defPPr>
+          </a:lstStyle>
+          <a:p xmlns:a="http://schemas.openxmlformats.org/drawingml/2006/main">
+            <a:pPr algn="l">
+              <a:defRPr sz="2025" b="0">
+                <a:solidFill>
+                  <a:srgbClr val="506367"/>
+                </a:solidFill>
+                <a:latin typeface="Arial"/>
+                <a:ea typeface="Arial"/>
+                <a:cs typeface="Arial"/>
+              </a:defRPr>
+            </a:pPr>
+            <a:r>
+              <a:rPr sz="2025" b="0">
+                <a:solidFill>
+                  <a:srgbClr val="506367"/>
+                </a:solidFill>
+                <a:latin typeface="Arial"/>
+                <a:ea typeface="Arial"/>
+                <a:cs typeface="Arial"/>
+              </a:rPr>
+              <a:t>SENA · Octubre 2021 – octubre 2023</a:t>
+            </a:r>
+          </a:p>
+        </p:txBody>
+      </p:sp>
+      <p:sp>
+        <p:nvSpPr>
+          <p:cNvPr id="6" name="education-text-6">
+            <a:extLst xmlns:a="http://schemas.openxmlformats.org/drawingml/2006/main">
+              <a:ext uri="{FF2B5EF4-FFF2-40B4-BE49-F238E27FC236}">
+                <a16:creationId xmlns:a16="http://schemas.microsoft.com/office/drawing/2014/main" id="{1E3ABD57-AC99-4EF3-B276-635E1A389F48}"/>
+              </a:ext>
+            </a:extLst>
+          </p:cNvPr>
+          <p:cNvSpPr>
+            <a:spLocks xmlns:a="http://schemas.openxmlformats.org/drawingml/2006/main" noGrp="1"/>
+          </p:cNvSpPr>
+          <p:nvPr/>
+        </p:nvSpPr>
+        <p:spPr>
+          <a:xfrm xmlns:a="http://schemas.openxmlformats.org/drawingml/2006/main">
+            <a:off x="685800" y="4429125"/>
+            <a:ext cx="10820400" cy="304800"/>
+          </a:xfrm>
+          <a:prstGeom xmlns:a="http://schemas.openxmlformats.org/drawingml/2006/main" prst="rect">
+            <a:avLst/>
+          </a:prstGeom>
+          <a:noFill xmlns:a="http://schemas.openxmlformats.org/drawingml/2006/main"/>
+          <a:ln xmlns:a="http://schemas.openxmlformats.org/drawingml/2006/main" w="0">
+            <a:noFill/>
+          </a:ln>
+        </p:spPr>
+        <p:txBody>
+          <a:bodyPr xmlns:a="http://schemas.openxmlformats.org/drawingml/2006/main" wrap="square" lIns="0" tIns="0" rIns="0" bIns="0" anchor="t">
+            <a:noAutofit/>
+          </a:bodyPr>
+          <a:lstStyle xmlns:a="http://schemas.openxmlformats.org/drawingml/2006/main">
+            <a:defPPr algn="l">
+              <a:defRPr sz="1725" b="1">
+                <a:solidFill>
+                  <a:srgbClr val="137C76"/>
+                </a:solidFill>
+                <a:latin typeface="Arial"/>
+                <a:ea typeface="Arial"/>
+                <a:cs typeface="Arial"/>
+              </a:defRPr>
+            </a:defPPr>
+          </a:lstStyle>
+          <a:p xmlns:a="http://schemas.openxmlformats.org/drawingml/2006/main">
+            <a:pPr algn="l">
+              <a:defRPr sz="1725" b="1">
+                <a:solidFill>
+                  <a:srgbClr val="137C76"/>
+                </a:solidFill>
+                <a:latin typeface="Arial"/>
+                <a:ea typeface="Arial"/>
+                <a:cs typeface="Arial"/>
+              </a:defRPr>
+            </a:pPr>
+            <a:r>
+              <a:rPr sz="1725" b="1">
+                <a:solidFill>
+                  <a:srgbClr val="137C76"/>
+                </a:solidFill>
+                <a:latin typeface="Arial"/>
+                <a:ea typeface="Arial"/>
+                <a:cs typeface="Arial"/>
+              </a:rPr>
+              <a:t>En curso</a:t>
+            </a:r>
+          </a:p>
+        </p:txBody>
+      </p:sp>
+      <p:sp>
+        <p:nvSpPr>
+          <p:cNvPr id="7" name="education-text-7">
+            <a:extLst xmlns:a="http://schemas.openxmlformats.org/drawingml/2006/main">
+              <a:ext uri="{FF2B5EF4-FFF2-40B4-BE49-F238E27FC236}">
+                <a16:creationId xmlns:a16="http://schemas.microsoft.com/office/drawing/2014/main" id="{A6EF6C98-B934-413D-882C-03D81FC44E47}"/>
+              </a:ext>
+            </a:extLst>
+          </p:cNvPr>
+          <p:cNvSpPr>
+            <a:spLocks xmlns:a="http://schemas.openxmlformats.org/drawingml/2006/main" noGrp="1"/>
+          </p:cNvSpPr>
+          <p:nvPr/>
+        </p:nvSpPr>
+        <p:spPr>
+          <a:xfrm xmlns:a="http://schemas.openxmlformats.org/drawingml/2006/main">
+            <a:off x="685800" y="4838700"/>
+            <a:ext cx="10820400" cy="495300"/>
+          </a:xfrm>
+          <a:prstGeom xmlns:a="http://schemas.openxmlformats.org/drawingml/2006/main" prst="rect">
+            <a:avLst/>
+          </a:prstGeom>
+          <a:noFill xmlns:a="http://schemas.openxmlformats.org/drawingml/2006/main"/>
+          <a:ln xmlns:a="http://schemas.openxmlformats.org/drawingml/2006/main" w="0">
+            <a:noFill/>
+          </a:ln>
+        </p:spPr>
+        <p:txBody>
+          <a:bodyPr xmlns:a="http://schemas.openxmlformats.org/drawingml/2006/main" wrap="square" lIns="0" tIns="0" rIns="0" bIns="0" anchor="t">
+            <a:noAutofit/>
+          </a:bodyPr>
+          <a:lstStyle xmlns:a="http://schemas.openxmlformats.org/drawingml/2006/main">
+            <a:defPPr algn="l">
+              <a:defRPr sz="2550" b="1">
+                <a:solidFill>
+                  <a:srgbClr val="0D292E"/>
+                </a:solidFill>
+                <a:latin typeface="Arial"/>
+                <a:ea typeface="Arial"/>
+                <a:cs typeface="Arial"/>
+              </a:defRPr>
+            </a:defPPr>
+          </a:lstStyle>
+          <a:p xmlns:a="http://schemas.openxmlformats.org/drawingml/2006/main">
+            <a:pPr algn="l">
+              <a:defRPr sz="2550" b="1">
+                <a:solidFill>
+                  <a:srgbClr val="0D292E"/>
+                </a:solidFill>
+                <a:latin typeface="Arial"/>
+                <a:ea typeface="Arial"/>
+                <a:cs typeface="Arial"/>
+              </a:defRPr>
+            </a:pPr>
+            <a:r>
+              <a:rPr sz="2550" b="1">
+                <a:solidFill>
+                  <a:srgbClr val="0D292E"/>
+                </a:solidFill>
+                <a:latin typeface="Arial"/>
+                <a:ea typeface="Arial"/>
+                <a:cs typeface="Arial"/>
+              </a:rPr>
+              <a:t>Tecnología en Análisis y Desarrollo de Software</a:t>
+            </a:r>
+          </a:p>
+        </p:txBody>
+      </p:sp>
+      <p:sp>
+        <p:nvSpPr>
+          <p:cNvPr id="8" name="education-text-8">
+            <a:extLst xmlns:a="http://schemas.openxmlformats.org/drawingml/2006/main">
+              <a:ext uri="{FF2B5EF4-FFF2-40B4-BE49-F238E27FC236}">
+                <a16:creationId xmlns:a16="http://schemas.microsoft.com/office/drawing/2014/main" id="{8BCBA81D-06EC-4203-99B8-43D09651B350}"/>
+              </a:ext>
+            </a:extLst>
+          </p:cNvPr>
+          <p:cNvSpPr>
+            <a:spLocks xmlns:a="http://schemas.openxmlformats.org/drawingml/2006/main" noGrp="1"/>
+          </p:cNvSpPr>
+          <p:nvPr/>
+        </p:nvSpPr>
+        <p:spPr>
+          <a:xfrm xmlns:a="http://schemas.openxmlformats.org/drawingml/2006/main">
+            <a:off x="685800" y="5438775"/>
+            <a:ext cx="10820400" cy="400050"/>
+          </a:xfrm>
+          <a:prstGeom xmlns:a="http://schemas.openxmlformats.org/drawingml/2006/main" prst="rect">
+            <a:avLst/>
+          </a:prstGeom>
+          <a:noFill xmlns:a="http://schemas.openxmlformats.org/drawingml/2006/main"/>
+          <a:ln xmlns:a="http://schemas.openxmlformats.org/drawingml/2006/main" w="0">
+            <a:noFill/>
+          </a:ln>
+        </p:spPr>
+        <p:txBody>
+          <a:bodyPr xmlns:a="http://schemas.openxmlformats.org/drawingml/2006/main" wrap="square" lIns="0" tIns="0" rIns="0" bIns="0" anchor="t">
+            <a:noAutofit/>
+          </a:bodyPr>
+          <a:lstStyle xmlns:a="http://schemas.openxmlformats.org/drawingml/2006/main">
+            <a:defPPr algn="l">
+              <a:defRPr sz="2025" b="0">
+                <a:solidFill>
+                  <a:srgbClr val="506367"/>
+                </a:solidFill>
+                <a:latin typeface="Arial"/>
+                <a:ea typeface="Arial"/>
+                <a:cs typeface="Arial"/>
+              </a:defRPr>
+            </a:defPPr>
+          </a:lstStyle>
+          <a:p xmlns:a="http://schemas.openxmlformats.org/drawingml/2006/main">
+            <a:pPr algn="l">
+              <a:defRPr sz="2025" b="0">
+                <a:solidFill>
+                  <a:srgbClr val="506367"/>
+                </a:solidFill>
+                <a:latin typeface="Arial"/>
+                <a:ea typeface="Arial"/>
+                <a:cs typeface="Arial"/>
+              </a:defRPr>
+            </a:pPr>
+            <a:r>
+              <a:rPr sz="2025" b="0">
+                <a:solidFill>
+                  <a:srgbClr val="506367"/>
+                </a:solidFill>
+                <a:latin typeface="Arial"/>
+                <a:ea typeface="Arial"/>
+                <a:cs typeface="Arial"/>
+              </a:rPr>
+              <a:t>SENA · Abril 2025 – en curso</a:t>
+            </a:r>
+          </a:p>
+        </p:txBody>
+      </p:sp>
+      <p:sp>
+        <p:nvSpPr>
+          <p:cNvPr id="9" name="education-text-9">
+            <a:extLst xmlns:a="http://schemas.openxmlformats.org/drawingml/2006/main">
+              <a:ext uri="{FF2B5EF4-FFF2-40B4-BE49-F238E27FC236}">
+                <a16:creationId xmlns:a16="http://schemas.microsoft.com/office/drawing/2014/main" id="{D7F22647-E0A0-4D63-BC1C-7D01562E4F21}"/>
+              </a:ext>
+            </a:extLst>
+          </p:cNvPr>
+          <p:cNvSpPr>
+            <a:spLocks xmlns:a="http://schemas.openxmlformats.org/drawingml/2006/main" noGrp="1"/>
+          </p:cNvSpPr>
+          <p:nvPr/>
+        </p:nvSpPr>
+        <p:spPr>
+          <a:xfrm xmlns:a="http://schemas.openxmlformats.org/drawingml/2006/main">
+            <a:off x="10953750" y="6286500"/>
+            <a:ext cx="552450" cy="266700"/>
+          </a:xfrm>
+          <a:prstGeom xmlns:a="http://schemas.openxmlformats.org/drawingml/2006/main" prst="rect">
+            <a:avLst/>
+          </a:prstGeom>
+          <a:noFill xmlns:a="http://schemas.openxmlformats.org/drawingml/2006/main"/>
+          <a:ln xmlns:a="http://schemas.openxmlformats.org/drawingml/2006/main" w="0">
+            <a:noFill/>
+          </a:ln>
+        </p:spPr>
+        <p:txBody>
+          <a:bodyPr xmlns:a="http://schemas.openxmlformats.org/drawingml/2006/main" wrap="square" lIns="0" tIns="0" rIns="0" bIns="0" anchor="t">
+            <a:noAutofit/>
+          </a:bodyPr>
+          <a:lstStyle xmlns:a="http://schemas.openxmlformats.org/drawingml/2006/main">
+            <a:defPPr algn="r">
+              <a:defRPr sz="1500" b="0">
+                <a:solidFill>
+                  <a:srgbClr val="506367"/>
+                </a:solidFill>
+                <a:latin typeface="Arial"/>
+                <a:ea typeface="Arial"/>
+                <a:cs typeface="Arial"/>
+              </a:defRPr>
+            </a:defPPr>
+          </a:lstStyle>
+          <a:p xmlns:a="http://schemas.openxmlformats.org/drawingml/2006/main">
+            <a:pPr algn="r">
+              <a:defRPr sz="1500" b="0">
+                <a:solidFill>
+                  <a:srgbClr val="506367"/>
+                </a:solidFill>
+                <a:latin typeface="Arial"/>
+                <a:ea typeface="Arial"/>
+                <a:cs typeface="Arial"/>
+              </a:defRPr>
+            </a:pPr>
+            <a:r>
+              <a:rPr sz="1500" b="0">
+                <a:solidFill>
+                  <a:srgbClr val="506367"/>
+                </a:solidFill>
+                <a:latin typeface="Arial"/>
+                <a:ea typeface="Arial"/>
+                <a:cs typeface="Arial"/>
+              </a:rPr>
+              <a:t>03</a:t>
+            </a:r>
+          </a:p>
+        </p:txBody>
+      </p:sp>
+    </p:spTree>
+    <p:extLst>
+      <p:ext uri="{BB962C8B-B14F-4D97-AF65-F5344CB8AC3E}">
+        <p14:creationId xmlns:p14="http://schemas.microsoft.com/office/powerpoint/2010/main" val="1113374465"/>
       </p:ext>
     </p:extLst>
   </p:cSld>
@@ -10898,7 +14054,7 @@
                           <a:ea typeface="Arial"/>
                           <a:cs typeface="Arial"/>
                         </a:rPr>
-                        <a:t>En curso según CV</a:t>
+                        <a:t>En curso</a:t>
                       </a:r>
                     </a:p>
                   </a:txBody>
@@ -11221,7 +14377,7 @@
                 <a:ea typeface="Arial"/>
                 <a:cs typeface="Arial"/>
               </a:rPr>
-              <a:t>03</a:t>
+              <a:t>04</a:t>
             </a:r>
           </a:p>
         </p:txBody>
@@ -12259,7 +15415,7 @@
                 <a:ea typeface="Arial"/>
                 <a:cs typeface="Arial"/>
               </a:rPr>
-              <a:t>04</a:t>
+              <a:t>05</a:t>
             </a:r>
           </a:p>
         </p:txBody>
@@ -12968,7 +16124,7 @@
                 <a:ea typeface="Arial"/>
                 <a:cs typeface="Arial"/>
               </a:rPr>
-              <a:t>05</a:t>
+              <a:t>06</a:t>
             </a:r>
           </a:p>
         </p:txBody>
@@ -14077,7 +17233,7 @@
                 <a:ea typeface="Arial"/>
                 <a:cs typeface="Arial"/>
               </a:rPr>
-              <a:t>06</a:t>
+              <a:t>07</a:t>
             </a:r>
           </a:p>
         </p:txBody>
@@ -14582,7 +17738,7 @@
                 <a:ea typeface="Arial"/>
                 <a:cs typeface="Arial"/>
               </a:rPr>
-              <a:t>07</a:t>
+              <a:t>08</a:t>
             </a:r>
           </a:p>
         </p:txBody>
@@ -15109,7 +18265,7 @@
                 <a:ea typeface="Arial"/>
                 <a:cs typeface="Arial"/>
               </a:rPr>
-              <a:t>08</a:t>
+              <a:t>09</a:t>
             </a:r>
           </a:p>
         </p:txBody>
@@ -16171,7 +19327,7 @@
                 <a:ea typeface="Arial"/>
                 <a:cs typeface="Arial"/>
               </a:rPr>
-              <a:t>09</a:t>
+              <a:t>10</a:t>
             </a:r>
           </a:p>
         </p:txBody>

</xml_diff>